<commit_message>
Design review deck: speaker notes on every diagram slide
</commit_message>
<xml_diff>
--- a/documents/slides/design_review_track_ctrl_hw.pptx
+++ b/documents/slides/design_review_track_ctrl_hw.pptx
@@ -11,38 +11,38 @@
     <p:sldId id="259" r:id="rId10"/>
     <p:sldId id="260" r:id="rId11"/>
     <p:sldId id="261" r:id="rId12"/>
-    <p:sldId id="262" r:id="rId13"/>
-    <p:sldId id="263" r:id="rId14"/>
-    <p:sldId id="264" r:id="rId15"/>
-    <p:sldId id="265" r:id="rId16"/>
-    <p:sldId id="266" r:id="rId17"/>
-    <p:sldId id="267" r:id="rId18"/>
-    <p:sldId id="268" r:id="rId19"/>
-    <p:sldId id="269" r:id="rId20"/>
-    <p:sldId id="270" r:id="rId21"/>
-    <p:sldId id="271" r:id="rId22"/>
-    <p:sldId id="272" r:id="rId23"/>
-    <p:sldId id="273" r:id="rId24"/>
-    <p:sldId id="274" r:id="rId25"/>
-    <p:sldId id="275" r:id="rId26"/>
-    <p:sldId id="276" r:id="rId27"/>
-    <p:sldId id="277" r:id="rId28"/>
-    <p:sldId id="278" r:id="rId29"/>
-    <p:sldId id="279" r:id="rId30"/>
-    <p:sldId id="280" r:id="rId31"/>
-    <p:sldId id="281" r:id="rId32"/>
-    <p:sldId id="282" r:id="rId33"/>
-    <p:sldId id="283" r:id="rId34"/>
-    <p:sldId id="284" r:id="rId35"/>
-    <p:sldId id="285" r:id="rId36"/>
-    <p:sldId id="286" r:id="rId37"/>
-    <p:sldId id="287" r:id="rId38"/>
-    <p:sldId id="288" r:id="rId39"/>
-    <p:sldId id="289" r:id="rId40"/>
-    <p:sldId id="290" r:id="rId41"/>
-    <p:sldId id="291" r:id="rId42"/>
-    <p:sldId id="292" r:id="rId43"/>
-    <p:sldId id="293" r:id="rId44"/>
+    <p:sldId id="262" r:id="rId14"/>
+    <p:sldId id="263" r:id="rId15"/>
+    <p:sldId id="264" r:id="rId16"/>
+    <p:sldId id="265" r:id="rId17"/>
+    <p:sldId id="266" r:id="rId18"/>
+    <p:sldId id="267" r:id="rId19"/>
+    <p:sldId id="268" r:id="rId20"/>
+    <p:sldId id="269" r:id="rId21"/>
+    <p:sldId id="270" r:id="rId22"/>
+    <p:sldId id="271" r:id="rId23"/>
+    <p:sldId id="272" r:id="rId24"/>
+    <p:sldId id="273" r:id="rId25"/>
+    <p:sldId id="274" r:id="rId26"/>
+    <p:sldId id="275" r:id="rId27"/>
+    <p:sldId id="276" r:id="rId28"/>
+    <p:sldId id="277" r:id="rId29"/>
+    <p:sldId id="278" r:id="rId30"/>
+    <p:sldId id="279" r:id="rId31"/>
+    <p:sldId id="280" r:id="rId32"/>
+    <p:sldId id="281" r:id="rId33"/>
+    <p:sldId id="282" r:id="rId34"/>
+    <p:sldId id="283" r:id="rId35"/>
+    <p:sldId id="284" r:id="rId36"/>
+    <p:sldId id="285" r:id="rId37"/>
+    <p:sldId id="286" r:id="rId38"/>
+    <p:sldId id="287" r:id="rId39"/>
+    <p:sldId id="288" r:id="rId40"/>
+    <p:sldId id="289" r:id="rId41"/>
+    <p:sldId id="290" r:id="rId42"/>
+    <p:sldId id="291" r:id="rId43"/>
+    <p:sldId id="292" r:id="rId44"/>
+    <p:sldId id="293" r:id="rId45"/>
   </p:sldIdLst>
   <p:sldSz cx="12191695" cy="6858000" type="screen4x3"/>
   <p:notesSz cx="6858000" cy="9144000"/>
@@ -142,6 +142,1756 @@
     </a:lvl9pPr>
   </p:defaultTextStyle>
 </p:presentation>
+</file>
+
+<file path=ppt/notesMasters/notesMaster1.xml><?xml version="1.0" encoding="utf-8"?>
+<p:notesMaster xmlns:a="http://schemas.openxmlformats.org/drawingml/2006/main" xmlns:p="http://schemas.openxmlformats.org/presentationml/2006/main" xmlns:r="http://schemas.openxmlformats.org/officeDocument/2006/relationships">
+  <p:cSld>
+    <p:bg>
+      <p:bgRef idx="1001">
+        <a:schemeClr val="bg1"/>
+      </p:bgRef>
+    </p:bg>
+    <p:spTree>
+      <p:nvGrpSpPr>
+        <p:cNvPr id="1" name=""/>
+        <p:cNvGrpSpPr/>
+        <p:nvPr/>
+      </p:nvGrpSpPr>
+      <p:grpSpPr>
+        <a:xfrm>
+          <a:off x="0" y="0"/>
+          <a:ext cx="0" cy="0"/>
+          <a:chOff x="0" y="0"/>
+          <a:chExt cx="0" cy="0"/>
+        </a:xfrm>
+      </p:grpSpPr>
+      <p:sp>
+        <p:nvSpPr>
+          <p:cNvPr id="2" name="Header Placeholder 1"/>
+          <p:cNvSpPr>
+            <a:spLocks noGrp="1"/>
+          </p:cNvSpPr>
+          <p:nvPr>
+            <p:ph type="hdr" sz="quarter"/>
+          </p:nvPr>
+        </p:nvSpPr>
+        <p:spPr>
+          <a:xfrm>
+            <a:off x="0" y="0"/>
+            <a:ext cx="2971800" cy="457200"/>
+          </a:xfrm>
+          <a:prstGeom prst="rect">
+            <a:avLst/>
+          </a:prstGeom>
+        </p:spPr>
+        <p:txBody>
+          <a:bodyPr vert="horz" lIns="91440" tIns="45720" rIns="91440" bIns="45720" rtlCol="0"/>
+          <a:lstStyle>
+            <a:lvl1pPr algn="l">
+              <a:defRPr sz="1200"/>
+            </a:lvl1pPr>
+          </a:lstStyle>
+          <a:p>
+            <a:endParaRPr lang="en-US"/>
+          </a:p>
+        </p:txBody>
+      </p:sp>
+      <p:sp>
+        <p:nvSpPr>
+          <p:cNvPr id="3" name="Date Placeholder 2"/>
+          <p:cNvSpPr>
+            <a:spLocks noGrp="1"/>
+          </p:cNvSpPr>
+          <p:nvPr>
+            <p:ph type="dt" idx="1"/>
+          </p:nvPr>
+        </p:nvSpPr>
+        <p:spPr>
+          <a:xfrm>
+            <a:off x="3884613" y="0"/>
+            <a:ext cx="2971800" cy="457200"/>
+          </a:xfrm>
+          <a:prstGeom prst="rect">
+            <a:avLst/>
+          </a:prstGeom>
+        </p:spPr>
+        <p:txBody>
+          <a:bodyPr vert="horz" lIns="91440" tIns="45720" rIns="91440" bIns="45720" rtlCol="0"/>
+          <a:lstStyle>
+            <a:lvl1pPr algn="r">
+              <a:defRPr sz="1200"/>
+            </a:lvl1pPr>
+          </a:lstStyle>
+          <a:p>
+            <a:fld id="{0F89C1C7-3DCD-1040-A9CF-14679D8B5DDD}" type="datetimeFigureOut">
+              <a:rPr lang="en-US" smtClean="0"/>
+              <a:t>10/17/16</a:t>
+            </a:fld>
+            <a:endParaRPr lang="en-US"/>
+          </a:p>
+        </p:txBody>
+      </p:sp>
+      <p:sp>
+        <p:nvSpPr>
+          <p:cNvPr id="4" name="Slide Image Placeholder 3"/>
+          <p:cNvSpPr>
+            <a:spLocks noGrp="1" noRot="1" noChangeAspect="1"/>
+          </p:cNvSpPr>
+          <p:nvPr>
+            <p:ph type="sldImg" idx="2"/>
+          </p:nvPr>
+        </p:nvSpPr>
+        <p:spPr>
+          <a:xfrm>
+            <a:off x="1143000" y="685800"/>
+            <a:ext cx="4572000" cy="3429000"/>
+          </a:xfrm>
+          <a:prstGeom prst="rect">
+            <a:avLst/>
+          </a:prstGeom>
+          <a:noFill/>
+          <a:ln w="12700">
+            <a:solidFill>
+              <a:prstClr val="black"/>
+            </a:solidFill>
+          </a:ln>
+        </p:spPr>
+        <p:txBody>
+          <a:bodyPr vert="horz" lIns="91440" tIns="45720" rIns="91440" bIns="45720" rtlCol="0" anchor="ctr"/>
+          <a:lstStyle/>
+          <a:p>
+            <a:endParaRPr lang="en-US"/>
+          </a:p>
+        </p:txBody>
+      </p:sp>
+      <p:sp>
+        <p:nvSpPr>
+          <p:cNvPr id="5" name="Notes Placeholder 4"/>
+          <p:cNvSpPr>
+            <a:spLocks noGrp="1"/>
+          </p:cNvSpPr>
+          <p:nvPr>
+            <p:ph type="body" sz="quarter" idx="3"/>
+          </p:nvPr>
+        </p:nvSpPr>
+        <p:spPr>
+          <a:xfrm>
+            <a:off x="685800" y="4343400"/>
+            <a:ext cx="5486400" cy="4114800"/>
+          </a:xfrm>
+          <a:prstGeom prst="rect">
+            <a:avLst/>
+          </a:prstGeom>
+        </p:spPr>
+        <p:txBody>
+          <a:bodyPr vert="horz" lIns="91440" tIns="45720" rIns="91440" bIns="45720" rtlCol="0"/>
+          <a:lstStyle/>
+          <a:p>
+            <a:pPr lvl="0"/>
+            <a:r>
+              <a:rPr lang="en-US" smtClean="0"/>
+              <a:t>Click to edit Master text styles</a:t>
+            </a:r>
+          </a:p>
+          <a:p>
+            <a:pPr lvl="1"/>
+            <a:r>
+              <a:rPr lang="en-US" smtClean="0"/>
+              <a:t>Second level</a:t>
+            </a:r>
+          </a:p>
+          <a:p>
+            <a:pPr lvl="2"/>
+            <a:r>
+              <a:rPr lang="en-US" smtClean="0"/>
+              <a:t>Third level</a:t>
+            </a:r>
+          </a:p>
+          <a:p>
+            <a:pPr lvl="3"/>
+            <a:r>
+              <a:rPr lang="en-US" smtClean="0"/>
+              <a:t>Fourth level</a:t>
+            </a:r>
+          </a:p>
+          <a:p>
+            <a:pPr lvl="4"/>
+            <a:r>
+              <a:rPr lang="en-US" smtClean="0"/>
+              <a:t>Fifth level</a:t>
+            </a:r>
+            <a:endParaRPr lang="en-US"/>
+          </a:p>
+        </p:txBody>
+      </p:sp>
+      <p:sp>
+        <p:nvSpPr>
+          <p:cNvPr id="6" name="Footer Placeholder 5"/>
+          <p:cNvSpPr>
+            <a:spLocks noGrp="1"/>
+          </p:cNvSpPr>
+          <p:nvPr>
+            <p:ph type="ftr" sz="quarter" idx="4"/>
+          </p:nvPr>
+        </p:nvSpPr>
+        <p:spPr>
+          <a:xfrm>
+            <a:off x="0" y="8685213"/>
+            <a:ext cx="2971800" cy="457200"/>
+          </a:xfrm>
+          <a:prstGeom prst="rect">
+            <a:avLst/>
+          </a:prstGeom>
+        </p:spPr>
+        <p:txBody>
+          <a:bodyPr vert="horz" lIns="91440" tIns="45720" rIns="91440" bIns="45720" rtlCol="0" anchor="b"/>
+          <a:lstStyle>
+            <a:lvl1pPr algn="l">
+              <a:defRPr sz="1200"/>
+            </a:lvl1pPr>
+          </a:lstStyle>
+          <a:p>
+            <a:endParaRPr lang="en-US"/>
+          </a:p>
+        </p:txBody>
+      </p:sp>
+      <p:sp>
+        <p:nvSpPr>
+          <p:cNvPr id="7" name="Slide Number Placeholder 6"/>
+          <p:cNvSpPr>
+            <a:spLocks noGrp="1"/>
+          </p:cNvSpPr>
+          <p:nvPr>
+            <p:ph type="sldNum" sz="quarter" idx="5"/>
+          </p:nvPr>
+        </p:nvSpPr>
+        <p:spPr>
+          <a:xfrm>
+            <a:off x="3884613" y="8685213"/>
+            <a:ext cx="2971800" cy="457200"/>
+          </a:xfrm>
+          <a:prstGeom prst="rect">
+            <a:avLst/>
+          </a:prstGeom>
+        </p:spPr>
+        <p:txBody>
+          <a:bodyPr vert="horz" lIns="91440" tIns="45720" rIns="91440" bIns="45720" rtlCol="0" anchor="b"/>
+          <a:lstStyle>
+            <a:lvl1pPr algn="r">
+              <a:defRPr sz="1200"/>
+            </a:lvl1pPr>
+          </a:lstStyle>
+          <a:p>
+            <a:fld id="{BB5E49A5-4136-284D-997B-48E1D791AD67}" type="slidenum">
+              <a:rPr lang="en-US" smtClean="0"/>
+              <a:t>‹#›</a:t>
+            </a:fld>
+            <a:endParaRPr lang="en-US"/>
+          </a:p>
+        </p:txBody>
+      </p:sp>
+    </p:spTree>
+    <p:extLst>
+      <p:ext uri="{BB962C8B-B14F-4D97-AF65-F5344CB8AC3E}">
+        <p14:creationId xmlns:p14="http://schemas.microsoft.com/office/powerpoint/2010/main" val="2623252185"/>
+      </p:ext>
+    </p:extLst>
+  </p:cSld>
+  <p:clrMap bg1="lt1" tx1="dk1" bg2="lt2" tx2="dk2" accent1="accent1" accent2="accent2" accent3="accent3" accent4="accent4" accent5="accent5" accent6="accent6" hlink="hlink" folHlink="folHlink"/>
+  <p:notesStyle>
+    <a:lvl1pPr marL="0" algn="l" defTabSz="457200" rtl="0" eaLnBrk="1" latinLnBrk="0" hangingPunct="1">
+      <a:defRPr sz="1200" kern="1200">
+        <a:solidFill>
+          <a:schemeClr val="tx1"/>
+        </a:solidFill>
+        <a:latin typeface="+mn-lt"/>
+        <a:ea typeface="+mn-ea"/>
+        <a:cs typeface="+mn-cs"/>
+      </a:defRPr>
+    </a:lvl1pPr>
+    <a:lvl2pPr marL="457200" algn="l" defTabSz="457200" rtl="0" eaLnBrk="1" latinLnBrk="0" hangingPunct="1">
+      <a:defRPr sz="1200" kern="1200">
+        <a:solidFill>
+          <a:schemeClr val="tx1"/>
+        </a:solidFill>
+        <a:latin typeface="+mn-lt"/>
+        <a:ea typeface="+mn-ea"/>
+        <a:cs typeface="+mn-cs"/>
+      </a:defRPr>
+    </a:lvl2pPr>
+    <a:lvl3pPr marL="914400" algn="l" defTabSz="457200" rtl="0" eaLnBrk="1" latinLnBrk="0" hangingPunct="1">
+      <a:defRPr sz="1200" kern="1200">
+        <a:solidFill>
+          <a:schemeClr val="tx1"/>
+        </a:solidFill>
+        <a:latin typeface="+mn-lt"/>
+        <a:ea typeface="+mn-ea"/>
+        <a:cs typeface="+mn-cs"/>
+      </a:defRPr>
+    </a:lvl3pPr>
+    <a:lvl4pPr marL="1371600" algn="l" defTabSz="457200" rtl="0" eaLnBrk="1" latinLnBrk="0" hangingPunct="1">
+      <a:defRPr sz="1200" kern="1200">
+        <a:solidFill>
+          <a:schemeClr val="tx1"/>
+        </a:solidFill>
+        <a:latin typeface="+mn-lt"/>
+        <a:ea typeface="+mn-ea"/>
+        <a:cs typeface="+mn-cs"/>
+      </a:defRPr>
+    </a:lvl4pPr>
+    <a:lvl5pPr marL="1828800" algn="l" defTabSz="457200" rtl="0" eaLnBrk="1" latinLnBrk="0" hangingPunct="1">
+      <a:defRPr sz="1200" kern="1200">
+        <a:solidFill>
+          <a:schemeClr val="tx1"/>
+        </a:solidFill>
+        <a:latin typeface="+mn-lt"/>
+        <a:ea typeface="+mn-ea"/>
+        <a:cs typeface="+mn-cs"/>
+      </a:defRPr>
+    </a:lvl5pPr>
+    <a:lvl6pPr marL="2286000" algn="l" defTabSz="457200" rtl="0" eaLnBrk="1" latinLnBrk="0" hangingPunct="1">
+      <a:defRPr sz="1200" kern="1200">
+        <a:solidFill>
+          <a:schemeClr val="tx1"/>
+        </a:solidFill>
+        <a:latin typeface="+mn-lt"/>
+        <a:ea typeface="+mn-ea"/>
+        <a:cs typeface="+mn-cs"/>
+      </a:defRPr>
+    </a:lvl6pPr>
+    <a:lvl7pPr marL="2743200" algn="l" defTabSz="457200" rtl="0" eaLnBrk="1" latinLnBrk="0" hangingPunct="1">
+      <a:defRPr sz="1200" kern="1200">
+        <a:solidFill>
+          <a:schemeClr val="tx1"/>
+        </a:solidFill>
+        <a:latin typeface="+mn-lt"/>
+        <a:ea typeface="+mn-ea"/>
+        <a:cs typeface="+mn-cs"/>
+      </a:defRPr>
+    </a:lvl7pPr>
+    <a:lvl8pPr marL="3200400" algn="l" defTabSz="457200" rtl="0" eaLnBrk="1" latinLnBrk="0" hangingPunct="1">
+      <a:defRPr sz="1200" kern="1200">
+        <a:solidFill>
+          <a:schemeClr val="tx1"/>
+        </a:solidFill>
+        <a:latin typeface="+mn-lt"/>
+        <a:ea typeface="+mn-ea"/>
+        <a:cs typeface="+mn-cs"/>
+      </a:defRPr>
+    </a:lvl8pPr>
+    <a:lvl9pPr marL="3657600" algn="l" defTabSz="457200" rtl="0" eaLnBrk="1" latinLnBrk="0" hangingPunct="1">
+      <a:defRPr sz="1200" kern="1200">
+        <a:solidFill>
+          <a:schemeClr val="tx1"/>
+        </a:solidFill>
+        <a:latin typeface="+mn-lt"/>
+        <a:ea typeface="+mn-ea"/>
+        <a:cs typeface="+mn-cs"/>
+      </a:defRPr>
+    </a:lvl9pPr>
+  </p:notesStyle>
+</p:notesMaster>
+</file>
+
+<file path=ppt/notesSlides/notesSlide1.xml><?xml version="1.0" encoding="utf-8"?>
+<p:notes xmlns:a="http://schemas.openxmlformats.org/drawingml/2006/main" xmlns:p="http://schemas.openxmlformats.org/presentationml/2006/main" xmlns:r="http://schemas.openxmlformats.org/officeDocument/2006/relationships">
+  <p:cSld>
+    <p:spTree>
+      <p:nvGrpSpPr>
+        <p:cNvPr id="1" name=""/>
+        <p:cNvGrpSpPr/>
+        <p:nvPr/>
+      </p:nvGrpSpPr>
+      <p:grpSpPr>
+        <a:xfrm>
+          <a:off x="0" y="0"/>
+          <a:ext cx="0" cy="0"/>
+          <a:chOff x="0" y="0"/>
+          <a:chExt cx="0" cy="0"/>
+        </a:xfrm>
+      </p:grpSpPr>
+      <p:sp>
+        <p:nvSpPr>
+          <p:cNvPr id="2" name="Slide Image Placeholder 1"/>
+          <p:cNvSpPr>
+            <a:spLocks noGrp="1"/>
+          </p:cNvSpPr>
+          <p:nvPr>
+            <p:ph type="sldImg" idx="2"/>
+          </p:nvPr>
+        </p:nvSpPr>
+        <p:spPr/>
+      </p:sp>
+      <p:sp>
+        <p:nvSpPr>
+          <p:cNvPr id="3" name="Notes Placeholder 2"/>
+          <p:cNvSpPr>
+            <a:spLocks noGrp="1"/>
+          </p:cNvSpPr>
+          <p:nvPr>
+            <p:ph type="body" idx="3" sz="quarter"/>
+          </p:nvPr>
+        </p:nvSpPr>
+        <p:spPr/>
+        <p:txBody>
+          <a:bodyPr/>
+          <a:lstStyle/>
+          <a:p>
+            <a:r>
+              <a:t>16 use cases. UC-01 to UC-06 are every control of the window (Programmer). UC-07 Run scan cycle runs once per tick, driven by the harness, and includes UC-08 to UC-15: inputs from the CTC Office and Track Model, commands to the Track Model, the report to the CTC. UC-16 Hold fail-safe extends the scan. Together they cover rubric 6.0 to 6.9 and 9.0.</a:t>
+            </a:r>
+          </a:p>
+        </p:txBody>
+      </p:sp>
+      <p:sp>
+        <p:nvSpPr>
+          <p:cNvPr id="4" name="Slide Number Placeholder 3"/>
+          <p:cNvSpPr>
+            <a:spLocks noGrp="1"/>
+          </p:cNvSpPr>
+          <p:nvPr>
+            <p:ph type="sldNum" idx="5" sz="quarter"/>
+          </p:nvPr>
+        </p:nvSpPr>
+        <p:spPr/>
+      </p:sp>
+    </p:spTree>
+  </p:cSld>
+  <p:clrMapOvr>
+    <a:masterClrMapping/>
+  </p:clrMapOvr>
+</p:notes>
+</file>
+
+<file path=ppt/notesSlides/notesSlide10.xml><?xml version="1.0" encoding="utf-8"?>
+<p:notes xmlns:a="http://schemas.openxmlformats.org/drawingml/2006/main" xmlns:p="http://schemas.openxmlformats.org/presentationml/2006/main" xmlns:r="http://schemas.openxmlformats.org/officeDocument/2006/relationships">
+  <p:cSld>
+    <p:spTree>
+      <p:nvGrpSpPr>
+        <p:cNvPr id="1" name=""/>
+        <p:cNvGrpSpPr/>
+        <p:nvPr/>
+      </p:nvGrpSpPr>
+      <p:grpSpPr>
+        <a:xfrm>
+          <a:off x="0" y="0"/>
+          <a:ext cx="0" cy="0"/>
+          <a:chOff x="0" y="0"/>
+          <a:chExt cx="0" cy="0"/>
+        </a:xfrm>
+      </p:grpSpPr>
+      <p:sp>
+        <p:nvSpPr>
+          <p:cNvPr id="2" name="Slide Image Placeholder 1"/>
+          <p:cNvSpPr>
+            <a:spLocks noGrp="1"/>
+          </p:cNvSpPr>
+          <p:nvPr>
+            <p:ph type="sldImg" idx="2"/>
+          </p:nvPr>
+        </p:nvSpPr>
+        <p:spPr/>
+      </p:sp>
+      <p:sp>
+        <p:nvSpPr>
+          <p:cNvPr id="3" name="Notes Placeholder 2"/>
+          <p:cNvSpPr>
+            <a:spLocks noGrp="1"/>
+          </p:cNvSpPr>
+          <p:nvPr>
+            <p:ph type="body" idx="3" sz="quarter"/>
+          </p:nvPr>
+        </p:nvSpPr>
+        <p:spPr/>
+        <p:txBody>
+          <a:bodyPr/>
+          <a:lstStyle/>
+          <a:p>
+            <a:r>
+              <a:t>TrackControllerState is the QML bridge: slots for the window's actions, properties QML binds to. It turns snapshots into rows through views, display and schematic, and updates five RowsModels in place, at most every 100 ms.</a:t>
+            </a:r>
+          </a:p>
+        </p:txBody>
+      </p:sp>
+      <p:sp>
+        <p:nvSpPr>
+          <p:cNvPr id="4" name="Slide Number Placeholder 3"/>
+          <p:cNvSpPr>
+            <a:spLocks noGrp="1"/>
+          </p:cNvSpPr>
+          <p:nvPr>
+            <p:ph type="sldNum" idx="5" sz="quarter"/>
+          </p:nvPr>
+        </p:nvSpPr>
+        <p:spPr/>
+      </p:sp>
+    </p:spTree>
+  </p:cSld>
+  <p:clrMapOvr>
+    <a:masterClrMapping/>
+  </p:clrMapOvr>
+</p:notes>
+</file>
+
+<file path=ppt/notesSlides/notesSlide11.xml><?xml version="1.0" encoding="utf-8"?>
+<p:notes xmlns:a="http://schemas.openxmlformats.org/drawingml/2006/main" xmlns:p="http://schemas.openxmlformats.org/presentationml/2006/main" xmlns:r="http://schemas.openxmlformats.org/officeDocument/2006/relationships">
+  <p:cSld>
+    <p:spTree>
+      <p:nvGrpSpPr>
+        <p:cNvPr id="1" name=""/>
+        <p:cNvGrpSpPr/>
+        <p:nvPr/>
+      </p:nvGrpSpPr>
+      <p:grpSpPr>
+        <a:xfrm>
+          <a:off x="0" y="0"/>
+          <a:ext cx="0" cy="0"/>
+          <a:chOff x="0" y="0"/>
+          <a:chExt cx="0" cy="0"/>
+        </a:xfrm>
+      </p:grpSpPr>
+      <p:sp>
+        <p:nvSpPr>
+          <p:cNvPr id="2" name="Slide Image Placeholder 1"/>
+          <p:cNvSpPr>
+            <a:spLocks noGrp="1"/>
+          </p:cNvSpPr>
+          <p:nvPr>
+            <p:ph type="sldImg" idx="2"/>
+          </p:nvPr>
+        </p:nvSpPr>
+        <p:spPr/>
+      </p:sp>
+      <p:sp>
+        <p:nvSpPr>
+          <p:cNvPr id="3" name="Notes Placeholder 2"/>
+          <p:cNvSpPr>
+            <a:spLocks noGrp="1"/>
+          </p:cNvSpPr>
+          <p:nvPr>
+            <p:ph type="body" idx="3" sz="quarter"/>
+          </p:nvPr>
+        </p:nvSpPr>
+        <p:spPr/>
+        <p:txBody>
+          <a:bodyPr/>
+          <a:lstStyle/>
+          <a:p>
+            <a:r>
+              <a:t>Planned. RemoteTrackController implements the same Protocol as HwTrackController, so neither the window nor the harness endpoint changes. PiSerialLink sends each call as one newline-JSON request over USB serial (D027); HarnessEndpoint answers the harness's ticks.</a:t>
+            </a:r>
+          </a:p>
+        </p:txBody>
+      </p:sp>
+      <p:sp>
+        <p:nvSpPr>
+          <p:cNvPr id="4" name="Slide Number Placeholder 3"/>
+          <p:cNvSpPr>
+            <a:spLocks noGrp="1"/>
+          </p:cNvSpPr>
+          <p:nvPr>
+            <p:ph type="sldNum" idx="5" sz="quarter"/>
+          </p:nvPr>
+        </p:nvSpPr>
+        <p:spPr/>
+      </p:sp>
+    </p:spTree>
+  </p:cSld>
+  <p:clrMapOvr>
+    <a:masterClrMapping/>
+  </p:clrMapOvr>
+</p:notes>
+</file>
+
+<file path=ppt/notesSlides/notesSlide12.xml><?xml version="1.0" encoding="utf-8"?>
+<p:notes xmlns:a="http://schemas.openxmlformats.org/drawingml/2006/main" xmlns:p="http://schemas.openxmlformats.org/presentationml/2006/main" xmlns:r="http://schemas.openxmlformats.org/officeDocument/2006/relationships">
+  <p:cSld>
+    <p:spTree>
+      <p:nvGrpSpPr>
+        <p:cNvPr id="1" name=""/>
+        <p:cNvGrpSpPr/>
+        <p:nvPr/>
+      </p:nvGrpSpPr>
+      <p:grpSpPr>
+        <a:xfrm>
+          <a:off x="0" y="0"/>
+          <a:ext cx="0" cy="0"/>
+          <a:chOff x="0" y="0"/>
+          <a:chExt cx="0" cy="0"/>
+        </a:xfrm>
+      </p:grpSpPr>
+      <p:sp>
+        <p:nvSpPr>
+          <p:cNvPr id="2" name="Slide Image Placeholder 1"/>
+          <p:cNvSpPr>
+            <a:spLocks noGrp="1"/>
+          </p:cNvSpPr>
+          <p:nvPr>
+            <p:ph type="sldImg" idx="2"/>
+          </p:nvPr>
+        </p:nvSpPr>
+        <p:spPr/>
+      </p:sp>
+      <p:sp>
+        <p:nvSpPr>
+          <p:cNvPr id="3" name="Notes Placeholder 2"/>
+          <p:cNvSpPr>
+            <a:spLocks noGrp="1"/>
+          </p:cNvSpPr>
+          <p:nvPr>
+            <p:ph type="body" idx="3" sz="quarter"/>
+          </p:nvPr>
+        </p:nvSpPr>
+        <p:spPr/>
+        <p:txBody>
+          <a:bodyPr/>
+          <a:lstStyle/>
+          <a:p>
+            <a:r>
+              <a:t>One tick: the harness maps the CTC Office's and Track Model's previous outputs into this module's inputs; the PC relays the step to the Pi; every wayside scans; the outputs go back. An invalid input rejects the whole tick. At 10x, USB round trip plus scan must stay under 10 ms.</a:t>
+            </a:r>
+          </a:p>
+        </p:txBody>
+      </p:sp>
+      <p:sp>
+        <p:nvSpPr>
+          <p:cNvPr id="4" name="Slide Number Placeholder 3"/>
+          <p:cNvSpPr>
+            <a:spLocks noGrp="1"/>
+          </p:cNvSpPr>
+          <p:nvPr>
+            <p:ph type="sldNum" idx="5" sz="quarter"/>
+          </p:nvPr>
+        </p:nvSpPr>
+        <p:spPr/>
+      </p:sp>
+    </p:spTree>
+  </p:cSld>
+  <p:clrMapOvr>
+    <a:masterClrMapping/>
+  </p:clrMapOvr>
+</p:notes>
+</file>
+
+<file path=ppt/notesSlides/notesSlide13.xml><?xml version="1.0" encoding="utf-8"?>
+<p:notes xmlns:a="http://schemas.openxmlformats.org/drawingml/2006/main" xmlns:p="http://schemas.openxmlformats.org/presentationml/2006/main" xmlns:r="http://schemas.openxmlformats.org/officeDocument/2006/relationships">
+  <p:cSld>
+    <p:spTree>
+      <p:nvGrpSpPr>
+        <p:cNvPr id="1" name=""/>
+        <p:cNvGrpSpPr/>
+        <p:nvPr/>
+      </p:nvGrpSpPr>
+      <p:grpSpPr>
+        <a:xfrm>
+          <a:off x="0" y="0"/>
+          <a:ext cx="0" cy="0"/>
+          <a:chOff x="0" y="0"/>
+          <a:chExt cx="0" cy="0"/>
+        </a:xfrm>
+      </p:grpSpPr>
+      <p:sp>
+        <p:nvSpPr>
+          <p:cNvPr id="2" name="Slide Image Placeholder 1"/>
+          <p:cNvSpPr>
+            <a:spLocks noGrp="1"/>
+          </p:cNvSpPr>
+          <p:nvPr>
+            <p:ph type="sldImg" idx="2"/>
+          </p:nvPr>
+        </p:nvSpPr>
+        <p:spPr/>
+      </p:sp>
+      <p:sp>
+        <p:nvSpPr>
+          <p:cNvPr id="3" name="Notes Placeholder 2"/>
+          <p:cNvSpPr>
+            <a:spLocks noGrp="1"/>
+          </p:cNvSpPr>
+          <p:nvPr>
+            <p:ph type="body" idx="3" sz="quarter"/>
+          </p:nvPr>
+        </p:nvSpPr>
+        <p:spPr/>
+        <p:txBody>
+          <a:bodyPr/>
+          <a:lstStyle/>
+          <a:p>
+            <a:r>
+              <a:t>One wayside's scan. It holds fail-safe if any wayside is not ready, it has no program, or a channel fault is latched. Otherwise: build the input image, run the user program on channels A and B, compare, run the vital block the same way (planned), then drive the outputs. The CTC report is built every scan.</a:t>
+            </a:r>
+          </a:p>
+        </p:txBody>
+      </p:sp>
+      <p:sp>
+        <p:nvSpPr>
+          <p:cNvPr id="4" name="Slide Number Placeholder 3"/>
+          <p:cNvSpPr>
+            <a:spLocks noGrp="1"/>
+          </p:cNvSpPr>
+          <p:nvPr>
+            <p:ph type="sldNum" idx="5" sz="quarter"/>
+          </p:nvPr>
+        </p:nvSpPr>
+        <p:spPr/>
+      </p:sp>
+    </p:spTree>
+  </p:cSld>
+  <p:clrMapOvr>
+    <a:masterClrMapping/>
+  </p:clrMapOvr>
+</p:notes>
+</file>
+
+<file path=ppt/notesSlides/notesSlide14.xml><?xml version="1.0" encoding="utf-8"?>
+<p:notes xmlns:a="http://schemas.openxmlformats.org/drawingml/2006/main" xmlns:p="http://schemas.openxmlformats.org/presentationml/2006/main" xmlns:r="http://schemas.openxmlformats.org/officeDocument/2006/relationships">
+  <p:cSld>
+    <p:spTree>
+      <p:nvGrpSpPr>
+        <p:cNvPr id="1" name=""/>
+        <p:cNvGrpSpPr/>
+        <p:nvPr/>
+      </p:nvGrpSpPr>
+      <p:grpSpPr>
+        <a:xfrm>
+          <a:off x="0" y="0"/>
+          <a:ext cx="0" cy="0"/>
+          <a:chOff x="0" y="0"/>
+          <a:chExt cx="0" cy="0"/>
+        </a:xfrm>
+      </p:grpSpPr>
+      <p:sp>
+        <p:nvSpPr>
+          <p:cNvPr id="2" name="Slide Image Placeholder 1"/>
+          <p:cNvSpPr>
+            <a:spLocks noGrp="1"/>
+          </p:cNvSpPr>
+          <p:nvPr>
+            <p:ph type="sldImg" idx="2"/>
+          </p:nvPr>
+        </p:nvSpPr>
+        <p:spPr/>
+      </p:sp>
+      <p:sp>
+        <p:nvSpPr>
+          <p:cNvPr id="3" name="Notes Placeholder 2"/>
+          <p:cNvSpPr>
+            <a:spLocks noGrp="1"/>
+          </p:cNvSpPr>
+          <p:nvPr>
+            <p:ph type="body" idx="3" sz="quarter"/>
+          </p:nvPr>
+        </p:nvSpPr>
+        <p:spPr/>
+        <p:txBody>
+          <a:bodyPr/>
+          <a:lstStyle/>
+          <a:p>
+            <a:r>
+              <a:t>One wayside's scan. It holds fail-safe if any wayside is not ready, it has no program, or a channel fault is latched. Otherwise: build the input image, run the user program on channels A and B, compare, run the vital block the same way (planned), then drive the outputs. The CTC report is built every scan.</a:t>
+            </a:r>
+          </a:p>
+        </p:txBody>
+      </p:sp>
+      <p:sp>
+        <p:nvSpPr>
+          <p:cNvPr id="4" name="Slide Number Placeholder 3"/>
+          <p:cNvSpPr>
+            <a:spLocks noGrp="1"/>
+          </p:cNvSpPr>
+          <p:nvPr>
+            <p:ph type="sldNum" idx="5" sz="quarter"/>
+          </p:nvPr>
+        </p:nvSpPr>
+        <p:spPr/>
+      </p:sp>
+    </p:spTree>
+  </p:cSld>
+  <p:clrMapOvr>
+    <a:masterClrMapping/>
+  </p:clrMapOvr>
+</p:notes>
+</file>
+
+<file path=ppt/notesSlides/notesSlide15.xml><?xml version="1.0" encoding="utf-8"?>
+<p:notes xmlns:a="http://schemas.openxmlformats.org/drawingml/2006/main" xmlns:p="http://schemas.openxmlformats.org/presentationml/2006/main" xmlns:r="http://schemas.openxmlformats.org/officeDocument/2006/relationships">
+  <p:cSld>
+    <p:spTree>
+      <p:nvGrpSpPr>
+        <p:cNvPr id="1" name=""/>
+        <p:cNvGrpSpPr/>
+        <p:nvPr/>
+      </p:nvGrpSpPr>
+      <p:grpSpPr>
+        <a:xfrm>
+          <a:off x="0" y="0"/>
+          <a:ext cx="0" cy="0"/>
+          <a:chOff x="0" y="0"/>
+          <a:chExt cx="0" cy="0"/>
+        </a:xfrm>
+      </p:grpSpPr>
+      <p:sp>
+        <p:nvSpPr>
+          <p:cNvPr id="2" name="Slide Image Placeholder 1"/>
+          <p:cNvSpPr>
+            <a:spLocks noGrp="1"/>
+          </p:cNvSpPr>
+          <p:nvPr>
+            <p:ph type="sldImg" idx="2"/>
+          </p:nvPr>
+        </p:nvSpPr>
+        <p:spPr/>
+      </p:sp>
+      <p:sp>
+        <p:nvSpPr>
+          <p:cNvPr id="3" name="Notes Placeholder 2"/>
+          <p:cNvSpPr>
+            <a:spLocks noGrp="1"/>
+          </p:cNvSpPr>
+          <p:nvPr>
+            <p:ph type="body" idx="3" sz="quarter"/>
+          </p:nvPr>
+        </p:nvSpPr>
+        <p:spPr/>
+        <p:txBody>
+          <a:bodyPr/>
+          <a:lstStyle/>
+          <a:p>
+            <a:r>
+              <a:t>The PC parses the file and rejects a bad one before sending it; the Pi checks the line and that no other wayside owns its blocks. A replaced wayside keeps its program if the program still fits.</a:t>
+            </a:r>
+          </a:p>
+        </p:txBody>
+      </p:sp>
+      <p:sp>
+        <p:nvSpPr>
+          <p:cNvPr id="4" name="Slide Number Placeholder 3"/>
+          <p:cNvSpPr>
+            <a:spLocks noGrp="1"/>
+          </p:cNvSpPr>
+          <p:nvPr>
+            <p:ph type="sldNum" idx="5" sz="quarter"/>
+          </p:nvPr>
+        </p:nvSpPr>
+        <p:spPr/>
+      </p:sp>
+    </p:spTree>
+  </p:cSld>
+  <p:clrMapOvr>
+    <a:masterClrMapping/>
+  </p:clrMapOvr>
+</p:notes>
+</file>
+
+<file path=ppt/notesSlides/notesSlide16.xml><?xml version="1.0" encoding="utf-8"?>
+<p:notes xmlns:a="http://schemas.openxmlformats.org/drawingml/2006/main" xmlns:p="http://schemas.openxmlformats.org/presentationml/2006/main" xmlns:r="http://schemas.openxmlformats.org/officeDocument/2006/relationships">
+  <p:cSld>
+    <p:spTree>
+      <p:nvGrpSpPr>
+        <p:cNvPr id="1" name=""/>
+        <p:cNvGrpSpPr/>
+        <p:nvPr/>
+      </p:nvGrpSpPr>
+      <p:grpSpPr>
+        <a:xfrm>
+          <a:off x="0" y="0"/>
+          <a:ext cx="0" cy="0"/>
+          <a:chOff x="0" y="0"/>
+          <a:chExt cx="0" cy="0"/>
+        </a:xfrm>
+      </p:grpSpPr>
+      <p:sp>
+        <p:nvSpPr>
+          <p:cNvPr id="2" name="Slide Image Placeholder 1"/>
+          <p:cNvSpPr>
+            <a:spLocks noGrp="1"/>
+          </p:cNvSpPr>
+          <p:nvPr>
+            <p:ph type="sldImg" idx="2"/>
+          </p:nvPr>
+        </p:nvSpPr>
+        <p:spPr/>
+      </p:sp>
+      <p:sp>
+        <p:nvSpPr>
+          <p:cNvPr id="3" name="Notes Placeholder 2"/>
+          <p:cNvSpPr>
+            <a:spLocks noGrp="1"/>
+          </p:cNvSpPr>
+          <p:nvPr>
+            <p:ph type="body" idx="3" sz="quarter"/>
+          </p:nvPr>
+        </p:nvSpPr>
+        <p:spPr/>
+        <p:txBody>
+          <a:bodyPr/>
+          <a:lstStyle/>
+          <a:p>
+            <a:r>
+              <a:t>Compiled twice and checked against the wayside's I/O, on the Pi. Any error refuses the program and lists every problem with its line number; the old program keeps running. A new program holds fail-safe until its first scan.</a:t>
+            </a:r>
+          </a:p>
+        </p:txBody>
+      </p:sp>
+      <p:sp>
+        <p:nvSpPr>
+          <p:cNvPr id="4" name="Slide Number Placeholder 3"/>
+          <p:cNvSpPr>
+            <a:spLocks noGrp="1"/>
+          </p:cNvSpPr>
+          <p:nvPr>
+            <p:ph type="sldNum" idx="5" sz="quarter"/>
+          </p:nvPr>
+        </p:nvSpPr>
+        <p:spPr/>
+      </p:sp>
+    </p:spTree>
+  </p:cSld>
+  <p:clrMapOvr>
+    <a:masterClrMapping/>
+  </p:clrMapOvr>
+</p:notes>
+</file>
+
+<file path=ppt/notesSlides/notesSlide17.xml><?xml version="1.0" encoding="utf-8"?>
+<p:notes xmlns:a="http://schemas.openxmlformats.org/drawingml/2006/main" xmlns:p="http://schemas.openxmlformats.org/presentationml/2006/main" xmlns:r="http://schemas.openxmlformats.org/officeDocument/2006/relationships">
+  <p:cSld>
+    <p:spTree>
+      <p:nvGrpSpPr>
+        <p:cNvPr id="1" name=""/>
+        <p:cNvGrpSpPr/>
+        <p:nvPr/>
+      </p:nvGrpSpPr>
+      <p:grpSpPr>
+        <a:xfrm>
+          <a:off x="0" y="0"/>
+          <a:ext cx="0" cy="0"/>
+          <a:chOff x="0" y="0"/>
+          <a:chExt cx="0" cy="0"/>
+        </a:xfrm>
+      </p:grpSpPr>
+      <p:sp>
+        <p:nvSpPr>
+          <p:cNvPr id="2" name="Slide Image Placeholder 1"/>
+          <p:cNvSpPr>
+            <a:spLocks noGrp="1"/>
+          </p:cNvSpPr>
+          <p:nvPr>
+            <p:ph type="sldImg" idx="2"/>
+          </p:nvPr>
+        </p:nvSpPr>
+        <p:spPr/>
+      </p:sp>
+      <p:sp>
+        <p:nvSpPr>
+          <p:cNvPr id="3" name="Notes Placeholder 2"/>
+          <p:cNvSpPr>
+            <a:spLocks noGrp="1"/>
+          </p:cNvSpPr>
+          <p:nvPr>
+            <p:ph type="body" idx="3" sz="quarter"/>
+          </p:nvPr>
+        </p:nvSpPr>
+        <p:spPr/>
+        <p:txBody>
+          <a:bodyPr/>
+          <a:lstStyle/>
+          <a:p>
+            <a:r>
+              <a:t>The window takes a snapshot, converts it to rows in display units and updates the tables in place. A 100 ms timer refreshes when ticks have advanced. Zoom and Fit are QML only.</a:t>
+            </a:r>
+          </a:p>
+        </p:txBody>
+      </p:sp>
+      <p:sp>
+        <p:nvSpPr>
+          <p:cNvPr id="4" name="Slide Number Placeholder 3"/>
+          <p:cNvSpPr>
+            <a:spLocks noGrp="1"/>
+          </p:cNvSpPr>
+          <p:nvPr>
+            <p:ph type="sldNum" idx="5" sz="quarter"/>
+          </p:nvPr>
+        </p:nvSpPr>
+        <p:spPr/>
+      </p:sp>
+    </p:spTree>
+  </p:cSld>
+  <p:clrMapOvr>
+    <a:masterClrMapping/>
+  </p:clrMapOvr>
+</p:notes>
+</file>
+
+<file path=ppt/notesSlides/notesSlide18.xml><?xml version="1.0" encoding="utf-8"?>
+<p:notes xmlns:a="http://schemas.openxmlformats.org/drawingml/2006/main" xmlns:p="http://schemas.openxmlformats.org/presentationml/2006/main" xmlns:r="http://schemas.openxmlformats.org/officeDocument/2006/relationships">
+  <p:cSld>
+    <p:spTree>
+      <p:nvGrpSpPr>
+        <p:cNvPr id="1" name=""/>
+        <p:cNvGrpSpPr/>
+        <p:nvPr/>
+      </p:nvGrpSpPr>
+      <p:grpSpPr>
+        <a:xfrm>
+          <a:off x="0" y="0"/>
+          <a:ext cx="0" cy="0"/>
+          <a:chOff x="0" y="0"/>
+          <a:chExt cx="0" cy="0"/>
+        </a:xfrm>
+      </p:grpSpPr>
+      <p:sp>
+        <p:nvSpPr>
+          <p:cNvPr id="2" name="Slide Image Placeholder 1"/>
+          <p:cNvSpPr>
+            <a:spLocks noGrp="1"/>
+          </p:cNvSpPr>
+          <p:nvPr>
+            <p:ph type="sldImg" idx="2"/>
+          </p:nvPr>
+        </p:nvSpPr>
+        <p:spPr/>
+      </p:sp>
+      <p:sp>
+        <p:nvSpPr>
+          <p:cNvPr id="3" name="Notes Placeholder 2"/>
+          <p:cNvSpPr>
+            <a:spLocks noGrp="1"/>
+          </p:cNvSpPr>
+          <p:nvPr>
+            <p:ph type="body" idx="3" sz="quarter"/>
+          </p:nvPr>
+        </p:nvSpPr>
+        <p:spPr/>
+        <p:txBody>
+          <a:bodyPr/>
+          <a:lstStyle/>
+          <a:p>
+            <a:r>
+              <a:t>Two read-only dialogs over values from the last refresh. New PLC in the details dialog starts SD-02.</a:t>
+            </a:r>
+          </a:p>
+        </p:txBody>
+      </p:sp>
+      <p:sp>
+        <p:nvSpPr>
+          <p:cNvPr id="4" name="Slide Number Placeholder 3"/>
+          <p:cNvSpPr>
+            <a:spLocks noGrp="1"/>
+          </p:cNvSpPr>
+          <p:nvPr>
+            <p:ph type="sldNum" idx="5" sz="quarter"/>
+          </p:nvPr>
+        </p:nvSpPr>
+        <p:spPr/>
+      </p:sp>
+    </p:spTree>
+  </p:cSld>
+  <p:clrMapOvr>
+    <a:masterClrMapping/>
+  </p:clrMapOvr>
+</p:notes>
+</file>
+
+<file path=ppt/notesSlides/notesSlide19.xml><?xml version="1.0" encoding="utf-8"?>
+<p:notes xmlns:a="http://schemas.openxmlformats.org/drawingml/2006/main" xmlns:p="http://schemas.openxmlformats.org/presentationml/2006/main" xmlns:r="http://schemas.openxmlformats.org/officeDocument/2006/relationships">
+  <p:cSld>
+    <p:spTree>
+      <p:nvGrpSpPr>
+        <p:cNvPr id="1" name=""/>
+        <p:cNvGrpSpPr/>
+        <p:nvPr/>
+      </p:nvGrpSpPr>
+      <p:grpSpPr>
+        <a:xfrm>
+          <a:off x="0" y="0"/>
+          <a:ext cx="0" cy="0"/>
+          <a:chOff x="0" y="0"/>
+          <a:chExt cx="0" cy="0"/>
+        </a:xfrm>
+      </p:grpSpPr>
+      <p:sp>
+        <p:nvSpPr>
+          <p:cNvPr id="2" name="Slide Image Placeholder 1"/>
+          <p:cNvSpPr>
+            <a:spLocks noGrp="1"/>
+          </p:cNvSpPr>
+          <p:nvPr>
+            <p:ph type="sldImg" idx="2"/>
+          </p:nvPr>
+        </p:nvSpPr>
+        <p:spPr/>
+      </p:sp>
+      <p:sp>
+        <p:nvSpPr>
+          <p:cNvPr id="3" name="Notes Placeholder 2"/>
+          <p:cNvSpPr>
+            <a:spLocks noGrp="1"/>
+          </p:cNvSpPr>
+          <p:nvPr>
+            <p:ph type="body" idx="3" sz="quarter"/>
+          </p:nvPr>
+        </p:nvSpPr>
+        <p:spPr/>
+        <p:txBody>
+          <a:bodyPr/>
+          <a:lstStyle/>
+          <a:p>
+            <a:r>
+              <a:t>The CTC Office's command reaches the program as the CTCSW and CTCREV inputs; the program obeys unless a train holds the switch. The Track Model's read-back goes into the CTC report. When maintenance ends, the program routes the switch again.</a:t>
+            </a:r>
+          </a:p>
+        </p:txBody>
+      </p:sp>
+      <p:sp>
+        <p:nvSpPr>
+          <p:cNvPr id="4" name="Slide Number Placeholder 3"/>
+          <p:cNvSpPr>
+            <a:spLocks noGrp="1"/>
+          </p:cNvSpPr>
+          <p:nvPr>
+            <p:ph type="sldNum" idx="5" sz="quarter"/>
+          </p:nvPr>
+        </p:nvSpPr>
+        <p:spPr/>
+      </p:sp>
+    </p:spTree>
+  </p:cSld>
+  <p:clrMapOvr>
+    <a:masterClrMapping/>
+  </p:clrMapOvr>
+</p:notes>
+</file>
+
+<file path=ppt/notesSlides/notesSlide2.xml><?xml version="1.0" encoding="utf-8"?>
+<p:notes xmlns:a="http://schemas.openxmlformats.org/drawingml/2006/main" xmlns:p="http://schemas.openxmlformats.org/presentationml/2006/main" xmlns:r="http://schemas.openxmlformats.org/officeDocument/2006/relationships">
+  <p:cSld>
+    <p:spTree>
+      <p:nvGrpSpPr>
+        <p:cNvPr id="1" name=""/>
+        <p:cNvGrpSpPr/>
+        <p:nvPr/>
+      </p:nvGrpSpPr>
+      <p:grpSpPr>
+        <a:xfrm>
+          <a:off x="0" y="0"/>
+          <a:ext cx="0" cy="0"/>
+          <a:chOff x="0" y="0"/>
+          <a:chExt cx="0" cy="0"/>
+        </a:xfrm>
+      </p:grpSpPr>
+      <p:sp>
+        <p:nvSpPr>
+          <p:cNvPr id="2" name="Slide Image Placeholder 1"/>
+          <p:cNvSpPr>
+            <a:spLocks noGrp="1"/>
+          </p:cNvSpPr>
+          <p:nvPr>
+            <p:ph type="sldImg" idx="2"/>
+          </p:nvPr>
+        </p:nvSpPr>
+        <p:spPr/>
+      </p:sp>
+      <p:sp>
+        <p:nvSpPr>
+          <p:cNvPr id="3" name="Notes Placeholder 2"/>
+          <p:cNvSpPr>
+            <a:spLocks noGrp="1"/>
+          </p:cNvSpPr>
+          <p:nvPr>
+            <p:ph type="body" idx="3" sz="quarter"/>
+          </p:nvPr>
+        </p:nvSpPr>
+        <p:spPr/>
+        <p:txBody>
+          <a:bodyPr/>
+          <a:lstStyle/>
+          <a:p>
+            <a:r>
+              <a:t>Layers: presentation and host-side communication on the PC; control, PLC engine and Pi-side communication on the Pi; the contract (interface, wire format, errors) is shared by both. Orange = planned: the PC/Pi split.</a:t>
+            </a:r>
+          </a:p>
+        </p:txBody>
+      </p:sp>
+      <p:sp>
+        <p:nvSpPr>
+          <p:cNvPr id="4" name="Slide Number Placeholder 3"/>
+          <p:cNvSpPr>
+            <a:spLocks noGrp="1"/>
+          </p:cNvSpPr>
+          <p:nvPr>
+            <p:ph type="sldNum" idx="5" sz="quarter"/>
+          </p:nvPr>
+        </p:nvSpPr>
+        <p:spPr/>
+      </p:sp>
+    </p:spTree>
+  </p:cSld>
+  <p:clrMapOvr>
+    <a:masterClrMapping/>
+  </p:clrMapOvr>
+</p:notes>
+</file>
+
+<file path=ppt/notesSlides/notesSlide20.xml><?xml version="1.0" encoding="utf-8"?>
+<p:notes xmlns:a="http://schemas.openxmlformats.org/drawingml/2006/main" xmlns:p="http://schemas.openxmlformats.org/presentationml/2006/main" xmlns:r="http://schemas.openxmlformats.org/officeDocument/2006/relationships">
+  <p:cSld>
+    <p:spTree>
+      <p:nvGrpSpPr>
+        <p:cNvPr id="1" name=""/>
+        <p:cNvGrpSpPr/>
+        <p:nvPr/>
+      </p:nvGrpSpPr>
+      <p:grpSpPr>
+        <a:xfrm>
+          <a:off x="0" y="0"/>
+          <a:ext cx="0" cy="0"/>
+          <a:chOff x="0" y="0"/>
+          <a:chExt cx="0" cy="0"/>
+        </a:xfrm>
+      </p:grpSpPr>
+      <p:sp>
+        <p:nvSpPr>
+          <p:cNvPr id="2" name="Slide Image Placeholder 1"/>
+          <p:cNvSpPr>
+            <a:spLocks noGrp="1"/>
+          </p:cNvSpPr>
+          <p:nvPr>
+            <p:ph type="sldImg" idx="2"/>
+          </p:nvPr>
+        </p:nvSpPr>
+        <p:spPr/>
+      </p:sp>
+      <p:sp>
+        <p:nvSpPr>
+          <p:cNvPr id="3" name="Notes Placeholder 2"/>
+          <p:cNvSpPr>
+            <a:spLocks noGrp="1"/>
+          </p:cNvSpPr>
+          <p:nvPr>
+            <p:ph type="body" idx="3" sz="quarter"/>
+          </p:nvPr>
+        </p:nvSpPr>
+        <p:spPr/>
+        <p:txBody>
+          <a:bodyPr/>
+          <a:lstStyle/>
+          <a:p>
+            <a:r>
+              <a:t>One Windows PC runs the executable; the harness spawns one process per module. The Track Ctrl HW process shows the window and owns the COM port to a Raspberry Pi 5 in USB device mode, which runs every Red Line wayside. The test UI is not deployed. Open item: powering the Pi 5.</a:t>
+            </a:r>
+          </a:p>
+        </p:txBody>
+      </p:sp>
+      <p:sp>
+        <p:nvSpPr>
+          <p:cNvPr id="4" name="Slide Number Placeholder 3"/>
+          <p:cNvSpPr>
+            <a:spLocks noGrp="1"/>
+          </p:cNvSpPr>
+          <p:nvPr>
+            <p:ph type="sldNum" idx="5" sz="quarter"/>
+          </p:nvPr>
+        </p:nvSpPr>
+        <p:spPr/>
+      </p:sp>
+    </p:spTree>
+  </p:cSld>
+  <p:clrMapOvr>
+    <a:masterClrMapping/>
+  </p:clrMapOvr>
+</p:notes>
+</file>
+
+<file path=ppt/notesSlides/notesSlide3.xml><?xml version="1.0" encoding="utf-8"?>
+<p:notes xmlns:a="http://schemas.openxmlformats.org/drawingml/2006/main" xmlns:p="http://schemas.openxmlformats.org/presentationml/2006/main" xmlns:r="http://schemas.openxmlformats.org/officeDocument/2006/relationships">
+  <p:cSld>
+    <p:spTree>
+      <p:nvGrpSpPr>
+        <p:cNvPr id="1" name=""/>
+        <p:cNvGrpSpPr/>
+        <p:nvPr/>
+      </p:nvGrpSpPr>
+      <p:grpSpPr>
+        <a:xfrm>
+          <a:off x="0" y="0"/>
+          <a:ext cx="0" cy="0"/>
+          <a:chOff x="0" y="0"/>
+          <a:chExt cx="0" cy="0"/>
+        </a:xfrm>
+      </p:grpSpPr>
+      <p:sp>
+        <p:nvSpPr>
+          <p:cNvPr id="2" name="Slide Image Placeholder 1"/>
+          <p:cNvSpPr>
+            <a:spLocks noGrp="1"/>
+          </p:cNvSpPr>
+          <p:nvPr>
+            <p:ph type="sldImg" idx="2"/>
+          </p:nvPr>
+        </p:nvSpPr>
+        <p:spPr/>
+      </p:sp>
+      <p:sp>
+        <p:nvSpPr>
+          <p:cNvPr id="3" name="Notes Placeholder 2"/>
+          <p:cNvSpPr>
+            <a:spLocks noGrp="1"/>
+          </p:cNvSpPr>
+          <p:nvPr>
+            <p:ph type="body" idx="3" sz="quarter"/>
+          </p:nvPr>
+        </p:nvSpPr>
+        <p:spPr/>
+        <p:txBody>
+          <a:bodyPr/>
+          <a:lstStyle/>
+          <a:p>
+            <a:r>
+              <a:t>PC side. The QML window talks only to TrackControllerState. Harness ticks and window requests both go through RemoteTrackController, which forwards them over USB serial through PiSerialLink.</a:t>
+            </a:r>
+          </a:p>
+        </p:txBody>
+      </p:sp>
+      <p:sp>
+        <p:nvSpPr>
+          <p:cNvPr id="4" name="Slide Number Placeholder 3"/>
+          <p:cNvSpPr>
+            <a:spLocks noGrp="1"/>
+          </p:cNvSpPr>
+          <p:nvPr>
+            <p:ph type="sldNum" idx="5" sz="quarter"/>
+          </p:nvPr>
+        </p:nvSpPr>
+        <p:spPr/>
+      </p:sp>
+    </p:spTree>
+  </p:cSld>
+  <p:clrMapOvr>
+    <a:masterClrMapping/>
+  </p:clrMapOvr>
+</p:notes>
+</file>
+
+<file path=ppt/notesSlides/notesSlide4.xml><?xml version="1.0" encoding="utf-8"?>
+<p:notes xmlns:a="http://schemas.openxmlformats.org/drawingml/2006/main" xmlns:p="http://schemas.openxmlformats.org/presentationml/2006/main" xmlns:r="http://schemas.openxmlformats.org/officeDocument/2006/relationships">
+  <p:cSld>
+    <p:spTree>
+      <p:nvGrpSpPr>
+        <p:cNvPr id="1" name=""/>
+        <p:cNvGrpSpPr/>
+        <p:nvPr/>
+      </p:nvGrpSpPr>
+      <p:grpSpPr>
+        <a:xfrm>
+          <a:off x="0" y="0"/>
+          <a:ext cx="0" cy="0"/>
+          <a:chOff x="0" y="0"/>
+          <a:chExt cx="0" cy="0"/>
+        </a:xfrm>
+      </p:grpSpPr>
+      <p:sp>
+        <p:nvSpPr>
+          <p:cNvPr id="2" name="Slide Image Placeholder 1"/>
+          <p:cNvSpPr>
+            <a:spLocks noGrp="1"/>
+          </p:cNvSpPr>
+          <p:nvPr>
+            <p:ph type="sldImg" idx="2"/>
+          </p:nvPr>
+        </p:nvSpPr>
+        <p:spPr/>
+      </p:sp>
+      <p:sp>
+        <p:nvSpPr>
+          <p:cNvPr id="3" name="Notes Placeholder 2"/>
+          <p:cNvSpPr>
+            <a:spLocks noGrp="1"/>
+          </p:cNvSpPr>
+          <p:nvPr>
+            <p:ph type="body" idx="3" sz="quarter"/>
+          </p:nvPr>
+        </p:nvSpPr>
+        <p:spPr/>
+        <p:txBody>
+          <a:bodyPr/>
+          <a:lstStyle/>
+          <a:p>
+            <a:r>
+              <a:t>Pi side. PiLinkServer receives each request and calls HwTrackController, which scans every Wayside. Each statement is compiled twice and run on two channels; the vital block runs after the user's program (planned). interface.py and wire.py are used on both sides.</a:t>
+            </a:r>
+          </a:p>
+        </p:txBody>
+      </p:sp>
+      <p:sp>
+        <p:nvSpPr>
+          <p:cNvPr id="4" name="Slide Number Placeholder 3"/>
+          <p:cNvSpPr>
+            <a:spLocks noGrp="1"/>
+          </p:cNvSpPr>
+          <p:nvPr>
+            <p:ph type="sldNum" idx="5" sz="quarter"/>
+          </p:nvPr>
+        </p:nvSpPr>
+        <p:spPr/>
+      </p:sp>
+    </p:spTree>
+  </p:cSld>
+  <p:clrMapOvr>
+    <a:masterClrMapping/>
+  </p:clrMapOvr>
+</p:notes>
+</file>
+
+<file path=ppt/notesSlides/notesSlide5.xml><?xml version="1.0" encoding="utf-8"?>
+<p:notes xmlns:a="http://schemas.openxmlformats.org/drawingml/2006/main" xmlns:p="http://schemas.openxmlformats.org/presentationml/2006/main" xmlns:r="http://schemas.openxmlformats.org/officeDocument/2006/relationships">
+  <p:cSld>
+    <p:spTree>
+      <p:nvGrpSpPr>
+        <p:cNvPr id="1" name=""/>
+        <p:cNvGrpSpPr/>
+        <p:nvPr/>
+      </p:nvGrpSpPr>
+      <p:grpSpPr>
+        <a:xfrm>
+          <a:off x="0" y="0"/>
+          <a:ext cx="0" cy="0"/>
+          <a:chOff x="0" y="0"/>
+          <a:chExt cx="0" cy="0"/>
+        </a:xfrm>
+      </p:grpSpPr>
+      <p:sp>
+        <p:nvSpPr>
+          <p:cNvPr id="2" name="Slide Image Placeholder 1"/>
+          <p:cNvSpPr>
+            <a:spLocks noGrp="1"/>
+          </p:cNvSpPr>
+          <p:nvPr>
+            <p:ph type="sldImg" idx="2"/>
+          </p:nvPr>
+        </p:nvSpPr>
+        <p:spPr/>
+      </p:sp>
+      <p:sp>
+        <p:nvSpPr>
+          <p:cNvPr id="3" name="Notes Placeholder 2"/>
+          <p:cNvSpPr>
+            <a:spLocks noGrp="1"/>
+          </p:cNvSpPr>
+          <p:nvPr>
+            <p:ph type="body" idx="3" sz="quarter"/>
+          </p:nvPr>
+        </p:nvSpPr>
+        <p:spPr/>
+        <p:txBody>
+          <a:bodyPr/>
+          <a:lstStyle/>
+          <a:p>
+            <a:r>
+              <a:t>HwTrackController implements the TrackController Protocol and owns one Wayside per database, all on one line. Wayside.scan builds the input image, runs the programs, compares the channels, drives the outputs and builds the CTC report. Every error derives from TrackControllerError. PiLinkServer is planned.</a:t>
+            </a:r>
+          </a:p>
+        </p:txBody>
+      </p:sp>
+      <p:sp>
+        <p:nvSpPr>
+          <p:cNvPr id="4" name="Slide Number Placeholder 3"/>
+          <p:cNvSpPr>
+            <a:spLocks noGrp="1"/>
+          </p:cNvSpPr>
+          <p:nvPr>
+            <p:ph type="sldNum" idx="5" sz="quarter"/>
+          </p:nvPr>
+        </p:nvSpPr>
+        <p:spPr/>
+      </p:sp>
+    </p:spTree>
+  </p:cSld>
+  <p:clrMapOvr>
+    <a:masterClrMapping/>
+  </p:clrMapOvr>
+</p:notes>
+</file>
+
+<file path=ppt/notesSlides/notesSlide6.xml><?xml version="1.0" encoding="utf-8"?>
+<p:notes xmlns:a="http://schemas.openxmlformats.org/drawingml/2006/main" xmlns:p="http://schemas.openxmlformats.org/presentationml/2006/main" xmlns:r="http://schemas.openxmlformats.org/officeDocument/2006/relationships">
+  <p:cSld>
+    <p:spTree>
+      <p:nvGrpSpPr>
+        <p:cNvPr id="1" name=""/>
+        <p:cNvGrpSpPr/>
+        <p:nvPr/>
+      </p:nvGrpSpPr>
+      <p:grpSpPr>
+        <a:xfrm>
+          <a:off x="0" y="0"/>
+          <a:ext cx="0" cy="0"/>
+          <a:chOff x="0" y="0"/>
+          <a:chExt cx="0" cy="0"/>
+        </a:xfrm>
+      </p:grpSpPr>
+      <p:sp>
+        <p:nvSpPr>
+          <p:cNvPr id="2" name="Slide Image Placeholder 1"/>
+          <p:cNvSpPr>
+            <a:spLocks noGrp="1"/>
+          </p:cNvSpPr>
+          <p:nvPr>
+            <p:ph type="sldImg" idx="2"/>
+          </p:nvPr>
+        </p:nvSpPr>
+        <p:spPr/>
+      </p:sp>
+      <p:sp>
+        <p:nvSpPr>
+          <p:cNvPr id="3" name="Notes Placeholder 2"/>
+          <p:cNvSpPr>
+            <a:spLocks noGrp="1"/>
+          </p:cNvSpPr>
+          <p:nvPr>
+            <p:ph type="body" idx="3" sz="quarter"/>
+          </p:nvPr>
+        </p:nvSpPr>
+        <p:spPr/>
+        <p:txBody>
+          <a:bodyPr/>
+          <a:lstStyle/>
+          <a:p>
+            <a:r>
+              <a:t>compile_program turns source into an immutable Program. Each Statement holds a tree (channel A) and postfix code (channel B); scan_a and scan_b must agree. check_program verifies every name against the wayside's I/O. vital_source (planned) generates the read-only block.</a:t>
+            </a:r>
+          </a:p>
+        </p:txBody>
+      </p:sp>
+      <p:sp>
+        <p:nvSpPr>
+          <p:cNvPr id="4" name="Slide Number Placeholder 3"/>
+          <p:cNvSpPr>
+            <a:spLocks noGrp="1"/>
+          </p:cNvSpPr>
+          <p:nvPr>
+            <p:ph type="sldNum" idx="5" sz="quarter"/>
+          </p:nvPr>
+        </p:nvSpPr>
+        <p:spPr/>
+      </p:sp>
+    </p:spTree>
+  </p:cSld>
+  <p:clrMapOvr>
+    <a:masterClrMapping/>
+  </p:clrMapOvr>
+</p:notes>
+</file>
+
+<file path=ppt/notesSlides/notesSlide7.xml><?xml version="1.0" encoding="utf-8"?>
+<p:notes xmlns:a="http://schemas.openxmlformats.org/drawingml/2006/main" xmlns:p="http://schemas.openxmlformats.org/presentationml/2006/main" xmlns:r="http://schemas.openxmlformats.org/officeDocument/2006/relationships">
+  <p:cSld>
+    <p:spTree>
+      <p:nvGrpSpPr>
+        <p:cNvPr id="1" name=""/>
+        <p:cNvGrpSpPr/>
+        <p:nvPr/>
+      </p:nvGrpSpPr>
+      <p:grpSpPr>
+        <a:xfrm>
+          <a:off x="0" y="0"/>
+          <a:ext cx="0" cy="0"/>
+          <a:chOff x="0" y="0"/>
+          <a:chExt cx="0" cy="0"/>
+        </a:xfrm>
+      </p:grpSpPr>
+      <p:sp>
+        <p:nvSpPr>
+          <p:cNvPr id="2" name="Slide Image Placeholder 1"/>
+          <p:cNvSpPr>
+            <a:spLocks noGrp="1"/>
+          </p:cNvSpPr>
+          <p:nvPr>
+            <p:ph type="sldImg" idx="2"/>
+          </p:nvPr>
+        </p:nvSpPr>
+        <p:spPr/>
+      </p:sp>
+      <p:sp>
+        <p:nvSpPr>
+          <p:cNvPr id="3" name="Notes Placeholder 2"/>
+          <p:cNvSpPr>
+            <a:spLocks noGrp="1"/>
+          </p:cNvSpPr>
+          <p:nvPr>
+            <p:ph type="body" idx="3" sz="quarter"/>
+          </p:nvPr>
+        </p:nvSpPr>
+        <p:spPr/>
+        <p:txBody>
+          <a:bodyPr/>
+          <a:lstStyle/>
+          <a:p>
+            <a:r>
+              <a:t>What crosses the boundary each tick. In: from the CTC Office closures, maintenance switch commands and per-block suggestions; from the Track Model occupancy and read-back. Out: track circuits and switch, signal and crossing commands to the Track Model; one CtcReport per wayside. The CTC keys blocks by BlockRef, the Track Model by BlockKey.</a:t>
+            </a:r>
+          </a:p>
+        </p:txBody>
+      </p:sp>
+      <p:sp>
+        <p:nvSpPr>
+          <p:cNvPr id="4" name="Slide Number Placeholder 3"/>
+          <p:cNvSpPr>
+            <a:spLocks noGrp="1"/>
+          </p:cNvSpPr>
+          <p:nvPr>
+            <p:ph type="sldNum" idx="5" sz="quarter"/>
+          </p:nvPr>
+        </p:nvSpPr>
+        <p:spPr/>
+      </p:sp>
+    </p:spTree>
+  </p:cSld>
+  <p:clrMapOvr>
+    <a:masterClrMapping/>
+  </p:clrMapOvr>
+</p:notes>
+</file>
+
+<file path=ppt/notesSlides/notesSlide8.xml><?xml version="1.0" encoding="utf-8"?>
+<p:notes xmlns:a="http://schemas.openxmlformats.org/drawingml/2006/main" xmlns:p="http://schemas.openxmlformats.org/presentationml/2006/main" xmlns:r="http://schemas.openxmlformats.org/officeDocument/2006/relationships">
+  <p:cSld>
+    <p:spTree>
+      <p:nvGrpSpPr>
+        <p:cNvPr id="1" name=""/>
+        <p:cNvGrpSpPr/>
+        <p:nvPr/>
+      </p:nvGrpSpPr>
+      <p:grpSpPr>
+        <a:xfrm>
+          <a:off x="0" y="0"/>
+          <a:ext cx="0" cy="0"/>
+          <a:chOff x="0" y="0"/>
+          <a:chExt cx="0" cy="0"/>
+        </a:xfrm>
+      </p:grpSpPr>
+      <p:sp>
+        <p:nvSpPr>
+          <p:cNvPr id="2" name="Slide Image Placeholder 1"/>
+          <p:cNvSpPr>
+            <a:spLocks noGrp="1"/>
+          </p:cNvSpPr>
+          <p:nvPr>
+            <p:ph type="sldImg" idx="2"/>
+          </p:nvPr>
+        </p:nvSpPr>
+        <p:spPr/>
+      </p:sp>
+      <p:sp>
+        <p:nvSpPr>
+          <p:cNvPr id="3" name="Notes Placeholder 2"/>
+          <p:cNvSpPr>
+            <a:spLocks noGrp="1"/>
+          </p:cNvSpPr>
+          <p:nvPr>
+            <p:ph type="body" idx="3" sz="quarter"/>
+          </p:nvPr>
+        </p:nvSpPr>
+        <p:spPr/>
+        <p:txBody>
+          <a:bodyPr/>
+          <a:lstStyle/>
+          <a:p>
+            <a:r>
+              <a:t>A wayside's territory, from its database: blocks with length and speed limit, switches (point, normal and reverse ends), crossings. BlockKey is line, section, number; BlockRef is line and number, the CTC's form (Red:15).</a:t>
+            </a:r>
+          </a:p>
+        </p:txBody>
+      </p:sp>
+      <p:sp>
+        <p:nvSpPr>
+          <p:cNvPr id="4" name="Slide Number Placeholder 3"/>
+          <p:cNvSpPr>
+            <a:spLocks noGrp="1"/>
+          </p:cNvSpPr>
+          <p:nvPr>
+            <p:ph type="sldNum" idx="5" sz="quarter"/>
+          </p:nvPr>
+        </p:nvSpPr>
+        <p:spPr/>
+      </p:sp>
+    </p:spTree>
+  </p:cSld>
+  <p:clrMapOvr>
+    <a:masterClrMapping/>
+  </p:clrMapOvr>
+</p:notes>
+</file>
+
+<file path=ppt/notesSlides/notesSlide9.xml><?xml version="1.0" encoding="utf-8"?>
+<p:notes xmlns:a="http://schemas.openxmlformats.org/drawingml/2006/main" xmlns:p="http://schemas.openxmlformats.org/presentationml/2006/main" xmlns:r="http://schemas.openxmlformats.org/officeDocument/2006/relationships">
+  <p:cSld>
+    <p:spTree>
+      <p:nvGrpSpPr>
+        <p:cNvPr id="1" name=""/>
+        <p:cNvGrpSpPr/>
+        <p:nvPr/>
+      </p:nvGrpSpPr>
+      <p:grpSpPr>
+        <a:xfrm>
+          <a:off x="0" y="0"/>
+          <a:ext cx="0" cy="0"/>
+          <a:chOff x="0" y="0"/>
+          <a:chExt cx="0" cy="0"/>
+        </a:xfrm>
+      </p:grpSpPr>
+      <p:sp>
+        <p:nvSpPr>
+          <p:cNvPr id="2" name="Slide Image Placeholder 1"/>
+          <p:cNvSpPr>
+            <a:spLocks noGrp="1"/>
+          </p:cNvSpPr>
+          <p:nvPr>
+            <p:ph type="sldImg" idx="2"/>
+          </p:nvPr>
+        </p:nvSpPr>
+        <p:spPr/>
+      </p:sp>
+      <p:sp>
+        <p:nvSpPr>
+          <p:cNvPr id="3" name="Notes Placeholder 2"/>
+          <p:cNvSpPr>
+            <a:spLocks noGrp="1"/>
+          </p:cNvSpPr>
+          <p:nvPr>
+            <p:ph type="body" idx="3" sz="quarter"/>
+          </p:nvPr>
+        </p:nvSpPr>
+        <p:spPr/>
+        <p:txBody>
+          <a:bodyPr/>
+          <a:lstStyle/>
+          <a:p>
+            <a:r>
+              <a:t>Read-only state for the window, from snapshot(), with no side effects: per wayside its program, scan health (scans, overruns, channel agreement), switch states and last report.</a:t>
+            </a:r>
+          </a:p>
+        </p:txBody>
+      </p:sp>
+      <p:sp>
+        <p:nvSpPr>
+          <p:cNvPr id="4" name="Slide Number Placeholder 3"/>
+          <p:cNvSpPr>
+            <a:spLocks noGrp="1"/>
+          </p:cNvSpPr>
+          <p:nvPr>
+            <p:ph type="sldNum" idx="5" sz="quarter"/>
+          </p:nvPr>
+        </p:nvSpPr>
+        <p:spPr/>
+      </p:sp>
+    </p:spTree>
+  </p:cSld>
+  <p:clrMapOvr>
+    <a:masterClrMapping/>
+  </p:clrMapOvr>
+</p:notes>
 </file>
 
 <file path=ppt/slideLayouts/slideLayout1.xml><?xml version="1.0" encoding="utf-8"?>
@@ -3483,7 +5233,7 @@
           <p:nvPr/>
         </p:nvPicPr>
         <p:blipFill>
-          <a:blip r:embed="rId2"/>
+          <a:blip r:embed="rId3"/>
           <a:stretch>
             <a:fillRect/>
           </a:stretch>
@@ -4183,7 +5933,7 @@
           <p:nvPr/>
         </p:nvPicPr>
         <p:blipFill>
-          <a:blip r:embed="rId2"/>
+          <a:blip r:embed="rId3"/>
           <a:stretch>
             <a:fillRect/>
           </a:stretch>
@@ -4408,7 +6158,7 @@
           <p:nvPr/>
         </p:nvPicPr>
         <p:blipFill>
-          <a:blip r:embed="rId2"/>
+          <a:blip r:embed="rId3"/>
           <a:stretch>
             <a:fillRect/>
           </a:stretch>
@@ -4598,7 +6348,7 @@
           <p:nvPr/>
         </p:nvPicPr>
         <p:blipFill>
-          <a:blip r:embed="rId2"/>
+          <a:blip r:embed="rId3"/>
           <a:stretch>
             <a:fillRect/>
           </a:stretch>
@@ -4788,7 +6538,7 @@
           <p:nvPr/>
         </p:nvPicPr>
         <p:blipFill>
-          <a:blip r:embed="rId2"/>
+          <a:blip r:embed="rId3"/>
           <a:stretch>
             <a:fillRect/>
           </a:stretch>
@@ -4978,7 +6728,7 @@
           <p:nvPr/>
         </p:nvPicPr>
         <p:blipFill>
-          <a:blip r:embed="rId2"/>
+          <a:blip r:embed="rId3"/>
           <a:stretch>
             <a:fillRect/>
           </a:stretch>
@@ -5203,7 +6953,7 @@
           <p:nvPr/>
         </p:nvPicPr>
         <p:blipFill>
-          <a:blip r:embed="rId2"/>
+          <a:blip r:embed="rId3"/>
           <a:stretch>
             <a:fillRect/>
           </a:stretch>
@@ -5463,7 +7213,7 @@
           <p:nvPr/>
         </p:nvPicPr>
         <p:blipFill>
-          <a:blip r:embed="rId2"/>
+          <a:blip r:embed="rId3"/>
           <a:stretch>
             <a:fillRect/>
           </a:stretch>
@@ -6001,7 +7751,7 @@
           <p:nvPr/>
         </p:nvPicPr>
         <p:blipFill>
-          <a:blip r:embed="rId2"/>
+          <a:blip r:embed="rId3"/>
           <a:stretch>
             <a:fillRect/>
           </a:stretch>
@@ -6226,7 +7976,7 @@
           <p:nvPr/>
         </p:nvPicPr>
         <p:blipFill>
-          <a:blip r:embed="rId2"/>
+          <a:blip r:embed="rId3"/>
           <a:stretch>
             <a:fillRect/>
           </a:stretch>
@@ -6451,7 +8201,7 @@
           <p:nvPr/>
         </p:nvPicPr>
         <p:blipFill>
-          <a:blip r:embed="rId2"/>
+          <a:blip r:embed="rId3"/>
           <a:stretch>
             <a:fillRect/>
           </a:stretch>
@@ -6676,7 +8426,7 @@
           <p:nvPr/>
         </p:nvPicPr>
         <p:blipFill>
-          <a:blip r:embed="rId2"/>
+          <a:blip r:embed="rId3"/>
           <a:stretch>
             <a:fillRect/>
           </a:stretch>
@@ -6901,7 +8651,7 @@
           <p:nvPr/>
         </p:nvPicPr>
         <p:blipFill>
-          <a:blip r:embed="rId2"/>
+          <a:blip r:embed="rId3"/>
           <a:stretch>
             <a:fillRect/>
           </a:stretch>
@@ -7126,7 +8876,7 @@
           <p:nvPr/>
         </p:nvPicPr>
         <p:blipFill>
-          <a:blip r:embed="rId2"/>
+          <a:blip r:embed="rId3"/>
           <a:stretch>
             <a:fillRect/>
           </a:stretch>
@@ -7351,7 +9101,7 @@
           <p:nvPr/>
         </p:nvPicPr>
         <p:blipFill>
-          <a:blip r:embed="rId2"/>
+          <a:blip r:embed="rId3"/>
           <a:stretch>
             <a:fillRect/>
           </a:stretch>
@@ -7576,7 +9326,7 @@
           <p:nvPr/>
         </p:nvPicPr>
         <p:blipFill>
-          <a:blip r:embed="rId2"/>
+          <a:blip r:embed="rId3"/>
           <a:stretch>
             <a:fillRect/>
           </a:stretch>
@@ -8276,7 +10026,7 @@
           <p:nvPr/>
         </p:nvPicPr>
         <p:blipFill>
-          <a:blip r:embed="rId2"/>
+          <a:blip r:embed="rId3"/>
           <a:stretch>
             <a:fillRect/>
           </a:stretch>
@@ -12910,7 +14660,7 @@
           <p:nvPr/>
         </p:nvPicPr>
         <p:blipFill>
-          <a:blip r:embed="rId2"/>
+          <a:blip r:embed="rId3"/>
           <a:stretch>
             <a:fillRect/>
           </a:stretch>
@@ -13309,7 +15059,7 @@
           <p:nvPr/>
         </p:nvPicPr>
         <p:blipFill>
-          <a:blip r:embed="rId2"/>
+          <a:blip r:embed="rId3"/>
           <a:stretch>
             <a:fillRect/>
           </a:stretch>
@@ -13534,7 +15284,7 @@
           <p:nvPr/>
         </p:nvPicPr>
         <p:blipFill>
-          <a:blip r:embed="rId2"/>
+          <a:blip r:embed="rId3"/>
           <a:stretch>
             <a:fillRect/>
           </a:stretch>
@@ -13875,4 +15625,324 @@
   </a:objectDefaults>
   <a:extraClrSchemeLst/>
 </a:theme>
+</file>
+
+<file path=ppt/theme/theme2.xml><?xml version="1.0" encoding="utf-8"?>
+<a:theme xmlns:a="http://schemas.openxmlformats.org/drawingml/2006/main" name="Office Theme">
+  <a:themeElements>
+    <a:clrScheme name="Office">
+      <a:dk1>
+        <a:sysClr val="windowText" lastClr="000000"/>
+      </a:dk1>
+      <a:lt1>
+        <a:sysClr val="window" lastClr="FFFFFF"/>
+      </a:lt1>
+      <a:dk2>
+        <a:srgbClr val="1F497D"/>
+      </a:dk2>
+      <a:lt2>
+        <a:srgbClr val="EEECE1"/>
+      </a:lt2>
+      <a:accent1>
+        <a:srgbClr val="4F81BD"/>
+      </a:accent1>
+      <a:accent2>
+        <a:srgbClr val="C0504D"/>
+      </a:accent2>
+      <a:accent3>
+        <a:srgbClr val="9BBB59"/>
+      </a:accent3>
+      <a:accent4>
+        <a:srgbClr val="8064A2"/>
+      </a:accent4>
+      <a:accent5>
+        <a:srgbClr val="4BACC6"/>
+      </a:accent5>
+      <a:accent6>
+        <a:srgbClr val="F79646"/>
+      </a:accent6>
+      <a:hlink>
+        <a:srgbClr val="0000FF"/>
+      </a:hlink>
+      <a:folHlink>
+        <a:srgbClr val="800080"/>
+      </a:folHlink>
+    </a:clrScheme>
+    <a:fontScheme name="Office">
+      <a:majorFont>
+        <a:latin typeface="Calibri"/>
+        <a:ea typeface=""/>
+        <a:cs typeface=""/>
+        <a:font script="Jpan" typeface="ＭＳ Ｐゴシック"/>
+        <a:font script="Hang" typeface="맑은 고딕"/>
+        <a:font script="Hans" typeface="宋体"/>
+        <a:font script="Hant" typeface="新細明體"/>
+        <a:font script="Arab" typeface="Times New Roman"/>
+        <a:font script="Hebr" typeface="Times New Roman"/>
+        <a:font script="Thai" typeface="Angsana New"/>
+        <a:font script="Ethi" typeface="Nyala"/>
+        <a:font script="Beng" typeface="Vrinda"/>
+        <a:font script="Gujr" typeface="Shruti"/>
+        <a:font script="Khmr" typeface="MoolBoran"/>
+        <a:font script="Knda" typeface="Tunga"/>
+        <a:font script="Guru" typeface="Raavi"/>
+        <a:font script="Cans" typeface="Euphemia"/>
+        <a:font script="Cher" typeface="Plantagenet Cherokee"/>
+        <a:font script="Yiii" typeface="Microsoft Yi Baiti"/>
+        <a:font script="Tibt" typeface="Microsoft Himalaya"/>
+        <a:font script="Thaa" typeface="MV Boli"/>
+        <a:font script="Deva" typeface="Mangal"/>
+        <a:font script="Telu" typeface="Gautami"/>
+        <a:font script="Taml" typeface="Latha"/>
+        <a:font script="Syrc" typeface="Estrangelo Edessa"/>
+        <a:font script="Orya" typeface="Kalinga"/>
+        <a:font script="Mlym" typeface="Kartika"/>
+        <a:font script="Laoo" typeface="DokChampa"/>
+        <a:font script="Sinh" typeface="Iskoola Pota"/>
+        <a:font script="Mong" typeface="Mongolian Baiti"/>
+        <a:font script="Viet" typeface="Times New Roman"/>
+        <a:font script="Uigh" typeface="Microsoft Uighur"/>
+        <a:font script="Geor" typeface="Sylfaen"/>
+      </a:majorFont>
+      <a:minorFont>
+        <a:latin typeface="Calibri"/>
+        <a:ea typeface=""/>
+        <a:cs typeface=""/>
+        <a:font script="Jpan" typeface="ＭＳ Ｐゴシック"/>
+        <a:font script="Hang" typeface="맑은 고딕"/>
+        <a:font script="Hans" typeface="宋体"/>
+        <a:font script="Hant" typeface="新細明體"/>
+        <a:font script="Arab" typeface="Arial"/>
+        <a:font script="Hebr" typeface="Arial"/>
+        <a:font script="Thai" typeface="Cordia New"/>
+        <a:font script="Ethi" typeface="Nyala"/>
+        <a:font script="Beng" typeface="Vrinda"/>
+        <a:font script="Gujr" typeface="Shruti"/>
+        <a:font script="Khmr" typeface="DaunPenh"/>
+        <a:font script="Knda" typeface="Tunga"/>
+        <a:font script="Guru" typeface="Raavi"/>
+        <a:font script="Cans" typeface="Euphemia"/>
+        <a:font script="Cher" typeface="Plantagenet Cherokee"/>
+        <a:font script="Yiii" typeface="Microsoft Yi Baiti"/>
+        <a:font script="Tibt" typeface="Microsoft Himalaya"/>
+        <a:font script="Thaa" typeface="MV Boli"/>
+        <a:font script="Deva" typeface="Mangal"/>
+        <a:font script="Telu" typeface="Gautami"/>
+        <a:font script="Taml" typeface="Latha"/>
+        <a:font script="Syrc" typeface="Estrangelo Edessa"/>
+        <a:font script="Orya" typeface="Kalinga"/>
+        <a:font script="Mlym" typeface="Kartika"/>
+        <a:font script="Laoo" typeface="DokChampa"/>
+        <a:font script="Sinh" typeface="Iskoola Pota"/>
+        <a:font script="Mong" typeface="Mongolian Baiti"/>
+        <a:font script="Viet" typeface="Arial"/>
+        <a:font script="Uigh" typeface="Microsoft Uighur"/>
+        <a:font script="Geor" typeface="Sylfaen"/>
+      </a:minorFont>
+    </a:fontScheme>
+    <a:fmtScheme name="Office">
+      <a:fillStyleLst>
+        <a:solidFill>
+          <a:schemeClr val="phClr"/>
+        </a:solidFill>
+        <a:gradFill rotWithShape="1">
+          <a:gsLst>
+            <a:gs pos="0">
+              <a:schemeClr val="phClr">
+                <a:tint val="50000"/>
+                <a:satMod val="300000"/>
+              </a:schemeClr>
+            </a:gs>
+            <a:gs pos="35000">
+              <a:schemeClr val="phClr">
+                <a:tint val="37000"/>
+                <a:satMod val="300000"/>
+              </a:schemeClr>
+            </a:gs>
+            <a:gs pos="100000">
+              <a:schemeClr val="phClr">
+                <a:tint val="15000"/>
+                <a:satMod val="350000"/>
+              </a:schemeClr>
+            </a:gs>
+          </a:gsLst>
+          <a:lin ang="16200000" scaled="1"/>
+        </a:gradFill>
+        <a:gradFill rotWithShape="1">
+          <a:gsLst>
+            <a:gs pos="0">
+              <a:schemeClr val="phClr">
+                <a:tint val="100000"/>
+                <a:shade val="100000"/>
+                <a:satMod val="130000"/>
+              </a:schemeClr>
+            </a:gs>
+            <a:gs pos="100000">
+              <a:schemeClr val="phClr">
+                <a:tint val="50000"/>
+                <a:shade val="100000"/>
+                <a:satMod val="350000"/>
+              </a:schemeClr>
+            </a:gs>
+          </a:gsLst>
+          <a:lin ang="16200000" scaled="0"/>
+        </a:gradFill>
+      </a:fillStyleLst>
+      <a:lnStyleLst>
+        <a:ln w="9525" cap="flat" cmpd="sng" algn="ctr">
+          <a:solidFill>
+            <a:schemeClr val="phClr">
+              <a:shade val="95000"/>
+              <a:satMod val="105000"/>
+            </a:schemeClr>
+          </a:solidFill>
+          <a:prstDash val="solid"/>
+        </a:ln>
+        <a:ln w="25400" cap="flat" cmpd="sng" algn="ctr">
+          <a:solidFill>
+            <a:schemeClr val="phClr"/>
+          </a:solidFill>
+          <a:prstDash val="solid"/>
+        </a:ln>
+        <a:ln w="38100" cap="flat" cmpd="sng" algn="ctr">
+          <a:solidFill>
+            <a:schemeClr val="phClr"/>
+          </a:solidFill>
+          <a:prstDash val="solid"/>
+        </a:ln>
+      </a:lnStyleLst>
+      <a:effectStyleLst>
+        <a:effectStyle>
+          <a:effectLst>
+            <a:outerShdw blurRad="40000" dist="20000" dir="5400000" rotWithShape="0">
+              <a:srgbClr val="000000">
+                <a:alpha val="38000"/>
+              </a:srgbClr>
+            </a:outerShdw>
+          </a:effectLst>
+        </a:effectStyle>
+        <a:effectStyle>
+          <a:effectLst>
+            <a:outerShdw blurRad="40000" dist="23000" dir="5400000" rotWithShape="0">
+              <a:srgbClr val="000000">
+                <a:alpha val="35000"/>
+              </a:srgbClr>
+            </a:outerShdw>
+          </a:effectLst>
+        </a:effectStyle>
+        <a:effectStyle>
+          <a:effectLst>
+            <a:outerShdw blurRad="40000" dist="23000" dir="5400000" rotWithShape="0">
+              <a:srgbClr val="000000">
+                <a:alpha val="35000"/>
+              </a:srgbClr>
+            </a:outerShdw>
+          </a:effectLst>
+          <a:scene3d>
+            <a:camera prst="orthographicFront">
+              <a:rot lat="0" lon="0" rev="0"/>
+            </a:camera>
+            <a:lightRig rig="threePt" dir="t">
+              <a:rot lat="0" lon="0" rev="1200000"/>
+            </a:lightRig>
+          </a:scene3d>
+          <a:sp3d>
+            <a:bevelT w="63500" h="25400"/>
+          </a:sp3d>
+        </a:effectStyle>
+      </a:effectStyleLst>
+      <a:bgFillStyleLst>
+        <a:solidFill>
+          <a:schemeClr val="phClr"/>
+        </a:solidFill>
+        <a:gradFill rotWithShape="1">
+          <a:gsLst>
+            <a:gs pos="0">
+              <a:schemeClr val="phClr">
+                <a:tint val="40000"/>
+                <a:satMod val="350000"/>
+              </a:schemeClr>
+            </a:gs>
+            <a:gs pos="40000">
+              <a:schemeClr val="phClr">
+                <a:tint val="45000"/>
+                <a:shade val="99000"/>
+                <a:satMod val="350000"/>
+              </a:schemeClr>
+            </a:gs>
+            <a:gs pos="100000">
+              <a:schemeClr val="phClr">
+                <a:shade val="20000"/>
+                <a:satMod val="255000"/>
+              </a:schemeClr>
+            </a:gs>
+          </a:gsLst>
+          <a:path path="circle">
+            <a:fillToRect l="50000" t="-80000" r="50000" b="180000"/>
+          </a:path>
+        </a:gradFill>
+        <a:gradFill rotWithShape="1">
+          <a:gsLst>
+            <a:gs pos="0">
+              <a:schemeClr val="phClr">
+                <a:tint val="80000"/>
+                <a:satMod val="300000"/>
+              </a:schemeClr>
+            </a:gs>
+            <a:gs pos="100000">
+              <a:schemeClr val="phClr">
+                <a:shade val="30000"/>
+                <a:satMod val="200000"/>
+              </a:schemeClr>
+            </a:gs>
+          </a:gsLst>
+          <a:path path="circle">
+            <a:fillToRect l="50000" t="50000" r="50000" b="50000"/>
+          </a:path>
+        </a:gradFill>
+      </a:bgFillStyleLst>
+    </a:fmtScheme>
+  </a:themeElements>
+  <a:objectDefaults>
+    <a:spDef>
+      <a:spPr/>
+      <a:bodyPr/>
+      <a:lstStyle/>
+      <a:style>
+        <a:lnRef idx="1">
+          <a:schemeClr val="accent1"/>
+        </a:lnRef>
+        <a:fillRef idx="3">
+          <a:schemeClr val="accent1"/>
+        </a:fillRef>
+        <a:effectRef idx="2">
+          <a:schemeClr val="accent1"/>
+        </a:effectRef>
+        <a:fontRef idx="minor">
+          <a:schemeClr val="lt1"/>
+        </a:fontRef>
+      </a:style>
+    </a:spDef>
+    <a:lnDef>
+      <a:spPr/>
+      <a:bodyPr/>
+      <a:lstStyle/>
+      <a:style>
+        <a:lnRef idx="2">
+          <a:schemeClr val="accent1"/>
+        </a:lnRef>
+        <a:fillRef idx="0">
+          <a:schemeClr val="accent1"/>
+        </a:fillRef>
+        <a:effectRef idx="1">
+          <a:schemeClr val="accent1"/>
+        </a:effectRef>
+        <a:fontRef idx="minor">
+          <a:schemeClr val="tx1"/>
+        </a:fontRef>
+      </a:style>
+    </a:lnDef>
+  </a:objectDefaults>
+  <a:extraClrSchemeLst/>
+</a:theme>
 </file>
</xml_diff>

<commit_message>
Design review deck: split SD-05, SD-01 and SD-02 across two slides; narrow SD-02
</commit_message>
<xml_diff>
--- a/documents/slides/design_review_track_ctrl_hw.pptx
+++ b/documents/slides/design_review_track_ctrl_hw.pptx
@@ -43,6 +43,9 @@
     <p:sldId id="291" r:id="rId43"/>
     <p:sldId id="292" r:id="rId44"/>
     <p:sldId id="293" r:id="rId45"/>
+    <p:sldId id="294" r:id="rId46"/>
+    <p:sldId id="295" r:id="rId47"/>
+    <p:sldId id="296" r:id="rId48"/>
   </p:sldIdLst>
   <p:sldSz cx="12191695" cy="6858000" type="screen4x3"/>
   <p:notesSz cx="6858000" cy="9144000"/>
@@ -819,7 +822,7 @@
           <a:lstStyle/>
           <a:p>
             <a:r>
-              <a:t>One wayside's scan. It holds fail-safe if any wayside is not ready, it has no program, or a channel fault is latched. Otherwise: build the input image, run the user program on channels A and B, compare, run the vital block the same way (planned), then drive the outputs. The CTC report is built every scan.</a:t>
+              <a:t>One tick: the harness maps the CTC Office's and Track Model's previous outputs into this module's inputs; the PC relays the step to the Pi; every wayside scans; the outputs go back. An invalid input rejects the whole tick. At 10x, USB round trip plus scan must stay under 10 ms.</a:t>
             </a:r>
           </a:p>
         </p:txBody>
@@ -959,7 +962,7 @@
           <a:lstStyle/>
           <a:p>
             <a:r>
-              <a:t>The PC parses the file and rejects a bad one before sending it; the Pi checks the line and that no other wayside owns its blocks. A replaced wayside keeps its program if the program still fits.</a:t>
+              <a:t>One wayside's scan. It holds fail-safe if any wayside is not ready, it has no program, or a channel fault is latched. Otherwise: build the input image, run the user program on channels A and B, compare, run the vital block the same way (planned), then drive the outputs. The CTC report is built every scan.</a:t>
             </a:r>
           </a:p>
         </p:txBody>
@@ -1029,7 +1032,7 @@
           <a:lstStyle/>
           <a:p>
             <a:r>
-              <a:t>Compiled twice and checked against the wayside's I/O, on the Pi. Any error refuses the program and lists every problem with its line number; the old program keeps running. A new program holds fail-safe until its first scan.</a:t>
+              <a:t>The PC parses the file and rejects a bad one before sending it; the Pi checks the line and that no other wayside owns its blocks. A replaced wayside keeps its program if the program still fits.</a:t>
             </a:r>
           </a:p>
         </p:txBody>
@@ -1099,7 +1102,7 @@
           <a:lstStyle/>
           <a:p>
             <a:r>
-              <a:t>The window takes a snapshot, converts it to rows in display units and updates the tables in place. A 100 ms timer refreshes when ticks have advanced. Zoom and Fit are QML only.</a:t>
+              <a:t>The PC parses the file and rejects a bad one before sending it; the Pi checks the line and that no other wayside owns its blocks. A replaced wayside keeps its program if the program still fits.</a:t>
             </a:r>
           </a:p>
         </p:txBody>
@@ -1169,7 +1172,7 @@
           <a:lstStyle/>
           <a:p>
             <a:r>
-              <a:t>Two read-only dialogs over values from the last refresh. New PLC in the details dialog starts SD-02.</a:t>
+              <a:t>Compiled twice and checked against the wayside's I/O, on the Pi. Any error refuses the program and lists every problem with its line number; the old program keeps running. A new program holds fail-safe until its first scan.</a:t>
             </a:r>
           </a:p>
         </p:txBody>
@@ -1239,7 +1242,7 @@
           <a:lstStyle/>
           <a:p>
             <a:r>
-              <a:t>The CTC Office's command reaches the program as the CTCSW and CTCREV inputs; the program obeys unless a train holds the switch. The Track Model's read-back goes into the CTC report. When maintenance ends, the program routes the switch again.</a:t>
+              <a:t>Compiled twice and checked against the wayside's I/O, on the Pi. Any error refuses the program and lists every problem with its line number; the old program keeps running. A new program holds fail-safe until its first scan.</a:t>
             </a:r>
           </a:p>
         </p:txBody>
@@ -1335,6 +1338,216 @@
 </file>
 
 <file path=ppt/notesSlides/notesSlide20.xml><?xml version="1.0" encoding="utf-8"?>
+<p:notes xmlns:a="http://schemas.openxmlformats.org/drawingml/2006/main" xmlns:p="http://schemas.openxmlformats.org/presentationml/2006/main" xmlns:r="http://schemas.openxmlformats.org/officeDocument/2006/relationships">
+  <p:cSld>
+    <p:spTree>
+      <p:nvGrpSpPr>
+        <p:cNvPr id="1" name=""/>
+        <p:cNvGrpSpPr/>
+        <p:nvPr/>
+      </p:nvGrpSpPr>
+      <p:grpSpPr>
+        <a:xfrm>
+          <a:off x="0" y="0"/>
+          <a:ext cx="0" cy="0"/>
+          <a:chOff x="0" y="0"/>
+          <a:chExt cx="0" cy="0"/>
+        </a:xfrm>
+      </p:grpSpPr>
+      <p:sp>
+        <p:nvSpPr>
+          <p:cNvPr id="2" name="Slide Image Placeholder 1"/>
+          <p:cNvSpPr>
+            <a:spLocks noGrp="1"/>
+          </p:cNvSpPr>
+          <p:nvPr>
+            <p:ph type="sldImg" idx="2"/>
+          </p:nvPr>
+        </p:nvSpPr>
+        <p:spPr/>
+      </p:sp>
+      <p:sp>
+        <p:nvSpPr>
+          <p:cNvPr id="3" name="Notes Placeholder 2"/>
+          <p:cNvSpPr>
+            <a:spLocks noGrp="1"/>
+          </p:cNvSpPr>
+          <p:nvPr>
+            <p:ph type="body" idx="3" sz="quarter"/>
+          </p:nvPr>
+        </p:nvSpPr>
+        <p:spPr/>
+        <p:txBody>
+          <a:bodyPr/>
+          <a:lstStyle/>
+          <a:p>
+            <a:r>
+              <a:t>The window takes a snapshot, converts it to rows in display units and updates the tables in place. A 100 ms timer refreshes when ticks have advanced. Zoom and Fit are QML only.</a:t>
+            </a:r>
+          </a:p>
+        </p:txBody>
+      </p:sp>
+      <p:sp>
+        <p:nvSpPr>
+          <p:cNvPr id="4" name="Slide Number Placeholder 3"/>
+          <p:cNvSpPr>
+            <a:spLocks noGrp="1"/>
+          </p:cNvSpPr>
+          <p:nvPr>
+            <p:ph type="sldNum" idx="5" sz="quarter"/>
+          </p:nvPr>
+        </p:nvSpPr>
+        <p:spPr/>
+      </p:sp>
+    </p:spTree>
+  </p:cSld>
+  <p:clrMapOvr>
+    <a:masterClrMapping/>
+  </p:clrMapOvr>
+</p:notes>
+</file>
+
+<file path=ppt/notesSlides/notesSlide21.xml><?xml version="1.0" encoding="utf-8"?>
+<p:notes xmlns:a="http://schemas.openxmlformats.org/drawingml/2006/main" xmlns:p="http://schemas.openxmlformats.org/presentationml/2006/main" xmlns:r="http://schemas.openxmlformats.org/officeDocument/2006/relationships">
+  <p:cSld>
+    <p:spTree>
+      <p:nvGrpSpPr>
+        <p:cNvPr id="1" name=""/>
+        <p:cNvGrpSpPr/>
+        <p:nvPr/>
+      </p:nvGrpSpPr>
+      <p:grpSpPr>
+        <a:xfrm>
+          <a:off x="0" y="0"/>
+          <a:ext cx="0" cy="0"/>
+          <a:chOff x="0" y="0"/>
+          <a:chExt cx="0" cy="0"/>
+        </a:xfrm>
+      </p:grpSpPr>
+      <p:sp>
+        <p:nvSpPr>
+          <p:cNvPr id="2" name="Slide Image Placeholder 1"/>
+          <p:cNvSpPr>
+            <a:spLocks noGrp="1"/>
+          </p:cNvSpPr>
+          <p:nvPr>
+            <p:ph type="sldImg" idx="2"/>
+          </p:nvPr>
+        </p:nvSpPr>
+        <p:spPr/>
+      </p:sp>
+      <p:sp>
+        <p:nvSpPr>
+          <p:cNvPr id="3" name="Notes Placeholder 2"/>
+          <p:cNvSpPr>
+            <a:spLocks noGrp="1"/>
+          </p:cNvSpPr>
+          <p:nvPr>
+            <p:ph type="body" idx="3" sz="quarter"/>
+          </p:nvPr>
+        </p:nvSpPr>
+        <p:spPr/>
+        <p:txBody>
+          <a:bodyPr/>
+          <a:lstStyle/>
+          <a:p>
+            <a:r>
+              <a:t>Two read-only dialogs over values from the last refresh. New PLC in the details dialog starts SD-02.</a:t>
+            </a:r>
+          </a:p>
+        </p:txBody>
+      </p:sp>
+      <p:sp>
+        <p:nvSpPr>
+          <p:cNvPr id="4" name="Slide Number Placeholder 3"/>
+          <p:cNvSpPr>
+            <a:spLocks noGrp="1"/>
+          </p:cNvSpPr>
+          <p:nvPr>
+            <p:ph type="sldNum" idx="5" sz="quarter"/>
+          </p:nvPr>
+        </p:nvSpPr>
+        <p:spPr/>
+      </p:sp>
+    </p:spTree>
+  </p:cSld>
+  <p:clrMapOvr>
+    <a:masterClrMapping/>
+  </p:clrMapOvr>
+</p:notes>
+</file>
+
+<file path=ppt/notesSlides/notesSlide22.xml><?xml version="1.0" encoding="utf-8"?>
+<p:notes xmlns:a="http://schemas.openxmlformats.org/drawingml/2006/main" xmlns:p="http://schemas.openxmlformats.org/presentationml/2006/main" xmlns:r="http://schemas.openxmlformats.org/officeDocument/2006/relationships">
+  <p:cSld>
+    <p:spTree>
+      <p:nvGrpSpPr>
+        <p:cNvPr id="1" name=""/>
+        <p:cNvGrpSpPr/>
+        <p:nvPr/>
+      </p:nvGrpSpPr>
+      <p:grpSpPr>
+        <a:xfrm>
+          <a:off x="0" y="0"/>
+          <a:ext cx="0" cy="0"/>
+          <a:chOff x="0" y="0"/>
+          <a:chExt cx="0" cy="0"/>
+        </a:xfrm>
+      </p:grpSpPr>
+      <p:sp>
+        <p:nvSpPr>
+          <p:cNvPr id="2" name="Slide Image Placeholder 1"/>
+          <p:cNvSpPr>
+            <a:spLocks noGrp="1"/>
+          </p:cNvSpPr>
+          <p:nvPr>
+            <p:ph type="sldImg" idx="2"/>
+          </p:nvPr>
+        </p:nvSpPr>
+        <p:spPr/>
+      </p:sp>
+      <p:sp>
+        <p:nvSpPr>
+          <p:cNvPr id="3" name="Notes Placeholder 2"/>
+          <p:cNvSpPr>
+            <a:spLocks noGrp="1"/>
+          </p:cNvSpPr>
+          <p:nvPr>
+            <p:ph type="body" idx="3" sz="quarter"/>
+          </p:nvPr>
+        </p:nvSpPr>
+        <p:spPr/>
+        <p:txBody>
+          <a:bodyPr/>
+          <a:lstStyle/>
+          <a:p>
+            <a:r>
+              <a:t>The CTC Office's command reaches the program as the CTCSW and CTCREV inputs; the program obeys unless a train holds the switch. The Track Model's read-back goes into the CTC report. When maintenance ends, the program routes the switch again.</a:t>
+            </a:r>
+          </a:p>
+        </p:txBody>
+      </p:sp>
+      <p:sp>
+        <p:nvSpPr>
+          <p:cNvPr id="4" name="Slide Number Placeholder 3"/>
+          <p:cNvSpPr>
+            <a:spLocks noGrp="1"/>
+          </p:cNvSpPr>
+          <p:nvPr>
+            <p:ph type="sldNum" idx="5" sz="quarter"/>
+          </p:nvPr>
+        </p:nvSpPr>
+        <p:spPr/>
+      </p:sp>
+    </p:spTree>
+  </p:cSld>
+  <p:clrMapOvr>
+    <a:masterClrMapping/>
+  </p:clrMapOvr>
+</p:notes>
+</file>
+
+<file path=ppt/notesSlides/notesSlide23.xml><?xml version="1.0" encoding="utf-8"?>
 <p:notes xmlns:a="http://schemas.openxmlformats.org/drawingml/2006/main" xmlns:p="http://schemas.openxmlformats.org/presentationml/2006/main" xmlns:r="http://schemas.openxmlformats.org/officeDocument/2006/relationships">
   <p:cSld>
     <p:spTree>
@@ -7632,7 +7845,7 @@
                 </a:solidFill>
                 <a:latin typeface="Segoe UI"/>
               </a:rPr>
-              <a:t>SD-05 One tick through the central harness</a:t>
+              <a:t>SD-05 One tick through the central harness (1 of 2)</a:t>
             </a:r>
           </a:p>
         </p:txBody>
@@ -7744,7 +7957,7 @@
       </p:sp>
       <p:pic>
         <p:nvPicPr>
-          <p:cNvPr id="7" name="Picture 6" descr="sd05_tick.png"/>
+          <p:cNvPr id="7" name="Picture 6" descr="sd05_tick_1.png"/>
           <p:cNvPicPr>
             <a:picLocks noChangeAspect="1"/>
           </p:cNvPicPr>
@@ -7758,8 +7971,8 @@
         </p:blipFill>
         <p:spPr>
           <a:xfrm>
-            <a:off x="2548882" y="978408"/>
-            <a:ext cx="7093931" cy="5468112"/>
+            <a:off x="411480" y="1487510"/>
+            <a:ext cx="11368735" cy="4449908"/>
           </a:xfrm>
           <a:prstGeom prst="rect">
             <a:avLst/>
@@ -7857,7 +8070,7 @@
                 </a:solidFill>
                 <a:latin typeface="Segoe UI"/>
               </a:rPr>
-              <a:t>SD-06 Scan cycle of one wayside (1 of 2)</a:t>
+              <a:t>SD-05 One tick through the central harness (2 of 2)</a:t>
             </a:r>
           </a:p>
         </p:txBody>
@@ -7969,7 +8182,7 @@
       </p:sp>
       <p:pic>
         <p:nvPicPr>
-          <p:cNvPr id="7" name="Picture 6" descr="sd06_scan_cycle_1.png"/>
+          <p:cNvPr id="7" name="Picture 6" descr="sd05_tick_2.png"/>
           <p:cNvPicPr>
             <a:picLocks noChangeAspect="1"/>
           </p:cNvPicPr>
@@ -7983,8 +8196,8 @@
         </p:blipFill>
         <p:spPr>
           <a:xfrm>
-            <a:off x="2467297" y="978408"/>
-            <a:ext cx="7257101" cy="5468112"/>
+            <a:off x="411480" y="1555820"/>
+            <a:ext cx="11368735" cy="4313288"/>
           </a:xfrm>
           <a:prstGeom prst="rect">
             <a:avLst/>
@@ -8082,7 +8295,7 @@
                 </a:solidFill>
                 <a:latin typeface="Segoe UI"/>
               </a:rPr>
-              <a:t>SD-06 Scan cycle of one wayside (2 of 2)</a:t>
+              <a:t>SD-06 Scan cycle of one wayside (1 of 2)</a:t>
             </a:r>
           </a:p>
         </p:txBody>
@@ -8194,7 +8407,7 @@
       </p:sp>
       <p:pic>
         <p:nvPicPr>
-          <p:cNvPr id="7" name="Picture 6" descr="sd06_scan_cycle_2.png"/>
+          <p:cNvPr id="7" name="Picture 6" descr="sd06_scan_cycle_1.png"/>
           <p:cNvPicPr>
             <a:picLocks noChangeAspect="1"/>
           </p:cNvPicPr>
@@ -8208,8 +8421,8 @@
         </p:blipFill>
         <p:spPr>
           <a:xfrm>
-            <a:off x="3401688" y="978408"/>
-            <a:ext cx="5388319" cy="5468112"/>
+            <a:off x="2467297" y="978408"/>
+            <a:ext cx="7257101" cy="5468112"/>
           </a:xfrm>
           <a:prstGeom prst="rect">
             <a:avLst/>
@@ -8307,7 +8520,7 @@
                 </a:solidFill>
                 <a:latin typeface="Segoe UI"/>
               </a:rPr>
-              <a:t>SD-01 Load wayside database</a:t>
+              <a:t>SD-06 Scan cycle of one wayside (2 of 2)</a:t>
             </a:r>
           </a:p>
         </p:txBody>
@@ -8419,7 +8632,7 @@
       </p:sp>
       <p:pic>
         <p:nvPicPr>
-          <p:cNvPr id="7" name="Picture 6" descr="sd01_load_database.png"/>
+          <p:cNvPr id="7" name="Picture 6" descr="sd06_scan_cycle_2.png"/>
           <p:cNvPicPr>
             <a:picLocks noChangeAspect="1"/>
           </p:cNvPicPr>
@@ -8433,8 +8646,8 @@
         </p:blipFill>
         <p:spPr>
           <a:xfrm>
-            <a:off x="2441823" y="978408"/>
-            <a:ext cx="7308049" cy="5468112"/>
+            <a:off x="3401688" y="978408"/>
+            <a:ext cx="5388319" cy="5468112"/>
           </a:xfrm>
           <a:prstGeom prst="rect">
             <a:avLst/>
@@ -8532,7 +8745,7 @@
                 </a:solidFill>
                 <a:latin typeface="Segoe UI"/>
               </a:rPr>
-              <a:t>SD-02 Load PLC program</a:t>
+              <a:t>SD-01 Load wayside database (1 of 2)</a:t>
             </a:r>
           </a:p>
         </p:txBody>
@@ -8644,7 +8857,7 @@
       </p:sp>
       <p:pic>
         <p:nvPicPr>
-          <p:cNvPr id="7" name="Picture 6" descr="sd02_load_program.png"/>
+          <p:cNvPr id="7" name="Picture 6" descr="sd01_load_database_1.png"/>
           <p:cNvPicPr>
             <a:picLocks noChangeAspect="1"/>
           </p:cNvPicPr>
@@ -8658,8 +8871,8 @@
         </p:blipFill>
         <p:spPr>
           <a:xfrm>
-            <a:off x="1445044" y="978408"/>
-            <a:ext cx="9301607" cy="5468112"/>
+            <a:off x="411480" y="1935951"/>
+            <a:ext cx="11368735" cy="3553025"/>
           </a:xfrm>
           <a:prstGeom prst="rect">
             <a:avLst/>
@@ -8757,7 +8970,7 @@
                 </a:solidFill>
                 <a:latin typeface="Segoe UI"/>
               </a:rPr>
-              <a:t>SD-03 Select wayside and monitor</a:t>
+              <a:t>SD-01 Load wayside database (2 of 2)</a:t>
             </a:r>
           </a:p>
         </p:txBody>
@@ -8869,7 +9082,7 @@
       </p:sp>
       <p:pic>
         <p:nvPicPr>
-          <p:cNvPr id="7" name="Picture 6" descr="sd03_monitor.png"/>
+          <p:cNvPr id="7" name="Picture 6" descr="sd01_load_database_2.png"/>
           <p:cNvPicPr>
             <a:picLocks noChangeAspect="1"/>
           </p:cNvPicPr>
@@ -8883,8 +9096,8 @@
         </p:blipFill>
         <p:spPr>
           <a:xfrm>
-            <a:off x="2177601" y="978408"/>
-            <a:ext cx="7836493" cy="5468112"/>
+            <a:off x="411480" y="1235755"/>
+            <a:ext cx="11368735" cy="4953418"/>
           </a:xfrm>
           <a:prstGeom prst="rect">
             <a:avLst/>
@@ -8982,7 +9195,7 @@
                 </a:solidFill>
                 <a:latin typeface="Segoe UI"/>
               </a:rPr>
-              <a:t>SD-04 PLC details and last report</a:t>
+              <a:t>SD-02 Load PLC program (1 of 2)</a:t>
             </a:r>
           </a:p>
         </p:txBody>
@@ -9094,7 +9307,7 @@
       </p:sp>
       <p:pic>
         <p:nvPicPr>
-          <p:cNvPr id="7" name="Picture 6" descr="sd04_details_and_report.png"/>
+          <p:cNvPr id="7" name="Picture 6" descr="sd02_load_program_1.png"/>
           <p:cNvPicPr>
             <a:picLocks noChangeAspect="1"/>
           </p:cNvPicPr>
@@ -9108,8 +9321,8 @@
         </p:blipFill>
         <p:spPr>
           <a:xfrm>
-            <a:off x="3214367" y="978408"/>
-            <a:ext cx="5762961" cy="5468112"/>
+            <a:off x="1179120" y="978408"/>
+            <a:ext cx="9833454" cy="5468112"/>
           </a:xfrm>
           <a:prstGeom prst="rect">
             <a:avLst/>
@@ -9207,7 +9420,7 @@
                 </a:solidFill>
                 <a:latin typeface="Segoe UI"/>
               </a:rPr>
-              <a:t>SD-07 Maintenance switch command</a:t>
+              <a:t>SD-02 Load PLC program (2 of 2)</a:t>
             </a:r>
           </a:p>
         </p:txBody>
@@ -9319,7 +9532,7 @@
       </p:sp>
       <p:pic>
         <p:nvPicPr>
-          <p:cNvPr id="7" name="Picture 6" descr="sd07_maintenance_switch.png"/>
+          <p:cNvPr id="7" name="Picture 6" descr="sd02_load_program_2.png"/>
           <p:cNvPicPr>
             <a:picLocks noChangeAspect="1"/>
           </p:cNvPicPr>
@@ -9333,8 +9546,8 @@
         </p:blipFill>
         <p:spPr>
           <a:xfrm>
-            <a:off x="1496415" y="978408"/>
-            <a:ext cx="9198864" cy="5468112"/>
+            <a:off x="1389087" y="978408"/>
+            <a:ext cx="9413520" cy="5468112"/>
           </a:xfrm>
           <a:prstGeom prst="rect">
             <a:avLst/>
@@ -9368,13 +9581,13 @@
         <p:spPr>
           <a:xfrm>
             <a:off x="0" y="0"/>
-            <a:ext cx="12191695" cy="6858000"/>
+            <a:ext cx="12191695" cy="868680"/>
           </a:xfrm>
           <a:prstGeom prst="rect">
             <a:avLst/>
           </a:prstGeom>
           <a:solidFill>
-            <a:srgbClr val="F7F9FC"/>
+            <a:srgbClr val="1F3A5F"/>
           </a:solidFill>
           <a:ln>
             <a:noFill/>
@@ -9404,44 +9617,36 @@
       </p:sp>
       <p:sp>
         <p:nvSpPr>
-          <p:cNvPr id="3" name="Rectangle 2"/>
-          <p:cNvSpPr/>
-          <p:nvPr/>
-        </p:nvSpPr>
-        <p:spPr>
-          <a:xfrm>
-            <a:off x="822960" y="3246120"/>
-            <a:ext cx="1280160" cy="73152"/>
-          </a:xfrm>
-          <a:prstGeom prst="rect">
-            <a:avLst/>
-          </a:prstGeom>
-          <a:solidFill>
-            <a:srgbClr val="1F3A5F"/>
-          </a:solidFill>
-          <a:ln>
-            <a:noFill/>
-          </a:ln>
-        </p:spPr>
-        <p:style>
-          <a:lnRef idx="1">
-            <a:schemeClr val="accent1"/>
-          </a:lnRef>
-          <a:fillRef idx="3">
-            <a:schemeClr val="accent1"/>
-          </a:fillRef>
-          <a:effectRef idx="2">
-            <a:schemeClr val="accent1"/>
-          </a:effectRef>
-          <a:fontRef idx="minor">
-            <a:schemeClr val="lt1"/>
-          </a:fontRef>
-        </p:style>
-        <p:txBody>
-          <a:bodyPr rtlCol="0" anchor="ctr"/>
-          <a:lstStyle/>
-          <a:p>
-            <a:pPr algn="ctr"/>
+          <p:cNvPr id="3" name="TextBox 2"/>
+          <p:cNvSpPr txBox="1"/>
+          <p:nvPr/>
+        </p:nvSpPr>
+        <p:spPr>
+          <a:xfrm>
+            <a:off x="411480" y="109728"/>
+            <a:ext cx="11368735" cy="685800"/>
+          </a:xfrm>
+          <a:prstGeom prst="rect">
+            <a:avLst/>
+          </a:prstGeom>
+          <a:noFill/>
+        </p:spPr>
+        <p:txBody>
+          <a:bodyPr wrap="square" anchor="ctr" lIns="45720" rIns="45720">
+            <a:spAutoFit/>
+          </a:bodyPr>
+          <a:lstStyle/>
+          <a:p>
+            <a:pPr algn="l"/>
+            <a:r>
+              <a:rPr sz="2800" b="1">
+                <a:solidFill>
+                  <a:srgbClr val="FFFFFF"/>
+                </a:solidFill>
+                <a:latin typeface="Segoe UI"/>
+              </a:rPr>
+              <a:t>SD-03 Select wayside and monitor</a:t>
+            </a:r>
           </a:p>
         </p:txBody>
       </p:sp>
@@ -9453,8 +9658,43 @@
         </p:nvSpPr>
         <p:spPr>
           <a:xfrm>
-            <a:off x="822960" y="2194560"/>
-            <a:ext cx="10515600" cy="1005840"/>
+            <a:off x="8351215" y="109728"/>
+            <a:ext cx="3474720" cy="685800"/>
+          </a:xfrm>
+          <a:prstGeom prst="rect">
+            <a:avLst/>
+          </a:prstGeom>
+          <a:noFill/>
+        </p:spPr>
+        <p:txBody>
+          <a:bodyPr wrap="square" anchor="ctr" lIns="45720" rIns="45720">
+            <a:spAutoFit/>
+          </a:bodyPr>
+          <a:lstStyle/>
+          <a:p>
+            <a:pPr algn="r"/>
+            <a:r>
+              <a:rPr sz="1200" b="0">
+                <a:solidFill>
+                  <a:srgbClr val="D9E2EC"/>
+                </a:solidFill>
+                <a:latin typeface="Segoe UI"/>
+              </a:rPr>
+              <a:t>Sequence diagrams</a:t>
+            </a:r>
+          </a:p>
+        </p:txBody>
+      </p:sp>
+      <p:sp>
+        <p:nvSpPr>
+          <p:cNvPr id="5" name="TextBox 4"/>
+          <p:cNvSpPr txBox="1"/>
+          <p:nvPr/>
+        </p:nvSpPr>
+        <p:spPr>
+          <a:xfrm>
+            <a:off x="411480" y="6537960"/>
+            <a:ext cx="8229600" cy="320040"/>
           </a:xfrm>
           <a:prstGeom prst="rect">
             <a:avLst/>
@@ -9469,17 +9709,76 @@
           <a:p>
             <a:pPr algn="l"/>
             <a:r>
-              <a:rPr sz="4000" b="1">
-                <a:solidFill>
-                  <a:srgbClr val="1F3A5F"/>
-                </a:solidFill>
-                <a:latin typeface="Segoe UI"/>
-              </a:rPr>
-              <a:t>Deployment</a:t>
-            </a:r>
-          </a:p>
-        </p:txBody>
-      </p:sp>
+              <a:rPr sz="1000" b="0">
+                <a:solidFill>
+                  <a:srgbClr val="5B6775"/>
+                </a:solidFill>
+                <a:latin typeface="Segoe UI"/>
+              </a:rPr>
+              <a:t>Track Overflow · Design Review · Track Controller (HW) · Braden</a:t>
+            </a:r>
+          </a:p>
+        </p:txBody>
+      </p:sp>
+      <p:sp>
+        <p:nvSpPr>
+          <p:cNvPr id="6" name="TextBox 5"/>
+          <p:cNvSpPr txBox="1"/>
+          <p:nvPr/>
+        </p:nvSpPr>
+        <p:spPr>
+          <a:xfrm>
+            <a:off x="10820095" y="6537960"/>
+            <a:ext cx="960120" cy="320040"/>
+          </a:xfrm>
+          <a:prstGeom prst="rect">
+            <a:avLst/>
+          </a:prstGeom>
+          <a:noFill/>
+        </p:spPr>
+        <p:txBody>
+          <a:bodyPr wrap="square" anchor="t" lIns="45720" rIns="45720">
+            <a:spAutoFit/>
+          </a:bodyPr>
+          <a:lstStyle/>
+          <a:p>
+            <a:pPr algn="r"/>
+            <a:r>
+              <a:rPr sz="1000" b="0">
+                <a:solidFill>
+                  <a:srgbClr val="5B6775"/>
+                </a:solidFill>
+                <a:latin typeface="Segoe UI"/>
+              </a:rPr>
+              <a:t>29</a:t>
+            </a:r>
+          </a:p>
+        </p:txBody>
+      </p:sp>
+      <p:pic>
+        <p:nvPicPr>
+          <p:cNvPr id="7" name="Picture 6" descr="sd03_monitor.png"/>
+          <p:cNvPicPr>
+            <a:picLocks noChangeAspect="1"/>
+          </p:cNvPicPr>
+          <p:nvPr/>
+        </p:nvPicPr>
+        <p:blipFill>
+          <a:blip r:embed="rId3"/>
+          <a:stretch>
+            <a:fillRect/>
+          </a:stretch>
+        </p:blipFill>
+        <p:spPr>
+          <a:xfrm>
+            <a:off x="2177601" y="978408"/>
+            <a:ext cx="7836493" cy="5468112"/>
+          </a:xfrm>
+          <a:prstGeom prst="rect">
+            <a:avLst/>
+          </a:prstGeom>
+        </p:spPr>
+      </p:pic>
     </p:spTree>
   </p:cSld>
   <p:clrMapOvr>
@@ -9907,7 +10206,7 @@
                 </a:solidFill>
                 <a:latin typeface="Segoe UI"/>
               </a:rPr>
-              <a:t>Deployment</a:t>
+              <a:t>SD-04 PLC details and last report</a:t>
             </a:r>
           </a:p>
         </p:txBody>
@@ -9942,7 +10241,7 @@
                 </a:solidFill>
                 <a:latin typeface="Segoe UI"/>
               </a:rPr>
-              <a:t>Deployment</a:t>
+              <a:t>Sequence diagrams</a:t>
             </a:r>
           </a:p>
         </p:txBody>
@@ -10019,7 +10318,7 @@
       </p:sp>
       <p:pic>
         <p:nvPicPr>
-          <p:cNvPr id="7" name="Picture 6" descr="deployment.png"/>
+          <p:cNvPr id="7" name="Picture 6" descr="sd04_details_and_report.png"/>
           <p:cNvPicPr>
             <a:picLocks noChangeAspect="1"/>
           </p:cNvPicPr>
@@ -10033,8 +10332,8 @@
         </p:blipFill>
         <p:spPr>
           <a:xfrm>
-            <a:off x="1796387" y="978408"/>
-            <a:ext cx="8598920" cy="5468112"/>
+            <a:off x="3214367" y="978408"/>
+            <a:ext cx="5762961" cy="5468112"/>
           </a:xfrm>
           <a:prstGeom prst="rect">
             <a:avLst/>
@@ -10068,13 +10367,13 @@
         <p:spPr>
           <a:xfrm>
             <a:off x="0" y="0"/>
-            <a:ext cx="12191695" cy="6858000"/>
+            <a:ext cx="12191695" cy="868680"/>
           </a:xfrm>
           <a:prstGeom prst="rect">
             <a:avLst/>
           </a:prstGeom>
           <a:solidFill>
-            <a:srgbClr val="F7F9FC"/>
+            <a:srgbClr val="1F3A5F"/>
           </a:solidFill>
           <a:ln>
             <a:noFill/>
@@ -10104,44 +10403,36 @@
       </p:sp>
       <p:sp>
         <p:nvSpPr>
-          <p:cNvPr id="3" name="Rectangle 2"/>
-          <p:cNvSpPr/>
-          <p:nvPr/>
-        </p:nvSpPr>
-        <p:spPr>
-          <a:xfrm>
-            <a:off x="822960" y="3246120"/>
-            <a:ext cx="1280160" cy="73152"/>
-          </a:xfrm>
-          <a:prstGeom prst="rect">
-            <a:avLst/>
-          </a:prstGeom>
-          <a:solidFill>
-            <a:srgbClr val="1F3A5F"/>
-          </a:solidFill>
-          <a:ln>
-            <a:noFill/>
-          </a:ln>
-        </p:spPr>
-        <p:style>
-          <a:lnRef idx="1">
-            <a:schemeClr val="accent1"/>
-          </a:lnRef>
-          <a:fillRef idx="3">
-            <a:schemeClr val="accent1"/>
-          </a:fillRef>
-          <a:effectRef idx="2">
-            <a:schemeClr val="accent1"/>
-          </a:effectRef>
-          <a:fontRef idx="minor">
-            <a:schemeClr val="lt1"/>
-          </a:fontRef>
-        </p:style>
-        <p:txBody>
-          <a:bodyPr rtlCol="0" anchor="ctr"/>
-          <a:lstStyle/>
-          <a:p>
-            <a:pPr algn="ctr"/>
+          <p:cNvPr id="3" name="TextBox 2"/>
+          <p:cNvSpPr txBox="1"/>
+          <p:nvPr/>
+        </p:nvSpPr>
+        <p:spPr>
+          <a:xfrm>
+            <a:off x="411480" y="109728"/>
+            <a:ext cx="11368735" cy="685800"/>
+          </a:xfrm>
+          <a:prstGeom prst="rect">
+            <a:avLst/>
+          </a:prstGeom>
+          <a:noFill/>
+        </p:spPr>
+        <p:txBody>
+          <a:bodyPr wrap="square" anchor="ctr" lIns="45720" rIns="45720">
+            <a:spAutoFit/>
+          </a:bodyPr>
+          <a:lstStyle/>
+          <a:p>
+            <a:pPr algn="l"/>
+            <a:r>
+              <a:rPr sz="2800" b="1">
+                <a:solidFill>
+                  <a:srgbClr val="FFFFFF"/>
+                </a:solidFill>
+                <a:latin typeface="Segoe UI"/>
+              </a:rPr>
+              <a:t>SD-07 Maintenance switch command</a:t>
+            </a:r>
           </a:p>
         </p:txBody>
       </p:sp>
@@ -10153,8 +10444,43 @@
         </p:nvSpPr>
         <p:spPr>
           <a:xfrm>
-            <a:off x="822960" y="2194560"/>
-            <a:ext cx="10515600" cy="1005840"/>
+            <a:off x="8351215" y="109728"/>
+            <a:ext cx="3474720" cy="685800"/>
+          </a:xfrm>
+          <a:prstGeom prst="rect">
+            <a:avLst/>
+          </a:prstGeom>
+          <a:noFill/>
+        </p:spPr>
+        <p:txBody>
+          <a:bodyPr wrap="square" anchor="ctr" lIns="45720" rIns="45720">
+            <a:spAutoFit/>
+          </a:bodyPr>
+          <a:lstStyle/>
+          <a:p>
+            <a:pPr algn="r"/>
+            <a:r>
+              <a:rPr sz="1200" b="0">
+                <a:solidFill>
+                  <a:srgbClr val="D9E2EC"/>
+                </a:solidFill>
+                <a:latin typeface="Segoe UI"/>
+              </a:rPr>
+              <a:t>Sequence diagrams</a:t>
+            </a:r>
+          </a:p>
+        </p:txBody>
+      </p:sp>
+      <p:sp>
+        <p:nvSpPr>
+          <p:cNvPr id="5" name="TextBox 4"/>
+          <p:cNvSpPr txBox="1"/>
+          <p:nvPr/>
+        </p:nvSpPr>
+        <p:spPr>
+          <a:xfrm>
+            <a:off x="411480" y="6537960"/>
+            <a:ext cx="8229600" cy="320040"/>
           </a:xfrm>
           <a:prstGeom prst="rect">
             <a:avLst/>
@@ -10169,27 +10495,27 @@
           <a:p>
             <a:pPr algn="l"/>
             <a:r>
-              <a:rPr sz="4000" b="1">
-                <a:solidFill>
-                  <a:srgbClr val="1F3A5F"/>
-                </a:solidFill>
-                <a:latin typeface="Segoe UI"/>
-              </a:rPr>
-              <a:t>System concepts</a:t>
-            </a:r>
-          </a:p>
-        </p:txBody>
-      </p:sp>
-      <p:sp>
-        <p:nvSpPr>
-          <p:cNvPr id="5" name="TextBox 4"/>
+              <a:rPr sz="1000" b="0">
+                <a:solidFill>
+                  <a:srgbClr val="5B6775"/>
+                </a:solidFill>
+                <a:latin typeface="Segoe UI"/>
+              </a:rPr>
+              <a:t>Track Overflow · Design Review · Track Controller (HW) · Braden</a:t>
+            </a:r>
+          </a:p>
+        </p:txBody>
+      </p:sp>
+      <p:sp>
+        <p:nvSpPr>
+          <p:cNvPr id="6" name="TextBox 5"/>
           <p:cNvSpPr txBox="1"/>
           <p:nvPr/>
         </p:nvSpPr>
         <p:spPr>
           <a:xfrm>
-            <a:off x="822960" y="3474720"/>
-            <a:ext cx="10515600" cy="914400"/>
+            <a:off x="10820095" y="6537960"/>
+            <a:ext cx="960120" cy="320040"/>
           </a:xfrm>
           <a:prstGeom prst="rect">
             <a:avLst/>
@@ -10202,19 +10528,43 @@
           </a:bodyPr>
           <a:lstStyle/>
           <a:p>
-            <a:pPr algn="l"/>
-            <a:r>
-              <a:rPr sz="2000" b="0">
+            <a:pPr algn="r"/>
+            <a:r>
+              <a:rPr sz="1000" b="0">
                 <a:solidFill>
                   <a:srgbClr val="5B6775"/>
                 </a:solidFill>
                 <a:latin typeface="Segoe UI"/>
               </a:rPr>
-              <a:t>Track Controller's part of the joint concepts, with Harry and Landis</a:t>
-            </a:r>
-          </a:p>
-        </p:txBody>
-      </p:sp>
+              <a:t>31</a:t>
+            </a:r>
+          </a:p>
+        </p:txBody>
+      </p:sp>
+      <p:pic>
+        <p:nvPicPr>
+          <p:cNvPr id="7" name="Picture 6" descr="sd07_maintenance_switch.png"/>
+          <p:cNvPicPr>
+            <a:picLocks noChangeAspect="1"/>
+          </p:cNvPicPr>
+          <p:nvPr/>
+        </p:nvPicPr>
+        <p:blipFill>
+          <a:blip r:embed="rId3"/>
+          <a:stretch>
+            <a:fillRect/>
+          </a:stretch>
+        </p:blipFill>
+        <p:spPr>
+          <a:xfrm>
+            <a:off x="1496415" y="978408"/>
+            <a:ext cx="9198864" cy="5468112"/>
+          </a:xfrm>
+          <a:prstGeom prst="rect">
+            <a:avLst/>
+          </a:prstGeom>
+        </p:spPr>
+      </p:pic>
     </p:spTree>
   </p:cSld>
   <p:clrMapOvr>
@@ -10242,13 +10592,13 @@
         <p:spPr>
           <a:xfrm>
             <a:off x="0" y="0"/>
-            <a:ext cx="12191695" cy="868680"/>
+            <a:ext cx="12191695" cy="6858000"/>
           </a:xfrm>
           <a:prstGeom prst="rect">
             <a:avLst/>
           </a:prstGeom>
           <a:solidFill>
-            <a:srgbClr val="1F3A5F"/>
+            <a:srgbClr val="F7F9FC"/>
           </a:solidFill>
           <a:ln>
             <a:noFill/>
@@ -10278,36 +10628,44 @@
       </p:sp>
       <p:sp>
         <p:nvSpPr>
-          <p:cNvPr id="3" name="TextBox 2"/>
-          <p:cNvSpPr txBox="1"/>
-          <p:nvPr/>
-        </p:nvSpPr>
-        <p:spPr>
-          <a:xfrm>
-            <a:off x="411480" y="109728"/>
-            <a:ext cx="11368735" cy="685800"/>
-          </a:xfrm>
-          <a:prstGeom prst="rect">
-            <a:avLst/>
-          </a:prstGeom>
-          <a:noFill/>
-        </p:spPr>
-        <p:txBody>
-          <a:bodyPr wrap="square" anchor="ctr" lIns="45720" rIns="45720">
-            <a:spAutoFit/>
-          </a:bodyPr>
-          <a:lstStyle/>
-          <a:p>
-            <a:pPr algn="l"/>
-            <a:r>
-              <a:rPr sz="2800" b="1">
-                <a:solidFill>
-                  <a:srgbClr val="FFFFFF"/>
-                </a:solidFill>
-                <a:latin typeface="Segoe UI"/>
-              </a:rPr>
-              <a:t>Distribution of wayside controllers</a:t>
-            </a:r>
+          <p:cNvPr id="3" name="Rectangle 2"/>
+          <p:cNvSpPr/>
+          <p:nvPr/>
+        </p:nvSpPr>
+        <p:spPr>
+          <a:xfrm>
+            <a:off x="822960" y="3246120"/>
+            <a:ext cx="1280160" cy="73152"/>
+          </a:xfrm>
+          <a:prstGeom prst="rect">
+            <a:avLst/>
+          </a:prstGeom>
+          <a:solidFill>
+            <a:srgbClr val="1F3A5F"/>
+          </a:solidFill>
+          <a:ln>
+            <a:noFill/>
+          </a:ln>
+        </p:spPr>
+        <p:style>
+          <a:lnRef idx="1">
+            <a:schemeClr val="accent1"/>
+          </a:lnRef>
+          <a:fillRef idx="3">
+            <a:schemeClr val="accent1"/>
+          </a:fillRef>
+          <a:effectRef idx="2">
+            <a:schemeClr val="accent1"/>
+          </a:effectRef>
+          <a:fontRef idx="minor">
+            <a:schemeClr val="lt1"/>
+          </a:fontRef>
+        </p:style>
+        <p:txBody>
+          <a:bodyPr rtlCol="0" anchor="ctr"/>
+          <a:lstStyle/>
+          <a:p>
+            <a:pPr algn="ctr"/>
           </a:p>
         </p:txBody>
       </p:sp>
@@ -10319,43 +10677,8 @@
         </p:nvSpPr>
         <p:spPr>
           <a:xfrm>
-            <a:off x="8351215" y="109728"/>
-            <a:ext cx="3474720" cy="685800"/>
-          </a:xfrm>
-          <a:prstGeom prst="rect">
-            <a:avLst/>
-          </a:prstGeom>
-          <a:noFill/>
-        </p:spPr>
-        <p:txBody>
-          <a:bodyPr wrap="square" anchor="ctr" lIns="45720" rIns="45720">
-            <a:spAutoFit/>
-          </a:bodyPr>
-          <a:lstStyle/>
-          <a:p>
-            <a:pPr algn="r"/>
-            <a:r>
-              <a:rPr sz="1200" b="0">
-                <a:solidFill>
-                  <a:srgbClr val="D9E2EC"/>
-                </a:solidFill>
-                <a:latin typeface="Segoe UI"/>
-              </a:rPr>
-              <a:t>System concepts</a:t>
-            </a:r>
-          </a:p>
-        </p:txBody>
-      </p:sp>
-      <p:sp>
-        <p:nvSpPr>
-          <p:cNvPr id="5" name="TextBox 4"/>
-          <p:cNvSpPr txBox="1"/>
-          <p:nvPr/>
-        </p:nvSpPr>
-        <p:spPr>
-          <a:xfrm>
-            <a:off x="411480" y="6537960"/>
-            <a:ext cx="8229600" cy="320040"/>
+            <a:off x="822960" y="2194560"/>
+            <a:ext cx="10515600" cy="1005840"/>
           </a:xfrm>
           <a:prstGeom prst="rect">
             <a:avLst/>
@@ -10370,183 +10693,13 @@
           <a:p>
             <a:pPr algn="l"/>
             <a:r>
-              <a:rPr sz="1000" b="0">
-                <a:solidFill>
-                  <a:srgbClr val="5B6775"/>
-                </a:solidFill>
-                <a:latin typeface="Segoe UI"/>
-              </a:rPr>
-              <a:t>Track Overflow · Design Review · Track Controller (HW) · Braden</a:t>
-            </a:r>
-          </a:p>
-        </p:txBody>
-      </p:sp>
-      <p:sp>
-        <p:nvSpPr>
-          <p:cNvPr id="6" name="TextBox 5"/>
-          <p:cNvSpPr txBox="1"/>
-          <p:nvPr/>
-        </p:nvSpPr>
-        <p:spPr>
-          <a:xfrm>
-            <a:off x="10820095" y="6537960"/>
-            <a:ext cx="960120" cy="320040"/>
-          </a:xfrm>
-          <a:prstGeom prst="rect">
-            <a:avLst/>
-          </a:prstGeom>
-          <a:noFill/>
-        </p:spPr>
-        <p:txBody>
-          <a:bodyPr wrap="square" anchor="t" lIns="45720" rIns="45720">
-            <a:spAutoFit/>
-          </a:bodyPr>
-          <a:lstStyle/>
-          <a:p>
-            <a:pPr algn="r"/>
-            <a:r>
-              <a:rPr sz="1000" b="0">
-                <a:solidFill>
-                  <a:srgbClr val="5B6775"/>
-                </a:solidFill>
-                <a:latin typeface="Segoe UI"/>
-              </a:rPr>
-              <a:t>32</a:t>
-            </a:r>
-          </a:p>
-        </p:txBody>
-      </p:sp>
-      <p:sp>
-        <p:nvSpPr>
-          <p:cNvPr id="7" name="TextBox 6"/>
-          <p:cNvSpPr txBox="1"/>
-          <p:nvPr/>
-        </p:nvSpPr>
-        <p:spPr>
-          <a:xfrm>
-            <a:off x="411480" y="1097280"/>
-            <a:ext cx="11368735" cy="5349240"/>
-          </a:xfrm>
-          <a:prstGeom prst="rect">
-            <a:avLst/>
-          </a:prstGeom>
-          <a:noFill/>
-        </p:spPr>
-        <p:txBody>
-          <a:bodyPr wrap="square">
-            <a:spAutoFit/>
-          </a:bodyPr>
-          <a:lstStyle/>
-          <a:p>
-            <a:pPr>
-              <a:spcAft>
-                <a:spcPts val="800"/>
-              </a:spcAft>
-            </a:pPr>
-            <a:r>
-              <a:rPr sz="2400">
-                <a:solidFill>
-                  <a:srgbClr val="222B36"/>
-                </a:solidFill>
-                <a:latin typeface="Segoe UI"/>
-              </a:rPr>
-              <a:t>•  One variant per line: HW runs the Red Line, SW the Green Line (D021)</a:t>
-            </a:r>
-          </a:p>
-          <a:p>
-            <a:pPr>
-              <a:spcAft>
-                <a:spcPts val="800"/>
-              </a:spcAft>
-            </a:pPr>
-            <a:r>
-              <a:rPr sz="2400">
-                <a:solidFill>
-                  <a:srgbClr val="222B36"/>
-                </a:solidFill>
-                <a:latin typeface="Segoe UI"/>
-              </a:rPr>
-              <a:t>•  A wayside owns a contiguous run of blocks and every switch, signal and crossing on them</a:t>
-            </a:r>
-          </a:p>
-          <a:p>
-            <a:pPr>
-              <a:spcAft>
-                <a:spcPts val="800"/>
-              </a:spcAft>
-            </a:pPr>
-            <a:r>
-              <a:rPr sz="2400">
-                <a:solidFill>
-                  <a:srgbClr val="222B36"/>
-                </a:solidFill>
-                <a:latin typeface="Segoe UI"/>
-              </a:rPr>
-              <a:t>•  One Raspberry Pi 5 runs every Red Line wayside</a:t>
-            </a:r>
-          </a:p>
-          <a:p>
-            <a:pPr>
-              <a:spcAft>
-                <a:spcPts val="800"/>
-              </a:spcAft>
-            </a:pPr>
-            <a:r>
-              <a:rPr sz="2400">
-                <a:solidFill>
-                  <a:srgbClr val="222B36"/>
-                </a:solidFill>
-                <a:latin typeface="Segoe UI"/>
-              </a:rPr>
-              <a:t>•  A line runs only when every wayside on it is ready</a:t>
-            </a:r>
-          </a:p>
-          <a:p>
-            <a:pPr lvl="1">
-              <a:spcAft>
-                <a:spcPts val="400"/>
-              </a:spcAft>
-            </a:pPr>
-            <a:r>
-              <a:rPr sz="2100">
-                <a:solidFill>
-                  <a:srgbClr val="5B6775"/>
-                </a:solidFill>
-                <a:latin typeface="Segoe UI"/>
-              </a:rPr>
-              <a:t>–  Ready: a person has loaded the database and the PLC program, and the channels agree</a:t>
-            </a:r>
-          </a:p>
-          <a:p>
-            <a:pPr lvl="1">
-              <a:spcAft>
-                <a:spcPts val="400"/>
-              </a:spcAft>
-            </a:pPr>
-            <a:r>
-              <a:rPr sz="2100">
-                <a:solidFill>
-                  <a:srgbClr val="5B6775"/>
-                </a:solidFill>
-                <a:latin typeface="Segoe UI"/>
-              </a:rPr>
-              <a:t>–  Not ready anywhere on the line: the whole line holds fail-safe and the CTC dispatches nothing</a:t>
-            </a:r>
-          </a:p>
-          <a:p>
-            <a:pPr>
-              <a:spcAft>
-                <a:spcPts val="800"/>
-              </a:spcAft>
-            </a:pPr>
-            <a:r>
-              <a:rPr sz="2400">
-                <a:solidFill>
-                  <a:srgbClr val="222B36"/>
-                </a:solidFill>
-                <a:latin typeface="Segoe UI"/>
-              </a:rPr>
-              <a:t>•  Red Line boundaries: to be chosen; a switch must lie inside one wayside</a:t>
+              <a:rPr sz="4000" b="1">
+                <a:solidFill>
+                  <a:srgbClr val="1F3A5F"/>
+                </a:solidFill>
+                <a:latin typeface="Segoe UI"/>
+              </a:rPr>
+              <a:t>Deployment</a:t>
             </a:r>
           </a:p>
         </p:txBody>
@@ -10642,7 +10795,7 @@
                 </a:solidFill>
                 <a:latin typeface="Segoe UI"/>
               </a:rPr>
-              <a:t>Authority, as the wayside handles it</a:t>
+              <a:t>Deployment</a:t>
             </a:r>
           </a:p>
         </p:txBody>
@@ -10677,7 +10830,7 @@
                 </a:solidFill>
                 <a:latin typeface="Segoe UI"/>
               </a:rPr>
-              <a:t>System concepts</a:t>
+              <a:t>Deployment</a:t>
             </a:r>
           </a:p>
         </p:txBody>
@@ -10752,125 +10905,30 @@
           </a:p>
         </p:txBody>
       </p:sp>
-      <p:sp>
-        <p:nvSpPr>
-          <p:cNvPr id="7" name="TextBox 6"/>
-          <p:cNvSpPr txBox="1"/>
-          <p:nvPr/>
-        </p:nvSpPr>
-        <p:spPr>
-          <a:xfrm>
-            <a:off x="411480" y="1097280"/>
-            <a:ext cx="11368735" cy="5349240"/>
-          </a:xfrm>
-          <a:prstGeom prst="rect">
-            <a:avLst/>
-          </a:prstGeom>
-          <a:noFill/>
-        </p:spPr>
-        <p:txBody>
-          <a:bodyPr wrap="square">
-            <a:spAutoFit/>
-          </a:bodyPr>
-          <a:lstStyle/>
-          <a:p>
-            <a:pPr>
-              <a:spcAft>
-                <a:spcPts val="800"/>
-              </a:spcAft>
-            </a:pPr>
-            <a:r>
-              <a:rPr sz="2400">
-                <a:solidFill>
-                  <a:srgbClr val="222B36"/>
-                </a:solidFill>
-                <a:latin typeface="Segoe UI"/>
-              </a:rPr>
-              <a:t>•  Authority = blocks ahead the train may still enter; 0 = stop (D013)</a:t>
-            </a:r>
-          </a:p>
-          <a:p>
-            <a:pPr>
-              <a:spcAft>
-                <a:spcPts val="800"/>
-              </a:spcAft>
-            </a:pPr>
-            <a:r>
-              <a:rPr sz="2400">
-                <a:solidFill>
-                  <a:srgbClr val="222B36"/>
-                </a:solidFill>
-                <a:latin typeface="Segoe UI"/>
-              </a:rPr>
-              <a:t>•  CTC Office computes it along the route and suggests it per block</a:t>
-            </a:r>
-          </a:p>
-          <a:p>
-            <a:pPr>
-              <a:spcAft>
-                <a:spcPts val="800"/>
-              </a:spcAft>
-            </a:pPr>
-            <a:r>
-              <a:rPr sz="2400">
-                <a:solidFill>
-                  <a:srgbClr val="222B36"/>
-                </a:solidFill>
-                <a:latin typeface="Segoe UI"/>
-              </a:rPr>
-              <a:t>•  The program's AUTH_n passes the CTC count down block n's track circuit, or sends 0</a:t>
-            </a:r>
-          </a:p>
-          <a:p>
-            <a:pPr lvl="1">
-              <a:spcAft>
-                <a:spcPts val="400"/>
-              </a:spcAft>
-            </a:pPr>
-            <a:r>
-              <a:rPr sz="2100">
-                <a:solidFill>
-                  <a:srgbClr val="5B6775"/>
-                </a:solidFill>
-                <a:latin typeface="Segoe UI"/>
-              </a:rPr>
-              <a:t>–  Withheld for a closed block, a switch not where commanded, an occupied neighbour</a:t>
-            </a:r>
-          </a:p>
-          <a:p>
-            <a:pPr>
-              <a:spcAft>
-                <a:spcPts val="800"/>
-              </a:spcAft>
-            </a:pPr>
-            <a:r>
-              <a:rPr sz="2400">
-                <a:solidFill>
-                  <a:srgbClr val="222B36"/>
-                </a:solidFill>
-                <a:latin typeface="Segoe UI"/>
-              </a:rPr>
-              <a:t>•  Speed travels with it as five bits, capped at the block's limit</a:t>
-            </a:r>
-          </a:p>
-          <a:p>
-            <a:pPr>
-              <a:spcAft>
-                <a:spcPts val="800"/>
-              </a:spcAft>
-            </a:pPr>
-            <a:r>
-              <a:rPr sz="2400">
-                <a:solidFill>
-                  <a:srgbClr val="222B36"/>
-                </a:solidFill>
-                <a:latin typeface="Segoe UI"/>
-              </a:rPr>
-              <a:t>•  Track Model delivers both to the train in the block, then clears them</a:t>
-            </a:r>
-          </a:p>
-        </p:txBody>
-      </p:sp>
+      <p:pic>
+        <p:nvPicPr>
+          <p:cNvPr id="7" name="Picture 6" descr="deployment.png"/>
+          <p:cNvPicPr>
+            <a:picLocks noChangeAspect="1"/>
+          </p:cNvPicPr>
+          <p:nvPr/>
+        </p:nvPicPr>
+        <p:blipFill>
+          <a:blip r:embed="rId3"/>
+          <a:stretch>
+            <a:fillRect/>
+          </a:stretch>
+        </p:blipFill>
+        <p:spPr>
+          <a:xfrm>
+            <a:off x="1796387" y="978408"/>
+            <a:ext cx="8598920" cy="5468112"/>
+          </a:xfrm>
+          <a:prstGeom prst="rect">
+            <a:avLst/>
+          </a:prstGeom>
+        </p:spPr>
+      </p:pic>
     </p:spTree>
   </p:cSld>
   <p:clrMapOvr>
@@ -10898,13 +10956,13 @@
         <p:spPr>
           <a:xfrm>
             <a:off x="0" y="0"/>
-            <a:ext cx="12191695" cy="868680"/>
+            <a:ext cx="12191695" cy="6858000"/>
           </a:xfrm>
           <a:prstGeom prst="rect">
             <a:avLst/>
           </a:prstGeom>
           <a:solidFill>
-            <a:srgbClr val="1F3A5F"/>
+            <a:srgbClr val="F7F9FC"/>
           </a:solidFill>
           <a:ln>
             <a:noFill/>
@@ -10934,165 +10992,23 @@
       </p:sp>
       <p:sp>
         <p:nvSpPr>
-          <p:cNvPr id="3" name="TextBox 2"/>
-          <p:cNvSpPr txBox="1"/>
-          <p:nvPr/>
-        </p:nvSpPr>
-        <p:spPr>
-          <a:xfrm>
-            <a:off x="411480" y="109728"/>
-            <a:ext cx="11368735" cy="685800"/>
-          </a:xfrm>
-          <a:prstGeom prst="rect">
-            <a:avLst/>
-          </a:prstGeom>
-          <a:noFill/>
-        </p:spPr>
-        <p:txBody>
-          <a:bodyPr wrap="square" anchor="ctr" lIns="45720" rIns="45720">
-            <a:spAutoFit/>
-          </a:bodyPr>
-          <a:lstStyle/>
-          <a:p>
-            <a:pPr algn="l"/>
-            <a:r>
-              <a:rPr sz="2800" b="1">
-                <a:solidFill>
-                  <a:srgbClr val="FFFFFF"/>
-                </a:solidFill>
-                <a:latin typeface="Segoe UI"/>
-              </a:rPr>
-              <a:t>Wayside language</a:t>
-            </a:r>
-          </a:p>
-        </p:txBody>
-      </p:sp>
-      <p:sp>
-        <p:nvSpPr>
-          <p:cNvPr id="4" name="TextBox 3"/>
-          <p:cNvSpPr txBox="1"/>
-          <p:nvPr/>
-        </p:nvSpPr>
-        <p:spPr>
-          <a:xfrm>
-            <a:off x="8351215" y="109728"/>
-            <a:ext cx="3474720" cy="685800"/>
-          </a:xfrm>
-          <a:prstGeom prst="rect">
-            <a:avLst/>
-          </a:prstGeom>
-          <a:noFill/>
-        </p:spPr>
-        <p:txBody>
-          <a:bodyPr wrap="square" anchor="ctr" lIns="45720" rIns="45720">
-            <a:spAutoFit/>
-          </a:bodyPr>
-          <a:lstStyle/>
-          <a:p>
-            <a:pPr algn="r"/>
-            <a:r>
-              <a:rPr sz="1200" b="0">
-                <a:solidFill>
-                  <a:srgbClr val="D9E2EC"/>
-                </a:solidFill>
-                <a:latin typeface="Segoe UI"/>
-              </a:rPr>
-              <a:t>System concepts</a:t>
-            </a:r>
-          </a:p>
-        </p:txBody>
-      </p:sp>
-      <p:sp>
-        <p:nvSpPr>
-          <p:cNvPr id="5" name="TextBox 4"/>
-          <p:cNvSpPr txBox="1"/>
-          <p:nvPr/>
-        </p:nvSpPr>
-        <p:spPr>
-          <a:xfrm>
-            <a:off x="411480" y="6537960"/>
-            <a:ext cx="8229600" cy="320040"/>
-          </a:xfrm>
-          <a:prstGeom prst="rect">
-            <a:avLst/>
-          </a:prstGeom>
-          <a:noFill/>
-        </p:spPr>
-        <p:txBody>
-          <a:bodyPr wrap="square" anchor="t" lIns="45720" rIns="45720">
-            <a:spAutoFit/>
-          </a:bodyPr>
-          <a:lstStyle/>
-          <a:p>
-            <a:pPr algn="l"/>
-            <a:r>
-              <a:rPr sz="1000" b="0">
-                <a:solidFill>
-                  <a:srgbClr val="5B6775"/>
-                </a:solidFill>
-                <a:latin typeface="Segoe UI"/>
-              </a:rPr>
-              <a:t>Track Overflow · Design Review · Track Controller (HW) · Braden</a:t>
-            </a:r>
-          </a:p>
-        </p:txBody>
-      </p:sp>
-      <p:sp>
-        <p:nvSpPr>
-          <p:cNvPr id="6" name="TextBox 5"/>
-          <p:cNvSpPr txBox="1"/>
-          <p:nvPr/>
-        </p:nvSpPr>
-        <p:spPr>
-          <a:xfrm>
-            <a:off x="10820095" y="6537960"/>
-            <a:ext cx="960120" cy="320040"/>
-          </a:xfrm>
-          <a:prstGeom prst="rect">
-            <a:avLst/>
-          </a:prstGeom>
-          <a:noFill/>
-        </p:spPr>
-        <p:txBody>
-          <a:bodyPr wrap="square" anchor="t" lIns="45720" rIns="45720">
-            <a:spAutoFit/>
-          </a:bodyPr>
-          <a:lstStyle/>
-          <a:p>
-            <a:pPr algn="r"/>
-            <a:r>
-              <a:rPr sz="1000" b="0">
-                <a:solidFill>
-                  <a:srgbClr val="5B6775"/>
-                </a:solidFill>
-                <a:latin typeface="Segoe UI"/>
-              </a:rPr>
-              <a:t>34</a:t>
-            </a:r>
-          </a:p>
-        </p:txBody>
-      </p:sp>
-      <p:sp>
-        <p:nvSpPr>
-          <p:cNvPr id="7" name="Rectangle 6"/>
+          <p:cNvPr id="3" name="Rectangle 2"/>
           <p:cNvSpPr/>
           <p:nvPr/>
         </p:nvSpPr>
         <p:spPr>
           <a:xfrm>
-            <a:off x="411480" y="1097280"/>
-            <a:ext cx="6366491" cy="5349240"/>
+            <a:off x="822960" y="3246120"/>
+            <a:ext cx="1280160" cy="73152"/>
           </a:xfrm>
           <a:prstGeom prst="rect">
             <a:avLst/>
           </a:prstGeom>
           <a:solidFill>
-            <a:srgbClr val="F7F9FC"/>
+            <a:srgbClr val="1F3A5F"/>
           </a:solidFill>
           <a:ln>
-            <a:solidFill>
-              <a:srgbClr val="D9E2EC"/>
-            </a:solidFill>
+            <a:noFill/>
           </a:ln>
         </p:spPr>
         <p:style>
@@ -11119,14 +11035,14 @@
       </p:sp>
       <p:sp>
         <p:nvSpPr>
-          <p:cNvPr id="8" name="TextBox 7"/>
+          <p:cNvPr id="4" name="TextBox 3"/>
           <p:cNvSpPr txBox="1"/>
           <p:nvPr/>
         </p:nvSpPr>
         <p:spPr>
           <a:xfrm>
-            <a:off x="548640" y="1188720"/>
-            <a:ext cx="6092171" cy="5166360"/>
+            <a:off x="822960" y="2194560"/>
+            <a:ext cx="10515600" cy="1005840"/>
           </a:xfrm>
           <a:prstGeom prst="rect">
             <a:avLst/>
@@ -11141,123 +11057,27 @@
           <a:p>
             <a:pPr algn="l"/>
             <a:r>
-              <a:rPr sz="1700" b="0">
-                <a:solidFill>
-                  <a:srgbClr val="222B36"/>
-                </a:solidFill>
-                <a:latin typeface="Consolas"/>
-              </a:rPr>
-              <a:t>// a comment</a:t>
-            </a:r>
-          </a:p>
-          <a:p>
-            <a:pPr algn="l"/>
-            <a:r>
-              <a:rPr sz="1700" b="0">
-                <a:solidFill>
-                  <a:srgbClr val="222B36"/>
-                </a:solidFill>
-                <a:latin typeface="Consolas"/>
-              </a:rPr>
-              <a:t>VAR_IN  OCC_12 OCC_13 SWREV_12</a:t>
-            </a:r>
-          </a:p>
-          <a:p>
-            <a:pPr algn="l"/>
-            <a:r>
-              <a:rPr sz="1700" b="0">
-                <a:solidFill>
-                  <a:srgbClr val="222B36"/>
-                </a:solidFill>
-                <a:latin typeface="Consolas"/>
-              </a:rPr>
-              <a:t>VAR_IN  CTCSW_12 CTCREV_12</a:t>
-            </a:r>
-          </a:p>
-          <a:p>
-            <a:pPr algn="l"/>
-            <a:r>
-              <a:rPr sz="1700" b="0">
-                <a:solidFill>
-                  <a:srgbClr val="222B36"/>
-                </a:solidFill>
-                <a:latin typeface="Consolas"/>
-              </a:rPr>
-              <a:t>VAR_OUT SW_12</a:t>
-            </a:r>
-          </a:p>
-          <a:p>
-            <a:pPr algn="l"/>
-            <a:r>
-              <a:rPr sz="1700" b="0">
-                <a:solidFill>
-                  <a:srgbClr val="222B36"/>
-                </a:solidFill>
-                <a:latin typeface="Consolas"/>
-              </a:rPr>
-              <a:t/>
-            </a:r>
-          </a:p>
-          <a:p>
-            <a:pPr algn="l"/>
-            <a:r>
-              <a:rPr sz="1700" b="0">
-                <a:solidFill>
-                  <a:srgbClr val="222B36"/>
-                </a:solidFill>
-                <a:latin typeface="Consolas"/>
-              </a:rPr>
-              <a:t>LOCK_12 := OCC_12 OR OCC_13</a:t>
-            </a:r>
-          </a:p>
-          <a:p>
-            <a:pPr algn="l"/>
-            <a:r>
-              <a:rPr sz="1700" b="0">
-                <a:solidFill>
-                  <a:srgbClr val="222B36"/>
-                </a:solidFill>
-                <a:latin typeface="Consolas"/>
-              </a:rPr>
-              <a:t>WANT_12 := CTCSW_12 AND CTCREV_12</a:t>
-            </a:r>
-          </a:p>
-          <a:p>
-            <a:pPr algn="l"/>
-            <a:r>
-              <a:rPr sz="1700" b="0">
-                <a:solidFill>
-                  <a:srgbClr val="222B36"/>
-                </a:solidFill>
-                <a:latin typeface="Consolas"/>
-              </a:rPr>
-              <a:t>SW_12   := (LOCK_12 AND SWREV_12)</a:t>
-            </a:r>
-          </a:p>
-          <a:p>
-            <a:pPr algn="l"/>
-            <a:r>
-              <a:rPr sz="1700" b="0">
-                <a:solidFill>
-                  <a:srgbClr val="222B36"/>
-                </a:solidFill>
-                <a:latin typeface="Consolas"/>
-              </a:rPr>
-              <a:t>           OR (NOT LOCK_12 AND WANT_12)</a:t>
-            </a:r>
-          </a:p>
-        </p:txBody>
-      </p:sp>
-      <p:sp>
-        <p:nvSpPr>
-          <p:cNvPr id="9" name="TextBox 8"/>
+              <a:rPr sz="4000" b="1">
+                <a:solidFill>
+                  <a:srgbClr val="1F3A5F"/>
+                </a:solidFill>
+                <a:latin typeface="Segoe UI"/>
+              </a:rPr>
+              <a:t>System concepts</a:t>
+            </a:r>
+          </a:p>
+        </p:txBody>
+      </p:sp>
+      <p:sp>
+        <p:nvSpPr>
+          <p:cNvPr id="5" name="TextBox 4"/>
           <p:cNvSpPr txBox="1"/>
           <p:nvPr/>
         </p:nvSpPr>
         <p:spPr>
           <a:xfrm>
-            <a:off x="7052291" y="1097280"/>
-            <a:ext cx="4727924" cy="5349240"/>
+            <a:off x="822960" y="3474720"/>
+            <a:ext cx="10515600" cy="914400"/>
           </a:xfrm>
           <a:prstGeom prst="rect">
             <a:avLst/>
@@ -11265,88 +11085,20 @@
           <a:noFill/>
         </p:spPr>
         <p:txBody>
-          <a:bodyPr wrap="square">
+          <a:bodyPr wrap="square" anchor="t" lIns="45720" rIns="45720">
             <a:spAutoFit/>
           </a:bodyPr>
           <a:lstStyle/>
           <a:p>
-            <a:pPr>
-              <a:spcAft>
-                <a:spcPts val="800"/>
-              </a:spcAft>
-            </a:pPr>
-            <a:r>
-              <a:rPr sz="1900">
-                <a:solidFill>
-                  <a:srgbClr val="222B36"/>
-                </a:solidFill>
-                <a:latin typeface="Segoe UI"/>
-              </a:rPr>
-              <a:t>•  Boolean only: NOT, AND, XOR, OR, 0, 1, parentheses</a:t>
-            </a:r>
-          </a:p>
-          <a:p>
-            <a:pPr>
-              <a:spcAft>
-                <a:spcPts val="800"/>
-              </a:spcAft>
-            </a:pPr>
-            <a:r>
-              <a:rPr sz="1900">
-                <a:solidFill>
-                  <a:srgbClr val="222B36"/>
-                </a:solidFill>
-                <a:latin typeface="Segoe UI"/>
-              </a:rPr>
-              <a:t>•  Runs top to bottom once per tick; an unset name reads 0</a:t>
-            </a:r>
-          </a:p>
-          <a:p>
-            <a:pPr>
-              <a:spcAft>
-                <a:spcPts val="800"/>
-              </a:spcAft>
-            </a:pPr>
-            <a:r>
-              <a:rPr sz="1900">
-                <a:solidFill>
-                  <a:srgbClr val="222B36"/>
-                </a:solidFill>
-                <a:latin typeface="Segoe UI"/>
-              </a:rPr>
-              <a:t>•  Speed crosses in and out as five bits (SPD_n_0..4, CMD_n_0..4)</a:t>
-            </a:r>
-          </a:p>
-          <a:p>
-            <a:pPr>
-              <a:spcAft>
-                <a:spcPts val="800"/>
-              </a:spcAft>
-            </a:pPr>
-            <a:r>
-              <a:rPr sz="1900">
-                <a:solidFill>
-                  <a:srgbClr val="222B36"/>
-                </a:solidFill>
-                <a:latin typeface="Segoe UI"/>
-              </a:rPr>
-              <a:t>•  Every error reported with its line number; a program naming I/O its wayside lacks is refused</a:t>
-            </a:r>
-          </a:p>
-          <a:p>
-            <a:pPr>
-              <a:spcAft>
-                <a:spcPts val="800"/>
-              </a:spcAft>
-            </a:pPr>
-            <a:r>
-              <a:rPr sz="1900">
-                <a:solidFill>
-                  <a:srgbClr val="222B36"/>
-                </a:solidFill>
-                <a:latin typeface="Segoe UI"/>
-              </a:rPr>
-              <a:t>•  Shared with the SW variant; the names still differ</a:t>
+            <a:pPr algn="l"/>
+            <a:r>
+              <a:rPr sz="2000" b="0">
+                <a:solidFill>
+                  <a:srgbClr val="5B6775"/>
+                </a:solidFill>
+                <a:latin typeface="Segoe UI"/>
+              </a:rPr>
+              <a:t>Track Controller's part of the joint concepts, with Harry and Landis</a:t>
             </a:r>
           </a:p>
         </p:txBody>
@@ -11442,7 +11194,7 @@
                 </a:solidFill>
                 <a:latin typeface="Segoe UI"/>
               </a:rPr>
-              <a:t>Vitality</a:t>
+              <a:t>Distribution of wayside controllers</a:t>
             </a:r>
           </a:p>
         </p:txBody>
@@ -11586,7 +11338,7 @@
                 </a:solidFill>
                 <a:latin typeface="Segoe UI"/>
               </a:rPr>
-              <a:t>•  The OS only holds and parses the PLC program: every decision is PLC code</a:t>
+              <a:t>•  One variant per line: HW runs the Red Line, SW the Green Line (D021)</a:t>
             </a:r>
           </a:p>
           <a:p>
@@ -11602,7 +11354,39 @@
                 </a:solidFill>
                 <a:latin typeface="Segoe UI"/>
               </a:rPr>
-              <a:t>•  Read-only vital block after the user's program «planned»</a:t>
+              <a:t>•  A wayside owns a contiguous run of blocks and every switch, signal and crossing on them</a:t>
+            </a:r>
+          </a:p>
+          <a:p>
+            <a:pPr>
+              <a:spcAft>
+                <a:spcPts val="800"/>
+              </a:spcAft>
+            </a:pPr>
+            <a:r>
+              <a:rPr sz="2400">
+                <a:solidFill>
+                  <a:srgbClr val="222B36"/>
+                </a:solidFill>
+                <a:latin typeface="Segoe UI"/>
+              </a:rPr>
+              <a:t>•  One Raspberry Pi 5 runs every Red Line wayside</a:t>
+            </a:r>
+          </a:p>
+          <a:p>
+            <a:pPr>
+              <a:spcAft>
+                <a:spcPts val="800"/>
+              </a:spcAft>
+            </a:pPr>
+            <a:r>
+              <a:rPr sz="2400">
+                <a:solidFill>
+                  <a:srgbClr val="222B36"/>
+                </a:solidFill>
+                <a:latin typeface="Segoe UI"/>
+              </a:rPr>
+              <a:t>•  A line runs only when every wayside on it is ready</a:t>
             </a:r>
           </a:p>
           <a:p>
@@ -11618,7 +11402,23 @@
                 </a:solidFill>
                 <a:latin typeface="Segoe UI"/>
               </a:rPr>
-              <a:t>–  Generated per territory; can only make outputs more restrictive</a:t>
+              <a:t>–  Ready: a person has loaded the database and the PLC program, and the channels agree</a:t>
+            </a:r>
+          </a:p>
+          <a:p>
+            <a:pPr lvl="1">
+              <a:spcAft>
+                <a:spcPts val="400"/>
+              </a:spcAft>
+            </a:pPr>
+            <a:r>
+              <a:rPr sz="2100">
+                <a:solidFill>
+                  <a:srgbClr val="5B6775"/>
+                </a:solidFill>
+                <a:latin typeface="Segoe UI"/>
+              </a:rPr>
+              <a:t>–  Not ready anywhere on the line: the whole line holds fail-safe and the CTC dispatches nothing</a:t>
             </a:r>
           </a:p>
           <a:p>
@@ -11634,55 +11434,7 @@
                 </a:solidFill>
                 <a:latin typeface="Segoe UI"/>
               </a:rPr>
-              <a:t>•  Diverse execution: two compilers, two interpreters, compared every scan</a:t>
-            </a:r>
-          </a:p>
-          <a:p>
-            <a:pPr>
-              <a:spcAft>
-                <a:spcPts val="800"/>
-              </a:spcAft>
-            </a:pPr>
-            <a:r>
-              <a:rPr sz="2400">
-                <a:solidFill>
-                  <a:srgbClr val="222B36"/>
-                </a:solidFill>
-                <a:latin typeface="Segoe UI"/>
-              </a:rPr>
-              <a:t>•  Diverse implementations: HW and SW share a language, not code</a:t>
-            </a:r>
-          </a:p>
-          <a:p>
-            <a:pPr>
-              <a:spcAft>
-                <a:spcPts val="800"/>
-              </a:spcAft>
-            </a:pPr>
-            <a:r>
-              <a:rPr sz="2400">
-                <a:solidFill>
-                  <a:srgbClr val="222B36"/>
-                </a:solidFill>
-                <a:latin typeface="Segoe UI"/>
-              </a:rPr>
-              <a:t>•  Fail-safe outputs: signals red, crossings active, speed and authority 0, switches stay</a:t>
-            </a:r>
-          </a:p>
-          <a:p>
-            <a:pPr>
-              <a:spcAft>
-                <a:spcPts val="800"/>
-              </a:spcAft>
-            </a:pPr>
-            <a:r>
-              <a:rPr sz="2400">
-                <a:solidFill>
-                  <a:srgbClr val="222B36"/>
-                </a:solidFill>
-                <a:latin typeface="Segoe UI"/>
-              </a:rPr>
-              <a:t>•  Inputs checked whole before anything changes; a failure reads as occupancy</a:t>
+              <a:t>•  Red Line boundaries: to be chosen; a switch must lie inside one wayside</a:t>
             </a:r>
           </a:p>
         </p:txBody>
@@ -11778,7 +11530,7 @@
                 </a:solidFill>
                 <a:latin typeface="Segoe UI"/>
               </a:rPr>
-              <a:t>Hardware/software interface</a:t>
+              <a:t>Authority, as the wayside handles it</a:t>
             </a:r>
           </a:p>
         </p:txBody>
@@ -11922,7 +11674,7 @@
                 </a:solidFill>
                 <a:latin typeface="Segoe UI"/>
               </a:rPr>
-              <a:t>•  Same TrackController Protocol and the same I/O in both variants (D021)</a:t>
+              <a:t>•  Authority = blocks ahead the train may still enter; 0 = stop (D013)</a:t>
             </a:r>
           </a:p>
           <a:p>
@@ -11938,7 +11690,23 @@
                 </a:solidFill>
                 <a:latin typeface="Segoe UI"/>
               </a:rPr>
-              <a:t>•  Pi 5 in USB device mode: a standard USB serial (CDC-ACM) device (D027)</a:t>
+              <a:t>•  CTC Office computes it along the route and suggests it per block</a:t>
+            </a:r>
+          </a:p>
+          <a:p>
+            <a:pPr>
+              <a:spcAft>
+                <a:spcPts val="800"/>
+              </a:spcAft>
+            </a:pPr>
+            <a:r>
+              <a:rPr sz="2400">
+                <a:solidFill>
+                  <a:srgbClr val="222B36"/>
+                </a:solidFill>
+                <a:latin typeface="Segoe UI"/>
+              </a:rPr>
+              <a:t>•  The program's AUTH_n passes the CTC count down block n's track circuit, or sends 0</a:t>
             </a:r>
           </a:p>
           <a:p>
@@ -11954,23 +11722,7 @@
                 </a:solidFill>
                 <a:latin typeface="Segoe UI"/>
               </a:rPr>
-              <a:t>–  Windows' built-in driver: no installation, no admin rights</a:t>
-            </a:r>
-          </a:p>
-          <a:p>
-            <a:pPr lvl="1">
-              <a:spcAft>
-                <a:spcPts val="400"/>
-              </a:spcAft>
-            </a:pPr>
-            <a:r>
-              <a:rPr sz="2100">
-                <a:solidFill>
-                  <a:srgbClr val="5B6775"/>
-                </a:solidFill>
-                <a:latin typeface="Segoe UI"/>
-              </a:rPr>
-              <a:t>–  Found by its USB identity, never a fixed COM number</a:t>
+              <a:t>–  Withheld for a closed block, a switch not where commanded, an occupied neighbour</a:t>
             </a:r>
           </a:p>
           <a:p>
@@ -11986,7 +11738,7 @@
                 </a:solidFill>
                 <a:latin typeface="Segoe UI"/>
               </a:rPr>
-              <a:t>•  Messages: the harness's newline JSON, with request ID and tick</a:t>
+              <a:t>•  Speed travels with it as five bits, capped at the block's limit</a:t>
             </a:r>
           </a:p>
           <a:p>
@@ -12002,23 +11754,7 @@
                 </a:solidFill>
                 <a:latin typeface="Segoe UI"/>
               </a:rPr>
-              <a:t>•  The PC process owns the COM port and relays harness messages to the Pi</a:t>
-            </a:r>
-          </a:p>
-          <a:p>
-            <a:pPr>
-              <a:spcAft>
-                <a:spcPts val="800"/>
-              </a:spcAft>
-            </a:pPr>
-            <a:r>
-              <a:rPr sz="2400">
-                <a:solidFill>
-                  <a:srgbClr val="222B36"/>
-                </a:solidFill>
-                <a:latin typeface="Segoe UI"/>
-              </a:rPr>
-              <a:t>•  10x: 100 ticks per second, so USB round trip + scan &lt; 10 ms</a:t>
+              <a:t>•  Track Model delivers both to the train in the block, then clears them</a:t>
             </a:r>
           </a:p>
         </p:txBody>
@@ -12050,13 +11786,13 @@
         <p:spPr>
           <a:xfrm>
             <a:off x="0" y="0"/>
-            <a:ext cx="12191695" cy="6858000"/>
+            <a:ext cx="12191695" cy="868680"/>
           </a:xfrm>
           <a:prstGeom prst="rect">
             <a:avLst/>
           </a:prstGeom>
           <a:solidFill>
-            <a:srgbClr val="F7F9FC"/>
+            <a:srgbClr val="1F3A5F"/>
           </a:solidFill>
           <a:ln>
             <a:noFill/>
@@ -12086,23 +11822,165 @@
       </p:sp>
       <p:sp>
         <p:nvSpPr>
-          <p:cNvPr id="3" name="Rectangle 2"/>
+          <p:cNvPr id="3" name="TextBox 2"/>
+          <p:cNvSpPr txBox="1"/>
+          <p:nvPr/>
+        </p:nvSpPr>
+        <p:spPr>
+          <a:xfrm>
+            <a:off x="411480" y="109728"/>
+            <a:ext cx="11368735" cy="685800"/>
+          </a:xfrm>
+          <a:prstGeom prst="rect">
+            <a:avLst/>
+          </a:prstGeom>
+          <a:noFill/>
+        </p:spPr>
+        <p:txBody>
+          <a:bodyPr wrap="square" anchor="ctr" lIns="45720" rIns="45720">
+            <a:spAutoFit/>
+          </a:bodyPr>
+          <a:lstStyle/>
+          <a:p>
+            <a:pPr algn="l"/>
+            <a:r>
+              <a:rPr sz="2800" b="1">
+                <a:solidFill>
+                  <a:srgbClr val="FFFFFF"/>
+                </a:solidFill>
+                <a:latin typeface="Segoe UI"/>
+              </a:rPr>
+              <a:t>Wayside language</a:t>
+            </a:r>
+          </a:p>
+        </p:txBody>
+      </p:sp>
+      <p:sp>
+        <p:nvSpPr>
+          <p:cNvPr id="4" name="TextBox 3"/>
+          <p:cNvSpPr txBox="1"/>
+          <p:nvPr/>
+        </p:nvSpPr>
+        <p:spPr>
+          <a:xfrm>
+            <a:off x="8351215" y="109728"/>
+            <a:ext cx="3474720" cy="685800"/>
+          </a:xfrm>
+          <a:prstGeom prst="rect">
+            <a:avLst/>
+          </a:prstGeom>
+          <a:noFill/>
+        </p:spPr>
+        <p:txBody>
+          <a:bodyPr wrap="square" anchor="ctr" lIns="45720" rIns="45720">
+            <a:spAutoFit/>
+          </a:bodyPr>
+          <a:lstStyle/>
+          <a:p>
+            <a:pPr algn="r"/>
+            <a:r>
+              <a:rPr sz="1200" b="0">
+                <a:solidFill>
+                  <a:srgbClr val="D9E2EC"/>
+                </a:solidFill>
+                <a:latin typeface="Segoe UI"/>
+              </a:rPr>
+              <a:t>System concepts</a:t>
+            </a:r>
+          </a:p>
+        </p:txBody>
+      </p:sp>
+      <p:sp>
+        <p:nvSpPr>
+          <p:cNvPr id="5" name="TextBox 4"/>
+          <p:cNvSpPr txBox="1"/>
+          <p:nvPr/>
+        </p:nvSpPr>
+        <p:spPr>
+          <a:xfrm>
+            <a:off x="411480" y="6537960"/>
+            <a:ext cx="8229600" cy="320040"/>
+          </a:xfrm>
+          <a:prstGeom prst="rect">
+            <a:avLst/>
+          </a:prstGeom>
+          <a:noFill/>
+        </p:spPr>
+        <p:txBody>
+          <a:bodyPr wrap="square" anchor="t" lIns="45720" rIns="45720">
+            <a:spAutoFit/>
+          </a:bodyPr>
+          <a:lstStyle/>
+          <a:p>
+            <a:pPr algn="l"/>
+            <a:r>
+              <a:rPr sz="1000" b="0">
+                <a:solidFill>
+                  <a:srgbClr val="5B6775"/>
+                </a:solidFill>
+                <a:latin typeface="Segoe UI"/>
+              </a:rPr>
+              <a:t>Track Overflow · Design Review · Track Controller (HW) · Braden</a:t>
+            </a:r>
+          </a:p>
+        </p:txBody>
+      </p:sp>
+      <p:sp>
+        <p:nvSpPr>
+          <p:cNvPr id="6" name="TextBox 5"/>
+          <p:cNvSpPr txBox="1"/>
+          <p:nvPr/>
+        </p:nvSpPr>
+        <p:spPr>
+          <a:xfrm>
+            <a:off x="10820095" y="6537960"/>
+            <a:ext cx="960120" cy="320040"/>
+          </a:xfrm>
+          <a:prstGeom prst="rect">
+            <a:avLst/>
+          </a:prstGeom>
+          <a:noFill/>
+        </p:spPr>
+        <p:txBody>
+          <a:bodyPr wrap="square" anchor="t" lIns="45720" rIns="45720">
+            <a:spAutoFit/>
+          </a:bodyPr>
+          <a:lstStyle/>
+          <a:p>
+            <a:pPr algn="r"/>
+            <a:r>
+              <a:rPr sz="1000" b="0">
+                <a:solidFill>
+                  <a:srgbClr val="5B6775"/>
+                </a:solidFill>
+                <a:latin typeface="Segoe UI"/>
+              </a:rPr>
+              <a:t>37</a:t>
+            </a:r>
+          </a:p>
+        </p:txBody>
+      </p:sp>
+      <p:sp>
+        <p:nvSpPr>
+          <p:cNvPr id="7" name="Rectangle 6"/>
           <p:cNvSpPr/>
           <p:nvPr/>
         </p:nvSpPr>
         <p:spPr>
           <a:xfrm>
-            <a:off x="822960" y="3246120"/>
-            <a:ext cx="1280160" cy="73152"/>
+            <a:off x="411480" y="1097280"/>
+            <a:ext cx="6366491" cy="5349240"/>
           </a:xfrm>
           <a:prstGeom prst="rect">
             <a:avLst/>
           </a:prstGeom>
           <a:solidFill>
-            <a:srgbClr val="1F3A5F"/>
+            <a:srgbClr val="F7F9FC"/>
           </a:solidFill>
           <a:ln>
-            <a:noFill/>
+            <a:solidFill>
+              <a:srgbClr val="D9E2EC"/>
+            </a:solidFill>
           </a:ln>
         </p:spPr>
         <p:style>
@@ -12129,14 +12007,14 @@
       </p:sp>
       <p:sp>
         <p:nvSpPr>
-          <p:cNvPr id="4" name="TextBox 3"/>
+          <p:cNvPr id="8" name="TextBox 7"/>
           <p:cNvSpPr txBox="1"/>
           <p:nvPr/>
         </p:nvSpPr>
         <p:spPr>
           <a:xfrm>
-            <a:off x="822960" y="2194560"/>
-            <a:ext cx="10515600" cy="1005840"/>
+            <a:off x="548640" y="1188720"/>
+            <a:ext cx="6092171" cy="5166360"/>
           </a:xfrm>
           <a:prstGeom prst="rect">
             <a:avLst/>
@@ -12151,13 +12029,212 @@
           <a:p>
             <a:pPr algn="l"/>
             <a:r>
-              <a:rPr sz="4000" b="1">
-                <a:solidFill>
-                  <a:srgbClr val="1F3A5F"/>
-                </a:solidFill>
-                <a:latin typeface="Segoe UI"/>
-              </a:rPr>
-              <a:t>Open items</a:t>
+              <a:rPr sz="1700" b="0">
+                <a:solidFill>
+                  <a:srgbClr val="222B36"/>
+                </a:solidFill>
+                <a:latin typeface="Consolas"/>
+              </a:rPr>
+              <a:t>// a comment</a:t>
+            </a:r>
+          </a:p>
+          <a:p>
+            <a:pPr algn="l"/>
+            <a:r>
+              <a:rPr sz="1700" b="0">
+                <a:solidFill>
+                  <a:srgbClr val="222B36"/>
+                </a:solidFill>
+                <a:latin typeface="Consolas"/>
+              </a:rPr>
+              <a:t>VAR_IN  OCC_12 OCC_13 SWREV_12</a:t>
+            </a:r>
+          </a:p>
+          <a:p>
+            <a:pPr algn="l"/>
+            <a:r>
+              <a:rPr sz="1700" b="0">
+                <a:solidFill>
+                  <a:srgbClr val="222B36"/>
+                </a:solidFill>
+                <a:latin typeface="Consolas"/>
+              </a:rPr>
+              <a:t>VAR_IN  CTCSW_12 CTCREV_12</a:t>
+            </a:r>
+          </a:p>
+          <a:p>
+            <a:pPr algn="l"/>
+            <a:r>
+              <a:rPr sz="1700" b="0">
+                <a:solidFill>
+                  <a:srgbClr val="222B36"/>
+                </a:solidFill>
+                <a:latin typeface="Consolas"/>
+              </a:rPr>
+              <a:t>VAR_OUT SW_12</a:t>
+            </a:r>
+          </a:p>
+          <a:p>
+            <a:pPr algn="l"/>
+            <a:r>
+              <a:rPr sz="1700" b="0">
+                <a:solidFill>
+                  <a:srgbClr val="222B36"/>
+                </a:solidFill>
+                <a:latin typeface="Consolas"/>
+              </a:rPr>
+              <a:t/>
+            </a:r>
+          </a:p>
+          <a:p>
+            <a:pPr algn="l"/>
+            <a:r>
+              <a:rPr sz="1700" b="0">
+                <a:solidFill>
+                  <a:srgbClr val="222B36"/>
+                </a:solidFill>
+                <a:latin typeface="Consolas"/>
+              </a:rPr>
+              <a:t>LOCK_12 := OCC_12 OR OCC_13</a:t>
+            </a:r>
+          </a:p>
+          <a:p>
+            <a:pPr algn="l"/>
+            <a:r>
+              <a:rPr sz="1700" b="0">
+                <a:solidFill>
+                  <a:srgbClr val="222B36"/>
+                </a:solidFill>
+                <a:latin typeface="Consolas"/>
+              </a:rPr>
+              <a:t>WANT_12 := CTCSW_12 AND CTCREV_12</a:t>
+            </a:r>
+          </a:p>
+          <a:p>
+            <a:pPr algn="l"/>
+            <a:r>
+              <a:rPr sz="1700" b="0">
+                <a:solidFill>
+                  <a:srgbClr val="222B36"/>
+                </a:solidFill>
+                <a:latin typeface="Consolas"/>
+              </a:rPr>
+              <a:t>SW_12   := (LOCK_12 AND SWREV_12)</a:t>
+            </a:r>
+          </a:p>
+          <a:p>
+            <a:pPr algn="l"/>
+            <a:r>
+              <a:rPr sz="1700" b="0">
+                <a:solidFill>
+                  <a:srgbClr val="222B36"/>
+                </a:solidFill>
+                <a:latin typeface="Consolas"/>
+              </a:rPr>
+              <a:t>           OR (NOT LOCK_12 AND WANT_12)</a:t>
+            </a:r>
+          </a:p>
+        </p:txBody>
+      </p:sp>
+      <p:sp>
+        <p:nvSpPr>
+          <p:cNvPr id="9" name="TextBox 8"/>
+          <p:cNvSpPr txBox="1"/>
+          <p:nvPr/>
+        </p:nvSpPr>
+        <p:spPr>
+          <a:xfrm>
+            <a:off x="7052291" y="1097280"/>
+            <a:ext cx="4727924" cy="5349240"/>
+          </a:xfrm>
+          <a:prstGeom prst="rect">
+            <a:avLst/>
+          </a:prstGeom>
+          <a:noFill/>
+        </p:spPr>
+        <p:txBody>
+          <a:bodyPr wrap="square">
+            <a:spAutoFit/>
+          </a:bodyPr>
+          <a:lstStyle/>
+          <a:p>
+            <a:pPr>
+              <a:spcAft>
+                <a:spcPts val="800"/>
+              </a:spcAft>
+            </a:pPr>
+            <a:r>
+              <a:rPr sz="1900">
+                <a:solidFill>
+                  <a:srgbClr val="222B36"/>
+                </a:solidFill>
+                <a:latin typeface="Segoe UI"/>
+              </a:rPr>
+              <a:t>•  Boolean only: NOT, AND, XOR, OR, 0, 1, parentheses</a:t>
+            </a:r>
+          </a:p>
+          <a:p>
+            <a:pPr>
+              <a:spcAft>
+                <a:spcPts val="800"/>
+              </a:spcAft>
+            </a:pPr>
+            <a:r>
+              <a:rPr sz="1900">
+                <a:solidFill>
+                  <a:srgbClr val="222B36"/>
+                </a:solidFill>
+                <a:latin typeface="Segoe UI"/>
+              </a:rPr>
+              <a:t>•  Runs top to bottom once per tick; an unset name reads 0</a:t>
+            </a:r>
+          </a:p>
+          <a:p>
+            <a:pPr>
+              <a:spcAft>
+                <a:spcPts val="800"/>
+              </a:spcAft>
+            </a:pPr>
+            <a:r>
+              <a:rPr sz="1900">
+                <a:solidFill>
+                  <a:srgbClr val="222B36"/>
+                </a:solidFill>
+                <a:latin typeface="Segoe UI"/>
+              </a:rPr>
+              <a:t>•  Speed crosses in and out as five bits (SPD_n_0..4, CMD_n_0..4)</a:t>
+            </a:r>
+          </a:p>
+          <a:p>
+            <a:pPr>
+              <a:spcAft>
+                <a:spcPts val="800"/>
+              </a:spcAft>
+            </a:pPr>
+            <a:r>
+              <a:rPr sz="1900">
+                <a:solidFill>
+                  <a:srgbClr val="222B36"/>
+                </a:solidFill>
+                <a:latin typeface="Segoe UI"/>
+              </a:rPr>
+              <a:t>•  Every error reported with its line number; a program naming I/O its wayside lacks is refused</a:t>
+            </a:r>
+          </a:p>
+          <a:p>
+            <a:pPr>
+              <a:spcAft>
+                <a:spcPts val="800"/>
+              </a:spcAft>
+            </a:pPr>
+            <a:r>
+              <a:rPr sz="1900">
+                <a:solidFill>
+                  <a:srgbClr val="222B36"/>
+                </a:solidFill>
+                <a:latin typeface="Segoe UI"/>
+              </a:rPr>
+              <a:t>•  Shared with the SW variant; the names still differ</a:t>
             </a:r>
           </a:p>
         </p:txBody>
@@ -12253,7 +12330,7 @@
                 </a:solidFill>
                 <a:latin typeface="Segoe UI"/>
               </a:rPr>
-              <a:t>Open items</a:t>
+              <a:t>Vitality</a:t>
             </a:r>
           </a:p>
         </p:txBody>
@@ -12288,7 +12365,7 @@
                 </a:solidFill>
                 <a:latin typeface="Segoe UI"/>
               </a:rPr>
-              <a:t>Open items</a:t>
+              <a:t>System concepts</a:t>
             </a:r>
           </a:p>
         </p:txBody>
@@ -12363,645 +12440,477 @@
           </a:p>
         </p:txBody>
       </p:sp>
-      <p:graphicFrame>
-        <p:nvGraphicFramePr>
-          <p:cNvPr id="7" name="Table 6"/>
-          <p:cNvGraphicFramePr>
-            <a:graphicFrameLocks noGrp="1"/>
-          </p:cNvGraphicFramePr>
-          <p:nvPr/>
-        </p:nvGraphicFramePr>
-        <p:xfrm>
-          <a:off x="411480" y="1097280"/>
-          <a:ext cx="11338560" cy="3291840"/>
-        </p:xfrm>
-        <a:graphic>
-          <a:graphicData uri="http://schemas.openxmlformats.org/drawingml/2006/table">
-            <a:tbl>
-              <a:tblPr firstRow="1" bandRow="1">
-                <a:tableStyleId>{5C22544A-7EE6-4342-B048-85BDC9FD1C3A}</a:tableStyleId>
-              </a:tblPr>
-              <a:tblGrid>
-                <a:gridCol w="548640"/>
-                <a:gridCol w="8412480"/>
-                <a:gridCol w="2377440"/>
-              </a:tblGrid>
-              <a:tr h="365760">
-                <a:tc>
-                  <a:txBody>
-                    <a:bodyPr wrap="square"/>
-                    <a:lstStyle/>
-                    <a:p>
-                      <a:r>
-                        <a:rPr sz="1600" b="1">
-                          <a:solidFill>
-                            <a:srgbClr val="FFFFFF"/>
-                          </a:solidFill>
-                          <a:latin typeface="Segoe UI"/>
-                        </a:rPr>
-                        <a:t>#</a:t>
-                      </a:r>
-                    </a:p>
-                  </a:txBody>
-                  <a:tcPr marL="73152" marR="73152" marT="36576" marB="36576">
-                    <a:solidFill>
-                      <a:srgbClr val="1F3A5F"/>
-                    </a:solidFill>
-                  </a:tcPr>
-                </a:tc>
-                <a:tc>
-                  <a:txBody>
-                    <a:bodyPr wrap="square"/>
-                    <a:lstStyle/>
-                    <a:p>
-                      <a:r>
-                        <a:rPr sz="1600" b="1">
-                          <a:solidFill>
-                            <a:srgbClr val="FFFFFF"/>
-                          </a:solidFill>
-                          <a:latin typeface="Segoe UI"/>
-                        </a:rPr>
-                        <a:t>Item</a:t>
-                      </a:r>
-                    </a:p>
-                  </a:txBody>
-                  <a:tcPr marL="73152" marR="73152" marT="36576" marB="36576">
-                    <a:solidFill>
-                      <a:srgbClr val="1F3A5F"/>
-                    </a:solidFill>
-                  </a:tcPr>
-                </a:tc>
-                <a:tc>
-                  <a:txBody>
-                    <a:bodyPr wrap="square"/>
-                    <a:lstStyle/>
-                    <a:p>
-                      <a:r>
-                        <a:rPr sz="1600" b="1">
-                          <a:solidFill>
-                            <a:srgbClr val="FFFFFF"/>
-                          </a:solidFill>
-                          <a:latin typeface="Segoe UI"/>
-                        </a:rPr>
-                        <a:t>Owner</a:t>
-                      </a:r>
-                    </a:p>
-                  </a:txBody>
-                  <a:tcPr marL="73152" marR="73152" marT="36576" marB="36576">
-                    <a:solidFill>
-                      <a:srgbClr val="1F3A5F"/>
-                    </a:solidFill>
-                  </a:tcPr>
-                </a:tc>
-              </a:tr>
-              <a:tr h="365760">
-                <a:tc>
-                  <a:txBody>
-                    <a:bodyPr wrap="square"/>
-                    <a:lstStyle/>
-                    <a:p>
-                      <a:r>
-                        <a:rPr sz="1600" b="0">
-                          <a:solidFill>
-                            <a:srgbClr val="222B36"/>
-                          </a:solidFill>
-                          <a:latin typeface="Segoe UI"/>
-                        </a:rPr>
-                        <a:t>1</a:t>
-                      </a:r>
-                    </a:p>
-                  </a:txBody>
-                  <a:tcPr marL="73152" marR="73152" marT="36576" marB="36576">
-                    <a:solidFill>
-                      <a:srgbClr val="F7F9FC"/>
-                    </a:solidFill>
-                  </a:tcPr>
-                </a:tc>
-                <a:tc>
-                  <a:txBody>
-                    <a:bodyPr wrap="square"/>
-                    <a:lstStyle/>
-                    <a:p>
-                      <a:r>
-                        <a:rPr sz="1600" b="0">
-                          <a:solidFill>
-                            <a:srgbClr val="222B36"/>
-                          </a:solidFill>
-                          <a:latin typeface="Segoe UI"/>
-                        </a:rPr>
-                        <a:t>Read-only vital PLC block: assumed, to confirm for both variants</a:t>
-                      </a:r>
-                    </a:p>
-                  </a:txBody>
-                  <a:tcPr marL="73152" marR="73152" marT="36576" marB="36576">
-                    <a:solidFill>
-                      <a:srgbClr val="F7F9FC"/>
-                    </a:solidFill>
-                  </a:tcPr>
-                </a:tc>
-                <a:tc>
-                  <a:txBody>
-                    <a:bodyPr wrap="square"/>
-                    <a:lstStyle/>
-                    <a:p>
-                      <a:r>
-                        <a:rPr sz="1600" b="0">
-                          <a:solidFill>
-                            <a:srgbClr val="222B36"/>
-                          </a:solidFill>
-                          <a:latin typeface="Segoe UI"/>
-                        </a:rPr>
-                        <a:t>Braden, Harry</a:t>
-                      </a:r>
-                    </a:p>
-                  </a:txBody>
-                  <a:tcPr marL="73152" marR="73152" marT="36576" marB="36576">
-                    <a:solidFill>
-                      <a:srgbClr val="F7F9FC"/>
-                    </a:solidFill>
-                  </a:tcPr>
-                </a:tc>
-              </a:tr>
-              <a:tr h="365760">
-                <a:tc>
-                  <a:txBody>
-                    <a:bodyPr wrap="square"/>
-                    <a:lstStyle/>
-                    <a:p>
-                      <a:r>
-                        <a:rPr sz="1600" b="0">
-                          <a:solidFill>
-                            <a:srgbClr val="222B36"/>
-                          </a:solidFill>
-                          <a:latin typeface="Segoe UI"/>
-                        </a:rPr>
-                        <a:t>2</a:t>
-                      </a:r>
-                    </a:p>
-                  </a:txBody>
-                  <a:tcPr marL="73152" marR="73152" marT="36576" marB="36576">
-                    <a:solidFill>
-                      <a:srgbClr val="FFFFFF"/>
-                    </a:solidFill>
-                  </a:tcPr>
-                </a:tc>
-                <a:tc>
-                  <a:txBody>
-                    <a:bodyPr wrap="square"/>
-                    <a:lstStyle/>
-                    <a:p>
-                      <a:r>
-                        <a:rPr sz="1600" b="0">
-                          <a:solidFill>
-                            <a:srgbClr val="222B36"/>
-                          </a:solidFill>
-                          <a:latin typeface="Segoe UI"/>
-                        </a:rPr>
-                        <a:t>Manual switch at the wayside in maintenance (rubric 6.8); assumed CTC only</a:t>
-                      </a:r>
-                    </a:p>
-                  </a:txBody>
-                  <a:tcPr marL="73152" marR="73152" marT="36576" marB="36576">
-                    <a:solidFill>
-                      <a:srgbClr val="FFFFFF"/>
-                    </a:solidFill>
-                  </a:tcPr>
-                </a:tc>
-                <a:tc>
-                  <a:txBody>
-                    <a:bodyPr wrap="square"/>
-                    <a:lstStyle/>
-                    <a:p>
-                      <a:r>
-                        <a:rPr sz="1600" b="0">
-                          <a:solidFill>
-                            <a:srgbClr val="222B36"/>
-                          </a:solidFill>
-                          <a:latin typeface="Segoe UI"/>
-                        </a:rPr>
-                        <a:t>Braden, Harry</a:t>
-                      </a:r>
-                    </a:p>
-                  </a:txBody>
-                  <a:tcPr marL="73152" marR="73152" marT="36576" marB="36576">
-                    <a:solidFill>
-                      <a:srgbClr val="FFFFFF"/>
-                    </a:solidFill>
-                  </a:tcPr>
-                </a:tc>
-              </a:tr>
-              <a:tr h="365760">
-                <a:tc>
-                  <a:txBody>
-                    <a:bodyPr wrap="square"/>
-                    <a:lstStyle/>
-                    <a:p>
-                      <a:r>
-                        <a:rPr sz="1600" b="0">
-                          <a:solidFill>
-                            <a:srgbClr val="222B36"/>
-                          </a:solidFill>
-                          <a:latin typeface="Segoe UI"/>
-                        </a:rPr>
-                        <a:t>3</a:t>
-                      </a:r>
-                    </a:p>
-                  </a:txBody>
-                  <a:tcPr marL="73152" marR="73152" marT="36576" marB="36576">
-                    <a:solidFill>
-                      <a:srgbClr val="F7F9FC"/>
-                    </a:solidFill>
-                  </a:tcPr>
-                </a:tc>
-                <a:tc>
-                  <a:txBody>
-                    <a:bodyPr wrap="square"/>
-                    <a:lstStyle/>
-                    <a:p>
-                      <a:r>
-                        <a:rPr sz="1600" b="0">
-                          <a:solidFill>
-                            <a:srgbClr val="222B36"/>
-                          </a:solidFill>
-                          <a:latin typeface="Segoe UI"/>
-                        </a:rPr>
-                        <a:t>Red Line wayside boundaries, databases and programs</a:t>
-                      </a:r>
-                    </a:p>
-                  </a:txBody>
-                  <a:tcPr marL="73152" marR="73152" marT="36576" marB="36576">
-                    <a:solidFill>
-                      <a:srgbClr val="F7F9FC"/>
-                    </a:solidFill>
-                  </a:tcPr>
-                </a:tc>
-                <a:tc>
-                  <a:txBody>
-                    <a:bodyPr wrap="square"/>
-                    <a:lstStyle/>
-                    <a:p>
-                      <a:r>
-                        <a:rPr sz="1600" b="0">
-                          <a:solidFill>
-                            <a:srgbClr val="222B36"/>
-                          </a:solidFill>
-                          <a:latin typeface="Segoe UI"/>
-                        </a:rPr>
-                        <a:t>Braden</a:t>
-                      </a:r>
-                    </a:p>
-                  </a:txBody>
-                  <a:tcPr marL="73152" marR="73152" marT="36576" marB="36576">
-                    <a:solidFill>
-                      <a:srgbClr val="F7F9FC"/>
-                    </a:solidFill>
-                  </a:tcPr>
-                </a:tc>
-              </a:tr>
-              <a:tr h="365760">
-                <a:tc>
-                  <a:txBody>
-                    <a:bodyPr wrap="square"/>
-                    <a:lstStyle/>
-                    <a:p>
-                      <a:r>
-                        <a:rPr sz="1600" b="0">
-                          <a:solidFill>
-                            <a:srgbClr val="222B36"/>
-                          </a:solidFill>
-                          <a:latin typeface="Segoe UI"/>
-                        </a:rPr>
-                        <a:t>4</a:t>
-                      </a:r>
-                    </a:p>
-                  </a:txBody>
-                  <a:tcPr marL="73152" marR="73152" marT="36576" marB="36576">
-                    <a:solidFill>
-                      <a:srgbClr val="FFFFFF"/>
-                    </a:solidFill>
-                  </a:tcPr>
-                </a:tc>
-                <a:tc>
-                  <a:txBody>
-                    <a:bodyPr wrap="square"/>
-                    <a:lstStyle/>
-                    <a:p>
-                      <a:r>
-                        <a:rPr sz="1600" b="0">
-                          <a:solidFill>
-                            <a:srgbClr val="222B36"/>
-                          </a:solidFill>
-                          <a:latin typeface="Segoe UI"/>
-                        </a:rPr>
-                        <a:t>USB message framing; the Pi's identification</a:t>
-                      </a:r>
-                    </a:p>
-                  </a:txBody>
-                  <a:tcPr marL="73152" marR="73152" marT="36576" marB="36576">
-                    <a:solidFill>
-                      <a:srgbClr val="FFFFFF"/>
-                    </a:solidFill>
-                  </a:tcPr>
-                </a:tc>
-                <a:tc>
-                  <a:txBody>
-                    <a:bodyPr wrap="square"/>
-                    <a:lstStyle/>
-                    <a:p>
-                      <a:r>
-                        <a:rPr sz="1600" b="0">
-                          <a:solidFill>
-                            <a:srgbClr val="222B36"/>
-                          </a:solidFill>
-                          <a:latin typeface="Segoe UI"/>
-                        </a:rPr>
-                        <a:t>Kevin, Braden</a:t>
-                      </a:r>
-                    </a:p>
-                  </a:txBody>
-                  <a:tcPr marL="73152" marR="73152" marT="36576" marB="36576">
-                    <a:solidFill>
-                      <a:srgbClr val="FFFFFF"/>
-                    </a:solidFill>
-                  </a:tcPr>
-                </a:tc>
-              </a:tr>
-              <a:tr h="365760">
-                <a:tc>
-                  <a:txBody>
-                    <a:bodyPr wrap="square"/>
-                    <a:lstStyle/>
-                    <a:p>
-                      <a:r>
-                        <a:rPr sz="1600" b="0">
-                          <a:solidFill>
-                            <a:srgbClr val="222B36"/>
-                          </a:solidFill>
-                          <a:latin typeface="Segoe UI"/>
-                        </a:rPr>
-                        <a:t>5</a:t>
-                      </a:r>
-                    </a:p>
-                  </a:txBody>
-                  <a:tcPr marL="73152" marR="73152" marT="36576" marB="36576">
-                    <a:solidFill>
-                      <a:srgbClr val="F7F9FC"/>
-                    </a:solidFill>
-                  </a:tcPr>
-                </a:tc>
-                <a:tc>
-                  <a:txBody>
-                    <a:bodyPr wrap="square"/>
-                    <a:lstStyle/>
-                    <a:p>
-                      <a:r>
-                        <a:rPr sz="1600" b="0">
-                          <a:solidFill>
-                            <a:srgbClr val="222B36"/>
-                          </a:solidFill>
-                          <a:latin typeface="Segoe UI"/>
-                        </a:rPr>
-                        <a:t>Pi 5 power through its USB-C port</a:t>
-                      </a:r>
-                    </a:p>
-                  </a:txBody>
-                  <a:tcPr marL="73152" marR="73152" marT="36576" marB="36576">
-                    <a:solidFill>
-                      <a:srgbClr val="F7F9FC"/>
-                    </a:solidFill>
-                  </a:tcPr>
-                </a:tc>
-                <a:tc>
-                  <a:txBody>
-                    <a:bodyPr wrap="square"/>
-                    <a:lstStyle/>
-                    <a:p>
-                      <a:r>
-                        <a:rPr sz="1600" b="0">
-                          <a:solidFill>
-                            <a:srgbClr val="222B36"/>
-                          </a:solidFill>
-                          <a:latin typeface="Segoe UI"/>
-                        </a:rPr>
-                        <a:t>Braden, Kevin</a:t>
-                      </a:r>
-                    </a:p>
-                  </a:txBody>
-                  <a:tcPr marL="73152" marR="73152" marT="36576" marB="36576">
-                    <a:solidFill>
-                      <a:srgbClr val="F7F9FC"/>
-                    </a:solidFill>
-                  </a:tcPr>
-                </a:tc>
-              </a:tr>
-              <a:tr h="365760">
-                <a:tc>
-                  <a:txBody>
-                    <a:bodyPr wrap="square"/>
-                    <a:lstStyle/>
-                    <a:p>
-                      <a:r>
-                        <a:rPr sz="1600" b="0">
-                          <a:solidFill>
-                            <a:srgbClr val="222B36"/>
-                          </a:solidFill>
-                          <a:latin typeface="Segoe UI"/>
-                        </a:rPr>
-                        <a:t>6</a:t>
-                      </a:r>
-                    </a:p>
-                  </a:txBody>
-                  <a:tcPr marL="73152" marR="73152" marT="36576" marB="36576">
-                    <a:solidFill>
-                      <a:srgbClr val="FFFFFF"/>
-                    </a:solidFill>
-                  </a:tcPr>
-                </a:tc>
-                <a:tc>
-                  <a:txBody>
-                    <a:bodyPr wrap="square"/>
-                    <a:lstStyle/>
-                    <a:p>
-                      <a:r>
-                        <a:rPr sz="1600" b="0">
-                          <a:solidFill>
-                            <a:srgbClr val="222B36"/>
-                          </a:solidFill>
-                          <a:latin typeface="Segoe UI"/>
-                        </a:rPr>
-                        <a:t>Measure USB round trip + scan against the 10 ms budget</a:t>
-                      </a:r>
-                    </a:p>
-                  </a:txBody>
-                  <a:tcPr marL="73152" marR="73152" marT="36576" marB="36576">
-                    <a:solidFill>
-                      <a:srgbClr val="FFFFFF"/>
-                    </a:solidFill>
-                  </a:tcPr>
-                </a:tc>
-                <a:tc>
-                  <a:txBody>
-                    <a:bodyPr wrap="square"/>
-                    <a:lstStyle/>
-                    <a:p>
-                      <a:r>
-                        <a:rPr sz="1600" b="0">
-                          <a:solidFill>
-                            <a:srgbClr val="222B36"/>
-                          </a:solidFill>
-                          <a:latin typeface="Segoe UI"/>
-                        </a:rPr>
-                        <a:t>Braden</a:t>
-                      </a:r>
-                    </a:p>
-                  </a:txBody>
-                  <a:tcPr marL="73152" marR="73152" marT="36576" marB="36576">
-                    <a:solidFill>
-                      <a:srgbClr val="FFFFFF"/>
-                    </a:solidFill>
-                  </a:tcPr>
-                </a:tc>
-              </a:tr>
-              <a:tr h="365760">
-                <a:tc>
-                  <a:txBody>
-                    <a:bodyPr wrap="square"/>
-                    <a:lstStyle/>
-                    <a:p>
-                      <a:r>
-                        <a:rPr sz="1600" b="0">
-                          <a:solidFill>
-                            <a:srgbClr val="222B36"/>
-                          </a:solidFill>
-                          <a:latin typeface="Segoe UI"/>
-                        </a:rPr>
-                        <a:t>7</a:t>
-                      </a:r>
-                    </a:p>
-                  </a:txBody>
-                  <a:tcPr marL="73152" marR="73152" marT="36576" marB="36576">
-                    <a:solidFill>
-                      <a:srgbClr val="F7F9FC"/>
-                    </a:solidFill>
-                  </a:tcPr>
-                </a:tc>
-                <a:tc>
-                  <a:txBody>
-                    <a:bodyPr wrap="square"/>
-                    <a:lstStyle/>
-                    <a:p>
-                      <a:r>
-                        <a:rPr sz="1600" b="0">
-                          <a:solidFill>
-                            <a:srgbClr val="222B36"/>
-                          </a:solidFill>
-                          <a:latin typeface="Segoe UI"/>
-                        </a:rPr>
-                        <a:t>PLC names differ between the variants (REQ-INTF-009)</a:t>
-                      </a:r>
-                    </a:p>
-                  </a:txBody>
-                  <a:tcPr marL="73152" marR="73152" marT="36576" marB="36576">
-                    <a:solidFill>
-                      <a:srgbClr val="F7F9FC"/>
-                    </a:solidFill>
-                  </a:tcPr>
-                </a:tc>
-                <a:tc>
-                  <a:txBody>
-                    <a:bodyPr wrap="square"/>
-                    <a:lstStyle/>
-                    <a:p>
-                      <a:r>
-                        <a:rPr sz="1600" b="0">
-                          <a:solidFill>
-                            <a:srgbClr val="222B36"/>
-                          </a:solidFill>
-                          <a:latin typeface="Segoe UI"/>
-                        </a:rPr>
-                        <a:t>Braden, Harry</a:t>
-                      </a:r>
-                    </a:p>
-                  </a:txBody>
-                  <a:tcPr marL="73152" marR="73152" marT="36576" marB="36576">
-                    <a:solidFill>
-                      <a:srgbClr val="F7F9FC"/>
-                    </a:solidFill>
-                  </a:tcPr>
-                </a:tc>
-              </a:tr>
-              <a:tr h="365760">
-                <a:tc>
-                  <a:txBody>
-                    <a:bodyPr wrap="square"/>
-                    <a:lstStyle/>
-                    <a:p>
-                      <a:r>
-                        <a:rPr sz="1600" b="0">
-                          <a:solidFill>
-                            <a:srgbClr val="222B36"/>
-                          </a:solidFill>
-                          <a:latin typeface="Segoe UI"/>
-                        </a:rPr>
-                        <a:t>8</a:t>
-                      </a:r>
-                    </a:p>
-                  </a:txBody>
-                  <a:tcPr marL="73152" marR="73152" marT="36576" marB="36576">
-                    <a:solidFill>
-                      <a:srgbClr val="FFFFFF"/>
-                    </a:solidFill>
-                  </a:tcPr>
-                </a:tc>
-                <a:tc>
-                  <a:txBody>
-                    <a:bodyPr wrap="square"/>
-                    <a:lstStyle/>
-                    <a:p>
-                      <a:r>
-                        <a:rPr sz="1600" b="0">
-                          <a:solidFill>
-                            <a:srgbClr val="222B36"/>
-                          </a:solidFill>
-                          <a:latin typeface="Segoe UI"/>
-                        </a:rPr>
-                        <a:t>Aspect values: lower case here, upper case system-wide</a:t>
-                      </a:r>
-                    </a:p>
-                  </a:txBody>
-                  <a:tcPr marL="73152" marR="73152" marT="36576" marB="36576">
-                    <a:solidFill>
-                      <a:srgbClr val="FFFFFF"/>
-                    </a:solidFill>
-                  </a:tcPr>
-                </a:tc>
-                <a:tc>
-                  <a:txBody>
-                    <a:bodyPr wrap="square"/>
-                    <a:lstStyle/>
-                    <a:p>
-                      <a:r>
-                        <a:rPr sz="1600" b="0">
-                          <a:solidFill>
-                            <a:srgbClr val="222B36"/>
-                          </a:solidFill>
-                          <a:latin typeface="Segoe UI"/>
-                        </a:rPr>
-                        <a:t>Braden</a:t>
-                      </a:r>
-                    </a:p>
-                  </a:txBody>
-                  <a:tcPr marL="73152" marR="73152" marT="36576" marB="36576">
-                    <a:solidFill>
-                      <a:srgbClr val="FFFFFF"/>
-                    </a:solidFill>
-                  </a:tcPr>
-                </a:tc>
-              </a:tr>
-            </a:tbl>
-          </a:graphicData>
-        </a:graphic>
-      </p:graphicFrame>
+      <p:sp>
+        <p:nvSpPr>
+          <p:cNvPr id="7" name="TextBox 6"/>
+          <p:cNvSpPr txBox="1"/>
+          <p:nvPr/>
+        </p:nvSpPr>
+        <p:spPr>
+          <a:xfrm>
+            <a:off x="411480" y="1097280"/>
+            <a:ext cx="11368735" cy="5349240"/>
+          </a:xfrm>
+          <a:prstGeom prst="rect">
+            <a:avLst/>
+          </a:prstGeom>
+          <a:noFill/>
+        </p:spPr>
+        <p:txBody>
+          <a:bodyPr wrap="square">
+            <a:spAutoFit/>
+          </a:bodyPr>
+          <a:lstStyle/>
+          <a:p>
+            <a:pPr>
+              <a:spcAft>
+                <a:spcPts val="800"/>
+              </a:spcAft>
+            </a:pPr>
+            <a:r>
+              <a:rPr sz="2400">
+                <a:solidFill>
+                  <a:srgbClr val="222B36"/>
+                </a:solidFill>
+                <a:latin typeface="Segoe UI"/>
+              </a:rPr>
+              <a:t>•  The OS only holds and parses the PLC program: every decision is PLC code</a:t>
+            </a:r>
+          </a:p>
+          <a:p>
+            <a:pPr>
+              <a:spcAft>
+                <a:spcPts val="800"/>
+              </a:spcAft>
+            </a:pPr>
+            <a:r>
+              <a:rPr sz="2400">
+                <a:solidFill>
+                  <a:srgbClr val="222B36"/>
+                </a:solidFill>
+                <a:latin typeface="Segoe UI"/>
+              </a:rPr>
+              <a:t>•  Read-only vital block after the user's program «planned»</a:t>
+            </a:r>
+          </a:p>
+          <a:p>
+            <a:pPr lvl="1">
+              <a:spcAft>
+                <a:spcPts val="400"/>
+              </a:spcAft>
+            </a:pPr>
+            <a:r>
+              <a:rPr sz="2100">
+                <a:solidFill>
+                  <a:srgbClr val="5B6775"/>
+                </a:solidFill>
+                <a:latin typeface="Segoe UI"/>
+              </a:rPr>
+              <a:t>–  Generated per territory; can only make outputs more restrictive</a:t>
+            </a:r>
+          </a:p>
+          <a:p>
+            <a:pPr>
+              <a:spcAft>
+                <a:spcPts val="800"/>
+              </a:spcAft>
+            </a:pPr>
+            <a:r>
+              <a:rPr sz="2400">
+                <a:solidFill>
+                  <a:srgbClr val="222B36"/>
+                </a:solidFill>
+                <a:latin typeface="Segoe UI"/>
+              </a:rPr>
+              <a:t>•  Diverse execution: two compilers, two interpreters, compared every scan</a:t>
+            </a:r>
+          </a:p>
+          <a:p>
+            <a:pPr>
+              <a:spcAft>
+                <a:spcPts val="800"/>
+              </a:spcAft>
+            </a:pPr>
+            <a:r>
+              <a:rPr sz="2400">
+                <a:solidFill>
+                  <a:srgbClr val="222B36"/>
+                </a:solidFill>
+                <a:latin typeface="Segoe UI"/>
+              </a:rPr>
+              <a:t>•  Diverse implementations: HW and SW share a language, not code</a:t>
+            </a:r>
+          </a:p>
+          <a:p>
+            <a:pPr>
+              <a:spcAft>
+                <a:spcPts val="800"/>
+              </a:spcAft>
+            </a:pPr>
+            <a:r>
+              <a:rPr sz="2400">
+                <a:solidFill>
+                  <a:srgbClr val="222B36"/>
+                </a:solidFill>
+                <a:latin typeface="Segoe UI"/>
+              </a:rPr>
+              <a:t>•  Fail-safe outputs: signals red, crossings active, speed and authority 0, switches stay</a:t>
+            </a:r>
+          </a:p>
+          <a:p>
+            <a:pPr>
+              <a:spcAft>
+                <a:spcPts val="800"/>
+              </a:spcAft>
+            </a:pPr>
+            <a:r>
+              <a:rPr sz="2400">
+                <a:solidFill>
+                  <a:srgbClr val="222B36"/>
+                </a:solidFill>
+                <a:latin typeface="Segoe UI"/>
+              </a:rPr>
+              <a:t>•  Inputs checked whole before anything changes; a failure reads as occupancy</a:t>
+            </a:r>
+          </a:p>
+        </p:txBody>
+      </p:sp>
+    </p:spTree>
+  </p:cSld>
+  <p:clrMapOvr>
+    <a:masterClrMapping/>
+  </p:clrMapOvr>
+</p:sld>
+</file>
+
+<file path=ppt/slides/slide39.xml><?xml version="1.0" encoding="utf-8"?>
+<p:sld xmlns:a="http://schemas.openxmlformats.org/drawingml/2006/main" xmlns:p="http://schemas.openxmlformats.org/presentationml/2006/main" xmlns:r="http://schemas.openxmlformats.org/officeDocument/2006/relationships">
+  <p:cSld>
+    <p:spTree>
+      <p:nvGrpSpPr>
+        <p:cNvPr id="1" name=""/>
+        <p:cNvGrpSpPr/>
+        <p:nvPr/>
+      </p:nvGrpSpPr>
+      <p:grpSpPr/>
+      <p:sp>
+        <p:nvSpPr>
+          <p:cNvPr id="2" name="Rectangle 1"/>
+          <p:cNvSpPr/>
+          <p:nvPr/>
+        </p:nvSpPr>
+        <p:spPr>
+          <a:xfrm>
+            <a:off x="0" y="0"/>
+            <a:ext cx="12191695" cy="868680"/>
+          </a:xfrm>
+          <a:prstGeom prst="rect">
+            <a:avLst/>
+          </a:prstGeom>
+          <a:solidFill>
+            <a:srgbClr val="1F3A5F"/>
+          </a:solidFill>
+          <a:ln>
+            <a:noFill/>
+          </a:ln>
+        </p:spPr>
+        <p:style>
+          <a:lnRef idx="1">
+            <a:schemeClr val="accent1"/>
+          </a:lnRef>
+          <a:fillRef idx="3">
+            <a:schemeClr val="accent1"/>
+          </a:fillRef>
+          <a:effectRef idx="2">
+            <a:schemeClr val="accent1"/>
+          </a:effectRef>
+          <a:fontRef idx="minor">
+            <a:schemeClr val="lt1"/>
+          </a:fontRef>
+        </p:style>
+        <p:txBody>
+          <a:bodyPr rtlCol="0" anchor="ctr"/>
+          <a:lstStyle/>
+          <a:p>
+            <a:pPr algn="ctr"/>
+          </a:p>
+        </p:txBody>
+      </p:sp>
+      <p:sp>
+        <p:nvSpPr>
+          <p:cNvPr id="3" name="TextBox 2"/>
+          <p:cNvSpPr txBox="1"/>
+          <p:nvPr/>
+        </p:nvSpPr>
+        <p:spPr>
+          <a:xfrm>
+            <a:off x="411480" y="109728"/>
+            <a:ext cx="11368735" cy="685800"/>
+          </a:xfrm>
+          <a:prstGeom prst="rect">
+            <a:avLst/>
+          </a:prstGeom>
+          <a:noFill/>
+        </p:spPr>
+        <p:txBody>
+          <a:bodyPr wrap="square" anchor="ctr" lIns="45720" rIns="45720">
+            <a:spAutoFit/>
+          </a:bodyPr>
+          <a:lstStyle/>
+          <a:p>
+            <a:pPr algn="l"/>
+            <a:r>
+              <a:rPr sz="2800" b="1">
+                <a:solidFill>
+                  <a:srgbClr val="FFFFFF"/>
+                </a:solidFill>
+                <a:latin typeface="Segoe UI"/>
+              </a:rPr>
+              <a:t>Hardware/software interface</a:t>
+            </a:r>
+          </a:p>
+        </p:txBody>
+      </p:sp>
+      <p:sp>
+        <p:nvSpPr>
+          <p:cNvPr id="4" name="TextBox 3"/>
+          <p:cNvSpPr txBox="1"/>
+          <p:nvPr/>
+        </p:nvSpPr>
+        <p:spPr>
+          <a:xfrm>
+            <a:off x="8351215" y="109728"/>
+            <a:ext cx="3474720" cy="685800"/>
+          </a:xfrm>
+          <a:prstGeom prst="rect">
+            <a:avLst/>
+          </a:prstGeom>
+          <a:noFill/>
+        </p:spPr>
+        <p:txBody>
+          <a:bodyPr wrap="square" anchor="ctr" lIns="45720" rIns="45720">
+            <a:spAutoFit/>
+          </a:bodyPr>
+          <a:lstStyle/>
+          <a:p>
+            <a:pPr algn="r"/>
+            <a:r>
+              <a:rPr sz="1200" b="0">
+                <a:solidFill>
+                  <a:srgbClr val="D9E2EC"/>
+                </a:solidFill>
+                <a:latin typeface="Segoe UI"/>
+              </a:rPr>
+              <a:t>System concepts</a:t>
+            </a:r>
+          </a:p>
+        </p:txBody>
+      </p:sp>
+      <p:sp>
+        <p:nvSpPr>
+          <p:cNvPr id="5" name="TextBox 4"/>
+          <p:cNvSpPr txBox="1"/>
+          <p:nvPr/>
+        </p:nvSpPr>
+        <p:spPr>
+          <a:xfrm>
+            <a:off x="411480" y="6537960"/>
+            <a:ext cx="8229600" cy="320040"/>
+          </a:xfrm>
+          <a:prstGeom prst="rect">
+            <a:avLst/>
+          </a:prstGeom>
+          <a:noFill/>
+        </p:spPr>
+        <p:txBody>
+          <a:bodyPr wrap="square" anchor="t" lIns="45720" rIns="45720">
+            <a:spAutoFit/>
+          </a:bodyPr>
+          <a:lstStyle/>
+          <a:p>
+            <a:pPr algn="l"/>
+            <a:r>
+              <a:rPr sz="1000" b="0">
+                <a:solidFill>
+                  <a:srgbClr val="5B6775"/>
+                </a:solidFill>
+                <a:latin typeface="Segoe UI"/>
+              </a:rPr>
+              <a:t>Track Overflow · Design Review · Track Controller (HW) · Braden</a:t>
+            </a:r>
+          </a:p>
+        </p:txBody>
+      </p:sp>
+      <p:sp>
+        <p:nvSpPr>
+          <p:cNvPr id="6" name="TextBox 5"/>
+          <p:cNvSpPr txBox="1"/>
+          <p:nvPr/>
+        </p:nvSpPr>
+        <p:spPr>
+          <a:xfrm>
+            <a:off x="10820095" y="6537960"/>
+            <a:ext cx="960120" cy="320040"/>
+          </a:xfrm>
+          <a:prstGeom prst="rect">
+            <a:avLst/>
+          </a:prstGeom>
+          <a:noFill/>
+        </p:spPr>
+        <p:txBody>
+          <a:bodyPr wrap="square" anchor="t" lIns="45720" rIns="45720">
+            <a:spAutoFit/>
+          </a:bodyPr>
+          <a:lstStyle/>
+          <a:p>
+            <a:pPr algn="r"/>
+            <a:r>
+              <a:rPr sz="1000" b="0">
+                <a:solidFill>
+                  <a:srgbClr val="5B6775"/>
+                </a:solidFill>
+                <a:latin typeface="Segoe UI"/>
+              </a:rPr>
+              <a:t>39</a:t>
+            </a:r>
+          </a:p>
+        </p:txBody>
+      </p:sp>
+      <p:sp>
+        <p:nvSpPr>
+          <p:cNvPr id="7" name="TextBox 6"/>
+          <p:cNvSpPr txBox="1"/>
+          <p:nvPr/>
+        </p:nvSpPr>
+        <p:spPr>
+          <a:xfrm>
+            <a:off x="411480" y="1097280"/>
+            <a:ext cx="11368735" cy="5349240"/>
+          </a:xfrm>
+          <a:prstGeom prst="rect">
+            <a:avLst/>
+          </a:prstGeom>
+          <a:noFill/>
+        </p:spPr>
+        <p:txBody>
+          <a:bodyPr wrap="square">
+            <a:spAutoFit/>
+          </a:bodyPr>
+          <a:lstStyle/>
+          <a:p>
+            <a:pPr>
+              <a:spcAft>
+                <a:spcPts val="800"/>
+              </a:spcAft>
+            </a:pPr>
+            <a:r>
+              <a:rPr sz="2400">
+                <a:solidFill>
+                  <a:srgbClr val="222B36"/>
+                </a:solidFill>
+                <a:latin typeface="Segoe UI"/>
+              </a:rPr>
+              <a:t>•  Same TrackController Protocol and the same I/O in both variants (D021)</a:t>
+            </a:r>
+          </a:p>
+          <a:p>
+            <a:pPr>
+              <a:spcAft>
+                <a:spcPts val="800"/>
+              </a:spcAft>
+            </a:pPr>
+            <a:r>
+              <a:rPr sz="2400">
+                <a:solidFill>
+                  <a:srgbClr val="222B36"/>
+                </a:solidFill>
+                <a:latin typeface="Segoe UI"/>
+              </a:rPr>
+              <a:t>•  Pi 5 in USB device mode: a standard USB serial (CDC-ACM) device (D027)</a:t>
+            </a:r>
+          </a:p>
+          <a:p>
+            <a:pPr lvl="1">
+              <a:spcAft>
+                <a:spcPts val="400"/>
+              </a:spcAft>
+            </a:pPr>
+            <a:r>
+              <a:rPr sz="2100">
+                <a:solidFill>
+                  <a:srgbClr val="5B6775"/>
+                </a:solidFill>
+                <a:latin typeface="Segoe UI"/>
+              </a:rPr>
+              <a:t>–  Windows' built-in driver: no installation, no admin rights</a:t>
+            </a:r>
+          </a:p>
+          <a:p>
+            <a:pPr lvl="1">
+              <a:spcAft>
+                <a:spcPts val="400"/>
+              </a:spcAft>
+            </a:pPr>
+            <a:r>
+              <a:rPr sz="2100">
+                <a:solidFill>
+                  <a:srgbClr val="5B6775"/>
+                </a:solidFill>
+                <a:latin typeface="Segoe UI"/>
+              </a:rPr>
+              <a:t>–  Found by its USB identity, never a fixed COM number</a:t>
+            </a:r>
+          </a:p>
+          <a:p>
+            <a:pPr>
+              <a:spcAft>
+                <a:spcPts val="800"/>
+              </a:spcAft>
+            </a:pPr>
+            <a:r>
+              <a:rPr sz="2400">
+                <a:solidFill>
+                  <a:srgbClr val="222B36"/>
+                </a:solidFill>
+                <a:latin typeface="Segoe UI"/>
+              </a:rPr>
+              <a:t>•  Messages: the harness's newline JSON, with request ID and tick</a:t>
+            </a:r>
+          </a:p>
+          <a:p>
+            <a:pPr>
+              <a:spcAft>
+                <a:spcPts val="800"/>
+              </a:spcAft>
+            </a:pPr>
+            <a:r>
+              <a:rPr sz="2400">
+                <a:solidFill>
+                  <a:srgbClr val="222B36"/>
+                </a:solidFill>
+                <a:latin typeface="Segoe UI"/>
+              </a:rPr>
+              <a:t>•  The PC process owns the COM port and relays harness messages to the Pi</a:t>
+            </a:r>
+          </a:p>
+          <a:p>
+            <a:pPr>
+              <a:spcAft>
+                <a:spcPts val="800"/>
+              </a:spcAft>
+            </a:pPr>
+            <a:r>
+              <a:rPr sz="2400">
+                <a:solidFill>
+                  <a:srgbClr val="222B36"/>
+                </a:solidFill>
+                <a:latin typeface="Segoe UI"/>
+              </a:rPr>
+              <a:t>•  10x: 100 ticks per second, so USB round trip + scan &lt; 10 ms</a:t>
+            </a:r>
+          </a:p>
+        </p:txBody>
+      </p:sp>
     </p:spTree>
   </p:cSld>
   <p:clrMapOvr>
@@ -14319,6 +14228,985 @@
 </p:sld>
 </file>
 
+<file path=ppt/slides/slide40.xml><?xml version="1.0" encoding="utf-8"?>
+<p:sld xmlns:a="http://schemas.openxmlformats.org/drawingml/2006/main" xmlns:p="http://schemas.openxmlformats.org/presentationml/2006/main" xmlns:r="http://schemas.openxmlformats.org/officeDocument/2006/relationships">
+  <p:cSld>
+    <p:spTree>
+      <p:nvGrpSpPr>
+        <p:cNvPr id="1" name=""/>
+        <p:cNvGrpSpPr/>
+        <p:nvPr/>
+      </p:nvGrpSpPr>
+      <p:grpSpPr/>
+      <p:sp>
+        <p:nvSpPr>
+          <p:cNvPr id="2" name="Rectangle 1"/>
+          <p:cNvSpPr/>
+          <p:nvPr/>
+        </p:nvSpPr>
+        <p:spPr>
+          <a:xfrm>
+            <a:off x="0" y="0"/>
+            <a:ext cx="12191695" cy="6858000"/>
+          </a:xfrm>
+          <a:prstGeom prst="rect">
+            <a:avLst/>
+          </a:prstGeom>
+          <a:solidFill>
+            <a:srgbClr val="F7F9FC"/>
+          </a:solidFill>
+          <a:ln>
+            <a:noFill/>
+          </a:ln>
+        </p:spPr>
+        <p:style>
+          <a:lnRef idx="1">
+            <a:schemeClr val="accent1"/>
+          </a:lnRef>
+          <a:fillRef idx="3">
+            <a:schemeClr val="accent1"/>
+          </a:fillRef>
+          <a:effectRef idx="2">
+            <a:schemeClr val="accent1"/>
+          </a:effectRef>
+          <a:fontRef idx="minor">
+            <a:schemeClr val="lt1"/>
+          </a:fontRef>
+        </p:style>
+        <p:txBody>
+          <a:bodyPr rtlCol="0" anchor="ctr"/>
+          <a:lstStyle/>
+          <a:p>
+            <a:pPr algn="ctr"/>
+          </a:p>
+        </p:txBody>
+      </p:sp>
+      <p:sp>
+        <p:nvSpPr>
+          <p:cNvPr id="3" name="Rectangle 2"/>
+          <p:cNvSpPr/>
+          <p:nvPr/>
+        </p:nvSpPr>
+        <p:spPr>
+          <a:xfrm>
+            <a:off x="822960" y="3246120"/>
+            <a:ext cx="1280160" cy="73152"/>
+          </a:xfrm>
+          <a:prstGeom prst="rect">
+            <a:avLst/>
+          </a:prstGeom>
+          <a:solidFill>
+            <a:srgbClr val="1F3A5F"/>
+          </a:solidFill>
+          <a:ln>
+            <a:noFill/>
+          </a:ln>
+        </p:spPr>
+        <p:style>
+          <a:lnRef idx="1">
+            <a:schemeClr val="accent1"/>
+          </a:lnRef>
+          <a:fillRef idx="3">
+            <a:schemeClr val="accent1"/>
+          </a:fillRef>
+          <a:effectRef idx="2">
+            <a:schemeClr val="accent1"/>
+          </a:effectRef>
+          <a:fontRef idx="minor">
+            <a:schemeClr val="lt1"/>
+          </a:fontRef>
+        </p:style>
+        <p:txBody>
+          <a:bodyPr rtlCol="0" anchor="ctr"/>
+          <a:lstStyle/>
+          <a:p>
+            <a:pPr algn="ctr"/>
+          </a:p>
+        </p:txBody>
+      </p:sp>
+      <p:sp>
+        <p:nvSpPr>
+          <p:cNvPr id="4" name="TextBox 3"/>
+          <p:cNvSpPr txBox="1"/>
+          <p:nvPr/>
+        </p:nvSpPr>
+        <p:spPr>
+          <a:xfrm>
+            <a:off x="822960" y="2194560"/>
+            <a:ext cx="10515600" cy="1005840"/>
+          </a:xfrm>
+          <a:prstGeom prst="rect">
+            <a:avLst/>
+          </a:prstGeom>
+          <a:noFill/>
+        </p:spPr>
+        <p:txBody>
+          <a:bodyPr wrap="square" anchor="t" lIns="45720" rIns="45720">
+            <a:spAutoFit/>
+          </a:bodyPr>
+          <a:lstStyle/>
+          <a:p>
+            <a:pPr algn="l"/>
+            <a:r>
+              <a:rPr sz="4000" b="1">
+                <a:solidFill>
+                  <a:srgbClr val="1F3A5F"/>
+                </a:solidFill>
+                <a:latin typeface="Segoe UI"/>
+              </a:rPr>
+              <a:t>Open items</a:t>
+            </a:r>
+          </a:p>
+        </p:txBody>
+      </p:sp>
+    </p:spTree>
+  </p:cSld>
+  <p:clrMapOvr>
+    <a:masterClrMapping/>
+  </p:clrMapOvr>
+</p:sld>
+</file>
+
+<file path=ppt/slides/slide41.xml><?xml version="1.0" encoding="utf-8"?>
+<p:sld xmlns:a="http://schemas.openxmlformats.org/drawingml/2006/main" xmlns:p="http://schemas.openxmlformats.org/presentationml/2006/main" xmlns:r="http://schemas.openxmlformats.org/officeDocument/2006/relationships">
+  <p:cSld>
+    <p:spTree>
+      <p:nvGrpSpPr>
+        <p:cNvPr id="1" name=""/>
+        <p:cNvGrpSpPr/>
+        <p:nvPr/>
+      </p:nvGrpSpPr>
+      <p:grpSpPr/>
+      <p:sp>
+        <p:nvSpPr>
+          <p:cNvPr id="2" name="Rectangle 1"/>
+          <p:cNvSpPr/>
+          <p:nvPr/>
+        </p:nvSpPr>
+        <p:spPr>
+          <a:xfrm>
+            <a:off x="0" y="0"/>
+            <a:ext cx="12191695" cy="868680"/>
+          </a:xfrm>
+          <a:prstGeom prst="rect">
+            <a:avLst/>
+          </a:prstGeom>
+          <a:solidFill>
+            <a:srgbClr val="1F3A5F"/>
+          </a:solidFill>
+          <a:ln>
+            <a:noFill/>
+          </a:ln>
+        </p:spPr>
+        <p:style>
+          <a:lnRef idx="1">
+            <a:schemeClr val="accent1"/>
+          </a:lnRef>
+          <a:fillRef idx="3">
+            <a:schemeClr val="accent1"/>
+          </a:fillRef>
+          <a:effectRef idx="2">
+            <a:schemeClr val="accent1"/>
+          </a:effectRef>
+          <a:fontRef idx="minor">
+            <a:schemeClr val="lt1"/>
+          </a:fontRef>
+        </p:style>
+        <p:txBody>
+          <a:bodyPr rtlCol="0" anchor="ctr"/>
+          <a:lstStyle/>
+          <a:p>
+            <a:pPr algn="ctr"/>
+          </a:p>
+        </p:txBody>
+      </p:sp>
+      <p:sp>
+        <p:nvSpPr>
+          <p:cNvPr id="3" name="TextBox 2"/>
+          <p:cNvSpPr txBox="1"/>
+          <p:nvPr/>
+        </p:nvSpPr>
+        <p:spPr>
+          <a:xfrm>
+            <a:off x="411480" y="109728"/>
+            <a:ext cx="11368735" cy="685800"/>
+          </a:xfrm>
+          <a:prstGeom prst="rect">
+            <a:avLst/>
+          </a:prstGeom>
+          <a:noFill/>
+        </p:spPr>
+        <p:txBody>
+          <a:bodyPr wrap="square" anchor="ctr" lIns="45720" rIns="45720">
+            <a:spAutoFit/>
+          </a:bodyPr>
+          <a:lstStyle/>
+          <a:p>
+            <a:pPr algn="l"/>
+            <a:r>
+              <a:rPr sz="2800" b="1">
+                <a:solidFill>
+                  <a:srgbClr val="FFFFFF"/>
+                </a:solidFill>
+                <a:latin typeface="Segoe UI"/>
+              </a:rPr>
+              <a:t>Open items</a:t>
+            </a:r>
+          </a:p>
+        </p:txBody>
+      </p:sp>
+      <p:sp>
+        <p:nvSpPr>
+          <p:cNvPr id="4" name="TextBox 3"/>
+          <p:cNvSpPr txBox="1"/>
+          <p:nvPr/>
+        </p:nvSpPr>
+        <p:spPr>
+          <a:xfrm>
+            <a:off x="8351215" y="109728"/>
+            <a:ext cx="3474720" cy="685800"/>
+          </a:xfrm>
+          <a:prstGeom prst="rect">
+            <a:avLst/>
+          </a:prstGeom>
+          <a:noFill/>
+        </p:spPr>
+        <p:txBody>
+          <a:bodyPr wrap="square" anchor="ctr" lIns="45720" rIns="45720">
+            <a:spAutoFit/>
+          </a:bodyPr>
+          <a:lstStyle/>
+          <a:p>
+            <a:pPr algn="r"/>
+            <a:r>
+              <a:rPr sz="1200" b="0">
+                <a:solidFill>
+                  <a:srgbClr val="D9E2EC"/>
+                </a:solidFill>
+                <a:latin typeface="Segoe UI"/>
+              </a:rPr>
+              <a:t>Open items</a:t>
+            </a:r>
+          </a:p>
+        </p:txBody>
+      </p:sp>
+      <p:sp>
+        <p:nvSpPr>
+          <p:cNvPr id="5" name="TextBox 4"/>
+          <p:cNvSpPr txBox="1"/>
+          <p:nvPr/>
+        </p:nvSpPr>
+        <p:spPr>
+          <a:xfrm>
+            <a:off x="411480" y="6537960"/>
+            <a:ext cx="8229600" cy="320040"/>
+          </a:xfrm>
+          <a:prstGeom prst="rect">
+            <a:avLst/>
+          </a:prstGeom>
+          <a:noFill/>
+        </p:spPr>
+        <p:txBody>
+          <a:bodyPr wrap="square" anchor="t" lIns="45720" rIns="45720">
+            <a:spAutoFit/>
+          </a:bodyPr>
+          <a:lstStyle/>
+          <a:p>
+            <a:pPr algn="l"/>
+            <a:r>
+              <a:rPr sz="1000" b="0">
+                <a:solidFill>
+                  <a:srgbClr val="5B6775"/>
+                </a:solidFill>
+                <a:latin typeface="Segoe UI"/>
+              </a:rPr>
+              <a:t>Track Overflow · Design Review · Track Controller (HW) · Braden</a:t>
+            </a:r>
+          </a:p>
+        </p:txBody>
+      </p:sp>
+      <p:sp>
+        <p:nvSpPr>
+          <p:cNvPr id="6" name="TextBox 5"/>
+          <p:cNvSpPr txBox="1"/>
+          <p:nvPr/>
+        </p:nvSpPr>
+        <p:spPr>
+          <a:xfrm>
+            <a:off x="10820095" y="6537960"/>
+            <a:ext cx="960120" cy="320040"/>
+          </a:xfrm>
+          <a:prstGeom prst="rect">
+            <a:avLst/>
+          </a:prstGeom>
+          <a:noFill/>
+        </p:spPr>
+        <p:txBody>
+          <a:bodyPr wrap="square" anchor="t" lIns="45720" rIns="45720">
+            <a:spAutoFit/>
+          </a:bodyPr>
+          <a:lstStyle/>
+          <a:p>
+            <a:pPr algn="r"/>
+            <a:r>
+              <a:rPr sz="1000" b="0">
+                <a:solidFill>
+                  <a:srgbClr val="5B6775"/>
+                </a:solidFill>
+                <a:latin typeface="Segoe UI"/>
+              </a:rPr>
+              <a:t>41</a:t>
+            </a:r>
+          </a:p>
+        </p:txBody>
+      </p:sp>
+      <p:graphicFrame>
+        <p:nvGraphicFramePr>
+          <p:cNvPr id="7" name="Table 6"/>
+          <p:cNvGraphicFramePr>
+            <a:graphicFrameLocks noGrp="1"/>
+          </p:cNvGraphicFramePr>
+          <p:nvPr/>
+        </p:nvGraphicFramePr>
+        <p:xfrm>
+          <a:off x="411480" y="1097280"/>
+          <a:ext cx="11338560" cy="3291840"/>
+        </p:xfrm>
+        <a:graphic>
+          <a:graphicData uri="http://schemas.openxmlformats.org/drawingml/2006/table">
+            <a:tbl>
+              <a:tblPr firstRow="1" bandRow="1">
+                <a:tableStyleId>{5C22544A-7EE6-4342-B048-85BDC9FD1C3A}</a:tableStyleId>
+              </a:tblPr>
+              <a:tblGrid>
+                <a:gridCol w="548640"/>
+                <a:gridCol w="8412480"/>
+                <a:gridCol w="2377440"/>
+              </a:tblGrid>
+              <a:tr h="365760">
+                <a:tc>
+                  <a:txBody>
+                    <a:bodyPr wrap="square"/>
+                    <a:lstStyle/>
+                    <a:p>
+                      <a:r>
+                        <a:rPr sz="1600" b="1">
+                          <a:solidFill>
+                            <a:srgbClr val="FFFFFF"/>
+                          </a:solidFill>
+                          <a:latin typeface="Segoe UI"/>
+                        </a:rPr>
+                        <a:t>#</a:t>
+                      </a:r>
+                    </a:p>
+                  </a:txBody>
+                  <a:tcPr marL="73152" marR="73152" marT="36576" marB="36576">
+                    <a:solidFill>
+                      <a:srgbClr val="1F3A5F"/>
+                    </a:solidFill>
+                  </a:tcPr>
+                </a:tc>
+                <a:tc>
+                  <a:txBody>
+                    <a:bodyPr wrap="square"/>
+                    <a:lstStyle/>
+                    <a:p>
+                      <a:r>
+                        <a:rPr sz="1600" b="1">
+                          <a:solidFill>
+                            <a:srgbClr val="FFFFFF"/>
+                          </a:solidFill>
+                          <a:latin typeface="Segoe UI"/>
+                        </a:rPr>
+                        <a:t>Item</a:t>
+                      </a:r>
+                    </a:p>
+                  </a:txBody>
+                  <a:tcPr marL="73152" marR="73152" marT="36576" marB="36576">
+                    <a:solidFill>
+                      <a:srgbClr val="1F3A5F"/>
+                    </a:solidFill>
+                  </a:tcPr>
+                </a:tc>
+                <a:tc>
+                  <a:txBody>
+                    <a:bodyPr wrap="square"/>
+                    <a:lstStyle/>
+                    <a:p>
+                      <a:r>
+                        <a:rPr sz="1600" b="1">
+                          <a:solidFill>
+                            <a:srgbClr val="FFFFFF"/>
+                          </a:solidFill>
+                          <a:latin typeface="Segoe UI"/>
+                        </a:rPr>
+                        <a:t>Owner</a:t>
+                      </a:r>
+                    </a:p>
+                  </a:txBody>
+                  <a:tcPr marL="73152" marR="73152" marT="36576" marB="36576">
+                    <a:solidFill>
+                      <a:srgbClr val="1F3A5F"/>
+                    </a:solidFill>
+                  </a:tcPr>
+                </a:tc>
+              </a:tr>
+              <a:tr h="365760">
+                <a:tc>
+                  <a:txBody>
+                    <a:bodyPr wrap="square"/>
+                    <a:lstStyle/>
+                    <a:p>
+                      <a:r>
+                        <a:rPr sz="1600" b="0">
+                          <a:solidFill>
+                            <a:srgbClr val="222B36"/>
+                          </a:solidFill>
+                          <a:latin typeface="Segoe UI"/>
+                        </a:rPr>
+                        <a:t>1</a:t>
+                      </a:r>
+                    </a:p>
+                  </a:txBody>
+                  <a:tcPr marL="73152" marR="73152" marT="36576" marB="36576">
+                    <a:solidFill>
+                      <a:srgbClr val="F7F9FC"/>
+                    </a:solidFill>
+                  </a:tcPr>
+                </a:tc>
+                <a:tc>
+                  <a:txBody>
+                    <a:bodyPr wrap="square"/>
+                    <a:lstStyle/>
+                    <a:p>
+                      <a:r>
+                        <a:rPr sz="1600" b="0">
+                          <a:solidFill>
+                            <a:srgbClr val="222B36"/>
+                          </a:solidFill>
+                          <a:latin typeface="Segoe UI"/>
+                        </a:rPr>
+                        <a:t>Read-only vital PLC block: assumed, to confirm for both variants</a:t>
+                      </a:r>
+                    </a:p>
+                  </a:txBody>
+                  <a:tcPr marL="73152" marR="73152" marT="36576" marB="36576">
+                    <a:solidFill>
+                      <a:srgbClr val="F7F9FC"/>
+                    </a:solidFill>
+                  </a:tcPr>
+                </a:tc>
+                <a:tc>
+                  <a:txBody>
+                    <a:bodyPr wrap="square"/>
+                    <a:lstStyle/>
+                    <a:p>
+                      <a:r>
+                        <a:rPr sz="1600" b="0">
+                          <a:solidFill>
+                            <a:srgbClr val="222B36"/>
+                          </a:solidFill>
+                          <a:latin typeface="Segoe UI"/>
+                        </a:rPr>
+                        <a:t>Braden, Harry</a:t>
+                      </a:r>
+                    </a:p>
+                  </a:txBody>
+                  <a:tcPr marL="73152" marR="73152" marT="36576" marB="36576">
+                    <a:solidFill>
+                      <a:srgbClr val="F7F9FC"/>
+                    </a:solidFill>
+                  </a:tcPr>
+                </a:tc>
+              </a:tr>
+              <a:tr h="365760">
+                <a:tc>
+                  <a:txBody>
+                    <a:bodyPr wrap="square"/>
+                    <a:lstStyle/>
+                    <a:p>
+                      <a:r>
+                        <a:rPr sz="1600" b="0">
+                          <a:solidFill>
+                            <a:srgbClr val="222B36"/>
+                          </a:solidFill>
+                          <a:latin typeface="Segoe UI"/>
+                        </a:rPr>
+                        <a:t>2</a:t>
+                      </a:r>
+                    </a:p>
+                  </a:txBody>
+                  <a:tcPr marL="73152" marR="73152" marT="36576" marB="36576">
+                    <a:solidFill>
+                      <a:srgbClr val="FFFFFF"/>
+                    </a:solidFill>
+                  </a:tcPr>
+                </a:tc>
+                <a:tc>
+                  <a:txBody>
+                    <a:bodyPr wrap="square"/>
+                    <a:lstStyle/>
+                    <a:p>
+                      <a:r>
+                        <a:rPr sz="1600" b="0">
+                          <a:solidFill>
+                            <a:srgbClr val="222B36"/>
+                          </a:solidFill>
+                          <a:latin typeface="Segoe UI"/>
+                        </a:rPr>
+                        <a:t>Manual switch at the wayside in maintenance (rubric 6.8); assumed CTC only</a:t>
+                      </a:r>
+                    </a:p>
+                  </a:txBody>
+                  <a:tcPr marL="73152" marR="73152" marT="36576" marB="36576">
+                    <a:solidFill>
+                      <a:srgbClr val="FFFFFF"/>
+                    </a:solidFill>
+                  </a:tcPr>
+                </a:tc>
+                <a:tc>
+                  <a:txBody>
+                    <a:bodyPr wrap="square"/>
+                    <a:lstStyle/>
+                    <a:p>
+                      <a:r>
+                        <a:rPr sz="1600" b="0">
+                          <a:solidFill>
+                            <a:srgbClr val="222B36"/>
+                          </a:solidFill>
+                          <a:latin typeface="Segoe UI"/>
+                        </a:rPr>
+                        <a:t>Braden, Harry</a:t>
+                      </a:r>
+                    </a:p>
+                  </a:txBody>
+                  <a:tcPr marL="73152" marR="73152" marT="36576" marB="36576">
+                    <a:solidFill>
+                      <a:srgbClr val="FFFFFF"/>
+                    </a:solidFill>
+                  </a:tcPr>
+                </a:tc>
+              </a:tr>
+              <a:tr h="365760">
+                <a:tc>
+                  <a:txBody>
+                    <a:bodyPr wrap="square"/>
+                    <a:lstStyle/>
+                    <a:p>
+                      <a:r>
+                        <a:rPr sz="1600" b="0">
+                          <a:solidFill>
+                            <a:srgbClr val="222B36"/>
+                          </a:solidFill>
+                          <a:latin typeface="Segoe UI"/>
+                        </a:rPr>
+                        <a:t>3</a:t>
+                      </a:r>
+                    </a:p>
+                  </a:txBody>
+                  <a:tcPr marL="73152" marR="73152" marT="36576" marB="36576">
+                    <a:solidFill>
+                      <a:srgbClr val="F7F9FC"/>
+                    </a:solidFill>
+                  </a:tcPr>
+                </a:tc>
+                <a:tc>
+                  <a:txBody>
+                    <a:bodyPr wrap="square"/>
+                    <a:lstStyle/>
+                    <a:p>
+                      <a:r>
+                        <a:rPr sz="1600" b="0">
+                          <a:solidFill>
+                            <a:srgbClr val="222B36"/>
+                          </a:solidFill>
+                          <a:latin typeface="Segoe UI"/>
+                        </a:rPr>
+                        <a:t>Red Line wayside boundaries, databases and programs</a:t>
+                      </a:r>
+                    </a:p>
+                  </a:txBody>
+                  <a:tcPr marL="73152" marR="73152" marT="36576" marB="36576">
+                    <a:solidFill>
+                      <a:srgbClr val="F7F9FC"/>
+                    </a:solidFill>
+                  </a:tcPr>
+                </a:tc>
+                <a:tc>
+                  <a:txBody>
+                    <a:bodyPr wrap="square"/>
+                    <a:lstStyle/>
+                    <a:p>
+                      <a:r>
+                        <a:rPr sz="1600" b="0">
+                          <a:solidFill>
+                            <a:srgbClr val="222B36"/>
+                          </a:solidFill>
+                          <a:latin typeface="Segoe UI"/>
+                        </a:rPr>
+                        <a:t>Braden</a:t>
+                      </a:r>
+                    </a:p>
+                  </a:txBody>
+                  <a:tcPr marL="73152" marR="73152" marT="36576" marB="36576">
+                    <a:solidFill>
+                      <a:srgbClr val="F7F9FC"/>
+                    </a:solidFill>
+                  </a:tcPr>
+                </a:tc>
+              </a:tr>
+              <a:tr h="365760">
+                <a:tc>
+                  <a:txBody>
+                    <a:bodyPr wrap="square"/>
+                    <a:lstStyle/>
+                    <a:p>
+                      <a:r>
+                        <a:rPr sz="1600" b="0">
+                          <a:solidFill>
+                            <a:srgbClr val="222B36"/>
+                          </a:solidFill>
+                          <a:latin typeface="Segoe UI"/>
+                        </a:rPr>
+                        <a:t>4</a:t>
+                      </a:r>
+                    </a:p>
+                  </a:txBody>
+                  <a:tcPr marL="73152" marR="73152" marT="36576" marB="36576">
+                    <a:solidFill>
+                      <a:srgbClr val="FFFFFF"/>
+                    </a:solidFill>
+                  </a:tcPr>
+                </a:tc>
+                <a:tc>
+                  <a:txBody>
+                    <a:bodyPr wrap="square"/>
+                    <a:lstStyle/>
+                    <a:p>
+                      <a:r>
+                        <a:rPr sz="1600" b="0">
+                          <a:solidFill>
+                            <a:srgbClr val="222B36"/>
+                          </a:solidFill>
+                          <a:latin typeface="Segoe UI"/>
+                        </a:rPr>
+                        <a:t>USB message framing; the Pi's identification</a:t>
+                      </a:r>
+                    </a:p>
+                  </a:txBody>
+                  <a:tcPr marL="73152" marR="73152" marT="36576" marB="36576">
+                    <a:solidFill>
+                      <a:srgbClr val="FFFFFF"/>
+                    </a:solidFill>
+                  </a:tcPr>
+                </a:tc>
+                <a:tc>
+                  <a:txBody>
+                    <a:bodyPr wrap="square"/>
+                    <a:lstStyle/>
+                    <a:p>
+                      <a:r>
+                        <a:rPr sz="1600" b="0">
+                          <a:solidFill>
+                            <a:srgbClr val="222B36"/>
+                          </a:solidFill>
+                          <a:latin typeface="Segoe UI"/>
+                        </a:rPr>
+                        <a:t>Kevin, Braden</a:t>
+                      </a:r>
+                    </a:p>
+                  </a:txBody>
+                  <a:tcPr marL="73152" marR="73152" marT="36576" marB="36576">
+                    <a:solidFill>
+                      <a:srgbClr val="FFFFFF"/>
+                    </a:solidFill>
+                  </a:tcPr>
+                </a:tc>
+              </a:tr>
+              <a:tr h="365760">
+                <a:tc>
+                  <a:txBody>
+                    <a:bodyPr wrap="square"/>
+                    <a:lstStyle/>
+                    <a:p>
+                      <a:r>
+                        <a:rPr sz="1600" b="0">
+                          <a:solidFill>
+                            <a:srgbClr val="222B36"/>
+                          </a:solidFill>
+                          <a:latin typeface="Segoe UI"/>
+                        </a:rPr>
+                        <a:t>5</a:t>
+                      </a:r>
+                    </a:p>
+                  </a:txBody>
+                  <a:tcPr marL="73152" marR="73152" marT="36576" marB="36576">
+                    <a:solidFill>
+                      <a:srgbClr val="F7F9FC"/>
+                    </a:solidFill>
+                  </a:tcPr>
+                </a:tc>
+                <a:tc>
+                  <a:txBody>
+                    <a:bodyPr wrap="square"/>
+                    <a:lstStyle/>
+                    <a:p>
+                      <a:r>
+                        <a:rPr sz="1600" b="0">
+                          <a:solidFill>
+                            <a:srgbClr val="222B36"/>
+                          </a:solidFill>
+                          <a:latin typeface="Segoe UI"/>
+                        </a:rPr>
+                        <a:t>Pi 5 power through its USB-C port</a:t>
+                      </a:r>
+                    </a:p>
+                  </a:txBody>
+                  <a:tcPr marL="73152" marR="73152" marT="36576" marB="36576">
+                    <a:solidFill>
+                      <a:srgbClr val="F7F9FC"/>
+                    </a:solidFill>
+                  </a:tcPr>
+                </a:tc>
+                <a:tc>
+                  <a:txBody>
+                    <a:bodyPr wrap="square"/>
+                    <a:lstStyle/>
+                    <a:p>
+                      <a:r>
+                        <a:rPr sz="1600" b="0">
+                          <a:solidFill>
+                            <a:srgbClr val="222B36"/>
+                          </a:solidFill>
+                          <a:latin typeface="Segoe UI"/>
+                        </a:rPr>
+                        <a:t>Braden, Kevin</a:t>
+                      </a:r>
+                    </a:p>
+                  </a:txBody>
+                  <a:tcPr marL="73152" marR="73152" marT="36576" marB="36576">
+                    <a:solidFill>
+                      <a:srgbClr val="F7F9FC"/>
+                    </a:solidFill>
+                  </a:tcPr>
+                </a:tc>
+              </a:tr>
+              <a:tr h="365760">
+                <a:tc>
+                  <a:txBody>
+                    <a:bodyPr wrap="square"/>
+                    <a:lstStyle/>
+                    <a:p>
+                      <a:r>
+                        <a:rPr sz="1600" b="0">
+                          <a:solidFill>
+                            <a:srgbClr val="222B36"/>
+                          </a:solidFill>
+                          <a:latin typeface="Segoe UI"/>
+                        </a:rPr>
+                        <a:t>6</a:t>
+                      </a:r>
+                    </a:p>
+                  </a:txBody>
+                  <a:tcPr marL="73152" marR="73152" marT="36576" marB="36576">
+                    <a:solidFill>
+                      <a:srgbClr val="FFFFFF"/>
+                    </a:solidFill>
+                  </a:tcPr>
+                </a:tc>
+                <a:tc>
+                  <a:txBody>
+                    <a:bodyPr wrap="square"/>
+                    <a:lstStyle/>
+                    <a:p>
+                      <a:r>
+                        <a:rPr sz="1600" b="0">
+                          <a:solidFill>
+                            <a:srgbClr val="222B36"/>
+                          </a:solidFill>
+                          <a:latin typeface="Segoe UI"/>
+                        </a:rPr>
+                        <a:t>Measure USB round trip + scan against the 10 ms budget</a:t>
+                      </a:r>
+                    </a:p>
+                  </a:txBody>
+                  <a:tcPr marL="73152" marR="73152" marT="36576" marB="36576">
+                    <a:solidFill>
+                      <a:srgbClr val="FFFFFF"/>
+                    </a:solidFill>
+                  </a:tcPr>
+                </a:tc>
+                <a:tc>
+                  <a:txBody>
+                    <a:bodyPr wrap="square"/>
+                    <a:lstStyle/>
+                    <a:p>
+                      <a:r>
+                        <a:rPr sz="1600" b="0">
+                          <a:solidFill>
+                            <a:srgbClr val="222B36"/>
+                          </a:solidFill>
+                          <a:latin typeface="Segoe UI"/>
+                        </a:rPr>
+                        <a:t>Braden</a:t>
+                      </a:r>
+                    </a:p>
+                  </a:txBody>
+                  <a:tcPr marL="73152" marR="73152" marT="36576" marB="36576">
+                    <a:solidFill>
+                      <a:srgbClr val="FFFFFF"/>
+                    </a:solidFill>
+                  </a:tcPr>
+                </a:tc>
+              </a:tr>
+              <a:tr h="365760">
+                <a:tc>
+                  <a:txBody>
+                    <a:bodyPr wrap="square"/>
+                    <a:lstStyle/>
+                    <a:p>
+                      <a:r>
+                        <a:rPr sz="1600" b="0">
+                          <a:solidFill>
+                            <a:srgbClr val="222B36"/>
+                          </a:solidFill>
+                          <a:latin typeface="Segoe UI"/>
+                        </a:rPr>
+                        <a:t>7</a:t>
+                      </a:r>
+                    </a:p>
+                  </a:txBody>
+                  <a:tcPr marL="73152" marR="73152" marT="36576" marB="36576">
+                    <a:solidFill>
+                      <a:srgbClr val="F7F9FC"/>
+                    </a:solidFill>
+                  </a:tcPr>
+                </a:tc>
+                <a:tc>
+                  <a:txBody>
+                    <a:bodyPr wrap="square"/>
+                    <a:lstStyle/>
+                    <a:p>
+                      <a:r>
+                        <a:rPr sz="1600" b="0">
+                          <a:solidFill>
+                            <a:srgbClr val="222B36"/>
+                          </a:solidFill>
+                          <a:latin typeface="Segoe UI"/>
+                        </a:rPr>
+                        <a:t>PLC names differ between the variants (REQ-INTF-009)</a:t>
+                      </a:r>
+                    </a:p>
+                  </a:txBody>
+                  <a:tcPr marL="73152" marR="73152" marT="36576" marB="36576">
+                    <a:solidFill>
+                      <a:srgbClr val="F7F9FC"/>
+                    </a:solidFill>
+                  </a:tcPr>
+                </a:tc>
+                <a:tc>
+                  <a:txBody>
+                    <a:bodyPr wrap="square"/>
+                    <a:lstStyle/>
+                    <a:p>
+                      <a:r>
+                        <a:rPr sz="1600" b="0">
+                          <a:solidFill>
+                            <a:srgbClr val="222B36"/>
+                          </a:solidFill>
+                          <a:latin typeface="Segoe UI"/>
+                        </a:rPr>
+                        <a:t>Braden, Harry</a:t>
+                      </a:r>
+                    </a:p>
+                  </a:txBody>
+                  <a:tcPr marL="73152" marR="73152" marT="36576" marB="36576">
+                    <a:solidFill>
+                      <a:srgbClr val="F7F9FC"/>
+                    </a:solidFill>
+                  </a:tcPr>
+                </a:tc>
+              </a:tr>
+              <a:tr h="365760">
+                <a:tc>
+                  <a:txBody>
+                    <a:bodyPr wrap="square"/>
+                    <a:lstStyle/>
+                    <a:p>
+                      <a:r>
+                        <a:rPr sz="1600" b="0">
+                          <a:solidFill>
+                            <a:srgbClr val="222B36"/>
+                          </a:solidFill>
+                          <a:latin typeface="Segoe UI"/>
+                        </a:rPr>
+                        <a:t>8</a:t>
+                      </a:r>
+                    </a:p>
+                  </a:txBody>
+                  <a:tcPr marL="73152" marR="73152" marT="36576" marB="36576">
+                    <a:solidFill>
+                      <a:srgbClr val="FFFFFF"/>
+                    </a:solidFill>
+                  </a:tcPr>
+                </a:tc>
+                <a:tc>
+                  <a:txBody>
+                    <a:bodyPr wrap="square"/>
+                    <a:lstStyle/>
+                    <a:p>
+                      <a:r>
+                        <a:rPr sz="1600" b="0">
+                          <a:solidFill>
+                            <a:srgbClr val="222B36"/>
+                          </a:solidFill>
+                          <a:latin typeface="Segoe UI"/>
+                        </a:rPr>
+                        <a:t>Aspect values: lower case here, upper case system-wide</a:t>
+                      </a:r>
+                    </a:p>
+                  </a:txBody>
+                  <a:tcPr marL="73152" marR="73152" marT="36576" marB="36576">
+                    <a:solidFill>
+                      <a:srgbClr val="FFFFFF"/>
+                    </a:solidFill>
+                  </a:tcPr>
+                </a:tc>
+                <a:tc>
+                  <a:txBody>
+                    <a:bodyPr wrap="square"/>
+                    <a:lstStyle/>
+                    <a:p>
+                      <a:r>
+                        <a:rPr sz="1600" b="0">
+                          <a:solidFill>
+                            <a:srgbClr val="222B36"/>
+                          </a:solidFill>
+                          <a:latin typeface="Segoe UI"/>
+                        </a:rPr>
+                        <a:t>Braden</a:t>
+                      </a:r>
+                    </a:p>
+                  </a:txBody>
+                  <a:tcPr marL="73152" marR="73152" marT="36576" marB="36576">
+                    <a:solidFill>
+                      <a:srgbClr val="FFFFFF"/>
+                    </a:solidFill>
+                  </a:tcPr>
+                </a:tc>
+              </a:tr>
+            </a:tbl>
+          </a:graphicData>
+        </a:graphic>
+      </p:graphicFrame>
+    </p:spTree>
+  </p:cSld>
+  <p:clrMapOvr>
+    <a:masterClrMapping/>
+  </p:clrMapOvr>
+</p:sld>
+</file>
+
 <file path=ppt/slides/slide5.xml><?xml version="1.0" encoding="utf-8"?>
 <p:sld xmlns:a="http://schemas.openxmlformats.org/drawingml/2006/main" xmlns:p="http://schemas.openxmlformats.org/presentationml/2006/main" xmlns:r="http://schemas.openxmlformats.org/officeDocument/2006/relationships">
   <p:cSld>

</xml_diff>